<commit_message>
Move SETAPAK 4 gate after stage 3: pipeline entry is the programme's main output
Co-Authored-By: Claude Opus 5.5 <noreply@anthropic.com>
Claude-Session: https://claude.ai/code/session_01Tt9bQwcKRKX4vaP5NybJqL
</commit_message>
<xml_diff>
--- a/hutan-desa-pasir/Roadmap_1Slide_HD_Pasir.pptx
+++ b/hutan-desa-pasir/Roadmap_1Slide_HD_Pasir.pptx
@@ -502,7 +502,7 @@
           <a:lstStyle/>
           <a:p>
             <a:r>
-              <a:t>Alur: Tahap 1–2 adalah cakupan SETAPAK 4 yang didanai TAF sampai September 2027. Targetnya PIN disetujui dan proyek masuk pipeline Plan Vivo. Pipeline belum berarti registrasi atau kredit. Tahap 3 adalah gerbang: dengan status pipeline, proyek mencari investor atau pembeli untuk pre-financing/offtake berjangka yang membiayai PDD dan validasi. Kredit baru muncul setelah registrasi (fPVC untuk restorasi, rPVC dari Annual Report) dan yang dapat di-retire hanya vPVC setelah verifikasi. Minimal 60% pendapatan dari penjualan untuk peserta dan pihak lokal.</a:t>
+              <a:t>Alur: Tahap 1–3 adalah cakupan program SETAPAK 4 yang didanai TAF sampai September 2027. Output utamanya Tahap 3: PIN disetujui dan proyek masuk pipeline Plan Vivo. Pipeline belum berarti registrasi atau kredit. Garis gerbang setelah Tahap 3 menandai akhir SETAPAK 4. Dengan status pipeline, proyek mencari investor atau pembeli untuk pre-financing/offtake berjangka yang membiayai PDD dan validasi (Tahap 4 dst.). Kredit baru muncul setelah registrasi (fPVC untuk restorasi, rPVC dari Annual Report) dan yang dapat di-retire hanya vPVC setelah verifikasi. Minimal 60% pendapatan dari penjualan untuk peserta dan pihak lokal.</a:t>
             </a:r>
           </a:p>
         </p:txBody>
@@ -3603,7 +3603,7 @@
                 </a:solidFill>
                 <a:latin typeface="Cambria"/>
               </a:rPr>
-              <a:t>Delapan tahap menuju kredit karbon komunitas — SETAPAK 4 menuntaskan</a:t>
+              <a:t>SETAPAK 4 berakhir dengan proyek masuk Pipeline Plan Vivo — status ini</a:t>
             </a:r>
           </a:p>
           <a:p>
@@ -3615,7 +3615,7 @@
                 </a:solidFill>
                 <a:latin typeface="Cambria"/>
               </a:rPr>
-              <a:t>persiapan dan persetujuan PIN; investasi membuka jalan ke PDD hingga penjualan</a:t>
+              <a:t>membuka investasi untuk PDD, validasi, hingga penjualan kredit karbon</a:t>
             </a:r>
           </a:p>
         </p:txBody>
@@ -3629,7 +3629,7 @@
         <p:spPr>
           <a:xfrm>
             <a:off x="1261872" y="1481328"/>
-            <a:ext cx="2585465" cy="292608"/>
+            <a:ext cx="3910203" cy="292608"/>
           </a:xfrm>
           <a:prstGeom prst="rect">
             <a:avLst/>
@@ -3654,7 +3654,7 @@
                 </a:solidFill>
                 <a:latin typeface="Calibri"/>
               </a:rPr>
-              <a:t>STEP 1 · SETAPAK 4 (TAF) · Okt 2026 – Sep 2027</a:t>
+              <a:t>STEP 1 · PROGRAM SETAPAK 4 (TAF) · Okt 2026 – Sep 2027</a:t>
             </a:r>
           </a:p>
         </p:txBody>
@@ -3662,45 +3662,6 @@
       <p:sp>
         <p:nvSpPr>
           <p:cNvPr id="6" name="Rectangle 5"/>
-          <p:cNvSpPr/>
-          <p:nvPr/>
-        </p:nvSpPr>
-        <p:spPr>
-          <a:xfrm>
-            <a:off x="3911346" y="1481328"/>
-            <a:ext cx="1260729" cy="292608"/>
-          </a:xfrm>
-          <a:prstGeom prst="rect">
-            <a:avLst/>
-          </a:prstGeom>
-          <a:solidFill>
-            <a:srgbClr val="C26A0A"/>
-          </a:solidFill>
-          <a:ln>
-            <a:noFill/>
-          </a:ln>
-          <a:effectLst/>
-        </p:spPr>
-        <p:txBody>
-          <a:bodyPr rtlCol="0" anchor="ctr" lIns="0" rIns="0" tIns="0" bIns="0"/>
-          <a:lstStyle/>
-          <a:p>
-            <a:pPr algn="ctr"/>
-            <a:r>
-              <a:rPr sz="850" b="1">
-                <a:solidFill>
-                  <a:srgbClr val="FFFFFF"/>
-                </a:solidFill>
-                <a:latin typeface="Calibri"/>
-              </a:rPr>
-              <a:t>GERBANG · PIPELINE</a:t>
-            </a:r>
-          </a:p>
-        </p:txBody>
-      </p:sp>
-      <p:sp>
-        <p:nvSpPr>
-          <p:cNvPr id="7" name="Rectangle 6"/>
           <p:cNvSpPr/>
           <p:nvPr/>
         </p:nvSpPr>
@@ -3732,21 +3693,21 @@
                 </a:solidFill>
                 <a:latin typeface="Calibri"/>
               </a:rPr>
-              <a:t>STEP 2 · PENGEMBANGAN LANJUTAN · 2027 →</a:t>
+              <a:t>STEP 2 · PENGEMBANGAN LANJUTAN (PASCA-SETAPAK 4) · Okt 2027 →</a:t>
             </a:r>
           </a:p>
         </p:txBody>
       </p:sp>
       <p:cxnSp>
         <p:nvCxnSpPr>
-          <p:cNvPr id="8" name="Connector 7"/>
+          <p:cNvPr id="7" name="Connector 6"/>
           <p:cNvCxnSpPr/>
           <p:nvPr/>
         </p:nvCxnSpPr>
         <p:spPr>
           <a:xfrm>
             <a:off x="1892236" y="2103120"/>
-            <a:ext cx="2649474" cy="0"/>
+            <a:ext cx="3311842" cy="0"/>
           </a:xfrm>
           <a:prstGeom prst="line">
             <a:avLst/>
@@ -3774,14 +3735,14 @@
       </p:cxnSp>
       <p:cxnSp>
         <p:nvCxnSpPr>
-          <p:cNvPr id="9" name="Connector 8"/>
+          <p:cNvPr id="8" name="Connector 7"/>
           <p:cNvCxnSpPr/>
           <p:nvPr/>
         </p:nvCxnSpPr>
         <p:spPr>
           <a:xfrm>
-            <a:off x="4541710" y="2103120"/>
-            <a:ext cx="6623685" cy="0"/>
+            <a:off x="5204078" y="2103120"/>
+            <a:ext cx="5961317" cy="0"/>
           </a:xfrm>
           <a:prstGeom prst="line">
             <a:avLst/>
@@ -3809,7 +3770,7 @@
       </p:cxnSp>
       <p:sp>
         <p:nvSpPr>
-          <p:cNvPr id="10" name="TextBox 9"/>
+          <p:cNvPr id="9" name="TextBox 8"/>
           <p:cNvSpPr txBox="1"/>
           <p:nvPr/>
         </p:nvSpPr>
@@ -3844,14 +3805,14 @@
       </p:sp>
       <p:cxnSp>
         <p:nvCxnSpPr>
-          <p:cNvPr id="11" name="Connector 10"/>
+          <p:cNvPr id="10" name="Connector 9"/>
           <p:cNvCxnSpPr/>
           <p:nvPr/>
         </p:nvCxnSpPr>
         <p:spPr>
           <a:xfrm>
-            <a:off x="3879341" y="1435608"/>
-            <a:ext cx="0" cy="4050792"/>
+            <a:off x="5204078" y="1426464"/>
+            <a:ext cx="0" cy="4059936"/>
           </a:xfrm>
           <a:prstGeom prst="line">
             <a:avLst/>
@@ -3880,6 +3841,41 @@
       </p:cxnSp>
       <p:sp>
         <p:nvSpPr>
+          <p:cNvPr id="11" name="TextBox 10"/>
+          <p:cNvSpPr txBox="1"/>
+          <p:nvPr/>
+        </p:nvSpPr>
+        <p:spPr>
+          <a:xfrm>
+            <a:off x="3741038" y="1234440"/>
+            <a:ext cx="2926080" cy="201168"/>
+          </a:xfrm>
+          <a:prstGeom prst="rect">
+            <a:avLst/>
+          </a:prstGeom>
+          <a:noFill/>
+        </p:spPr>
+        <p:txBody>
+          <a:bodyPr wrap="square" lIns="18288" rIns="18288" tIns="9144" bIns="9144" anchor="t">
+            <a:spAutoFit/>
+          </a:bodyPr>
+          <a:lstStyle/>
+          <a:p>
+            <a:pPr algn="ctr"/>
+            <a:r>
+              <a:rPr sz="750" b="1" i="0">
+                <a:solidFill>
+                  <a:srgbClr val="C26A0A"/>
+                </a:solidFill>
+                <a:latin typeface="Calibri"/>
+              </a:rPr>
+              <a:t>▼ GERBANG PIPELINE · AKHIR SETAPAK 4</a:t>
+            </a:r>
+          </a:p>
+        </p:txBody>
+      </p:sp>
+      <p:sp>
+        <p:nvSpPr>
           <p:cNvPr id="12" name="Oval 11"/>
           <p:cNvSpPr/>
           <p:nvPr/>
@@ -4504,14 +4500,46 @@
         </p:nvSpPr>
         <p:spPr>
           <a:xfrm>
-            <a:off x="4322254" y="1883663"/>
-            <a:ext cx="438912" cy="438912"/>
+            <a:off x="4230814" y="1792223"/>
+            <a:ext cx="621792" cy="621792"/>
           </a:xfrm>
           <a:prstGeom prst="ellipse">
             <a:avLst/>
           </a:prstGeom>
           <a:solidFill>
-            <a:srgbClr val="C26A0A"/>
+            <a:srgbClr val="FFFFFF"/>
+          </a:solidFill>
+          <a:ln w="25400">
+            <a:solidFill>
+              <a:srgbClr val="0E7C6B"/>
+            </a:solidFill>
+          </a:ln>
+          <a:effectLst/>
+        </p:spPr>
+        <p:txBody>
+          <a:bodyPr rtlCol="0" anchor="ctr"/>
+          <a:lstStyle/>
+          <a:p>
+            <a:pPr algn="ctr"/>
+          </a:p>
+        </p:txBody>
+      </p:sp>
+      <p:sp>
+        <p:nvSpPr>
+          <p:cNvPr id="27" name="Oval 26"/>
+          <p:cNvSpPr/>
+          <p:nvPr/>
+        </p:nvSpPr>
+        <p:spPr>
+          <a:xfrm>
+            <a:off x="4303966" y="1865376"/>
+            <a:ext cx="475488" cy="475488"/>
+          </a:xfrm>
+          <a:prstGeom prst="ellipse">
+            <a:avLst/>
+          </a:prstGeom>
+          <a:solidFill>
+            <a:srgbClr val="0E7C6B"/>
           </a:solidFill>
           <a:ln>
             <a:noFill/>
@@ -4524,26 +4552,385 @@
           <a:p>
             <a:pPr algn="ctr"/>
             <a:r>
+              <a:rPr sz="1400" b="1">
+                <a:solidFill>
+                  <a:srgbClr val="FFFFFF"/>
+                </a:solidFill>
+                <a:latin typeface="Calibri"/>
+              </a:rPr>
+              <a:t>3</a:t>
+            </a:r>
+          </a:p>
+        </p:txBody>
+      </p:sp>
+      <p:sp>
+        <p:nvSpPr>
+          <p:cNvPr id="28" name="Rectangle 27"/>
+          <p:cNvSpPr/>
+          <p:nvPr/>
+        </p:nvSpPr>
+        <p:spPr>
+          <a:xfrm>
+            <a:off x="3911346" y="2450592"/>
+            <a:ext cx="1260729" cy="2194560"/>
+          </a:xfrm>
+          <a:prstGeom prst="rect">
+            <a:avLst/>
+          </a:prstGeom>
+          <a:solidFill>
+            <a:srgbClr val="E3F1EE"/>
+          </a:solidFill>
+          <a:ln w="22225">
+            <a:solidFill>
+              <a:srgbClr val="0E7C6B"/>
+            </a:solidFill>
+          </a:ln>
+          <a:effectLst/>
+        </p:spPr>
+        <p:txBody>
+          <a:bodyPr rtlCol="0" anchor="ctr"/>
+          <a:lstStyle/>
+          <a:p>
+            <a:pPr algn="ctr"/>
+          </a:p>
+        </p:txBody>
+      </p:sp>
+      <p:sp>
+        <p:nvSpPr>
+          <p:cNvPr id="29" name="Rectangle 28"/>
+          <p:cNvSpPr/>
+          <p:nvPr/>
+        </p:nvSpPr>
+        <p:spPr>
+          <a:xfrm>
+            <a:off x="3911346" y="2450592"/>
+            <a:ext cx="1260729" cy="45720"/>
+          </a:xfrm>
+          <a:prstGeom prst="rect">
+            <a:avLst/>
+          </a:prstGeom>
+          <a:solidFill>
+            <a:srgbClr val="0E7C6B"/>
+          </a:solidFill>
+          <a:ln>
+            <a:noFill/>
+          </a:ln>
+          <a:effectLst/>
+        </p:spPr>
+        <p:txBody>
+          <a:bodyPr rtlCol="0" anchor="ctr"/>
+          <a:lstStyle/>
+          <a:p>
+            <a:pPr algn="ctr"/>
+          </a:p>
+        </p:txBody>
+      </p:sp>
+      <p:sp>
+        <p:nvSpPr>
+          <p:cNvPr id="30" name="Rounded Rectangle 29"/>
+          <p:cNvSpPr/>
+          <p:nvPr/>
+        </p:nvSpPr>
+        <p:spPr>
+          <a:xfrm>
+            <a:off x="4021074" y="2331720"/>
+            <a:ext cx="1041272" cy="219456"/>
+          </a:xfrm>
+          <a:prstGeom prst="roundRect">
+            <a:avLst/>
+          </a:prstGeom>
+          <a:solidFill>
+            <a:srgbClr val="0E7C6B"/>
+          </a:solidFill>
+          <a:ln>
+            <a:noFill/>
+          </a:ln>
+          <a:effectLst/>
+        </p:spPr>
+        <p:txBody>
+          <a:bodyPr rtlCol="0" anchor="ctr" lIns="0" rIns="0" tIns="0" bIns="0"/>
+          <a:lstStyle/>
+          <a:p>
+            <a:pPr algn="ctr"/>
+            <a:r>
+              <a:rPr sz="750" b="1">
+                <a:solidFill>
+                  <a:srgbClr val="FFFFFF"/>
+                </a:solidFill>
+                <a:latin typeface="Calibri"/>
+              </a:rPr>
+              <a:t>★ OUTPUT UTAMA</a:t>
+            </a:r>
+          </a:p>
+        </p:txBody>
+      </p:sp>
+      <p:sp>
+        <p:nvSpPr>
+          <p:cNvPr id="31" name="TextBox 30"/>
+          <p:cNvSpPr txBox="1"/>
+          <p:nvPr/>
+        </p:nvSpPr>
+        <p:spPr>
+          <a:xfrm>
+            <a:off x="3984498" y="2542032"/>
+            <a:ext cx="1114425" cy="411480"/>
+          </a:xfrm>
+          <a:prstGeom prst="rect">
+            <a:avLst/>
+          </a:prstGeom>
+          <a:noFill/>
+        </p:spPr>
+        <p:txBody>
+          <a:bodyPr wrap="square" lIns="18288" rIns="18288" tIns="9144" bIns="9144" anchor="t">
+            <a:spAutoFit/>
+          </a:bodyPr>
+          <a:lstStyle/>
+          <a:p>
+            <a:pPr algn="l"/>
+            <a:r>
+              <a:rPr sz="1000" b="1" i="0">
+                <a:solidFill>
+                  <a:srgbClr val="1B2420"/>
+                </a:solidFill>
+                <a:latin typeface="Calibri"/>
+              </a:rPr>
+              <a:t>Masuk</a:t>
+            </a:r>
+          </a:p>
+          <a:p>
+            <a:pPr algn="l"/>
+            <a:r>
+              <a:rPr sz="1000" b="1" i="0">
+                <a:solidFill>
+                  <a:srgbClr val="1B2420"/>
+                </a:solidFill>
+                <a:latin typeface="Calibri"/>
+              </a:rPr>
+              <a:t>Pipeline PV</a:t>
+            </a:r>
+          </a:p>
+        </p:txBody>
+      </p:sp>
+      <p:sp>
+        <p:nvSpPr>
+          <p:cNvPr id="32" name="TextBox 31"/>
+          <p:cNvSpPr txBox="1"/>
+          <p:nvPr/>
+        </p:nvSpPr>
+        <p:spPr>
+          <a:xfrm>
+            <a:off x="3984498" y="2962656"/>
+            <a:ext cx="1114425" cy="182880"/>
+          </a:xfrm>
+          <a:prstGeom prst="rect">
+            <a:avLst/>
+          </a:prstGeom>
+          <a:noFill/>
+        </p:spPr>
+        <p:txBody>
+          <a:bodyPr wrap="square" lIns="18288" rIns="18288" tIns="9144" bIns="9144" anchor="t">
+            <a:spAutoFit/>
+          </a:bodyPr>
+          <a:lstStyle/>
+          <a:p>
+            <a:pPr algn="l"/>
+            <a:r>
+              <a:rPr sz="700" b="1" i="0">
+                <a:solidFill>
+                  <a:srgbClr val="0E7C6B"/>
+                </a:solidFill>
+                <a:latin typeface="Calibri"/>
+              </a:rPr>
+              <a:t>Sep 2027 · M7.5 · M8</a:t>
+            </a:r>
+          </a:p>
+        </p:txBody>
+      </p:sp>
+      <p:sp>
+        <p:nvSpPr>
+          <p:cNvPr id="33" name="TextBox 32"/>
+          <p:cNvSpPr txBox="1"/>
+          <p:nvPr/>
+        </p:nvSpPr>
+        <p:spPr>
+          <a:xfrm>
+            <a:off x="3947922" y="3182112"/>
+            <a:ext cx="1169288" cy="1005840"/>
+          </a:xfrm>
+          <a:prstGeom prst="rect">
+            <a:avLst/>
+          </a:prstGeom>
+          <a:noFill/>
+        </p:spPr>
+        <p:txBody>
+          <a:bodyPr wrap="square" lIns="36576" rIns="36576" tIns="18288" bIns="18288" anchor="t">
+            <a:spAutoFit/>
+          </a:bodyPr>
+          <a:lstStyle/>
+          <a:p>
+            <a:pPr algn="l">
+              <a:spcAft>
+                <a:spcPts val="200"/>
+              </a:spcAft>
+            </a:pPr>
+            <a:r>
+              <a:rPr sz="800" b="1">
+                <a:solidFill>
+                  <a:srgbClr val="0E7C6B"/>
+                </a:solidFill>
+                <a:latin typeface="Calibri"/>
+              </a:rPr>
+              <a:t>▪ </a:t>
+            </a:r>
+            <a:r>
+              <a:rPr sz="800" b="0">
+                <a:solidFill>
+                  <a:srgbClr val="1B2420"/>
+                </a:solidFill>
+                <a:latin typeface="Calibri"/>
+              </a:rPr>
+              <a:t>PIN dipublikasikan di pipeline Plan Vivo</a:t>
+            </a:r>
+          </a:p>
+          <a:p>
+            <a:pPr algn="l">
+              <a:spcAft>
+                <a:spcPts val="200"/>
+              </a:spcAft>
+            </a:pPr>
+            <a:r>
+              <a:rPr sz="800" b="1">
+                <a:solidFill>
+                  <a:srgbClr val="0E7C6B"/>
+                </a:solidFill>
+                <a:latin typeface="Calibri"/>
+              </a:rPr>
+              <a:t>▪ </a:t>
+            </a:r>
+            <a:r>
+              <a:rPr sz="800" b="0">
+                <a:solidFill>
+                  <a:srgbClr val="1B2420"/>
+                </a:solidFill>
+                <a:latin typeface="Calibri"/>
+              </a:rPr>
+              <a:t>Profil proyek &amp; penjajakan investor</a:t>
+            </a:r>
+          </a:p>
+          <a:p>
+            <a:pPr algn="l">
+              <a:spcAft>
+                <a:spcPts val="200"/>
+              </a:spcAft>
+            </a:pPr>
+            <a:r>
+              <a:rPr sz="800" b="1">
+                <a:solidFill>
+                  <a:srgbClr val="0E7C6B"/>
+                </a:solidFill>
+                <a:latin typeface="Calibri"/>
+              </a:rPr>
+              <a:t>▪ </a:t>
+            </a:r>
+            <a:r>
+              <a:rPr sz="800" b="0">
+                <a:solidFill>
+                  <a:srgbClr val="1B2420"/>
+                </a:solidFill>
+                <a:latin typeface="Calibri"/>
+              </a:rPr>
+              <a:t>Pendamping teregistrasi (Permenhut 6/2026)</a:t>
+            </a:r>
+          </a:p>
+        </p:txBody>
+      </p:sp>
+      <p:sp>
+        <p:nvSpPr>
+          <p:cNvPr id="34" name="Rounded Rectangle 33"/>
+          <p:cNvSpPr/>
+          <p:nvPr/>
+        </p:nvSpPr>
+        <p:spPr>
+          <a:xfrm>
+            <a:off x="3984498" y="4261104"/>
+            <a:ext cx="1114425" cy="292608"/>
+          </a:xfrm>
+          <a:prstGeom prst="roundRect">
+            <a:avLst/>
+          </a:prstGeom>
+          <a:solidFill>
+            <a:srgbClr val="0E7C6B"/>
+          </a:solidFill>
+          <a:ln>
+            <a:noFill/>
+          </a:ln>
+          <a:effectLst/>
+        </p:spPr>
+        <p:txBody>
+          <a:bodyPr rtlCol="0" anchor="ctr" lIns="0" rIns="0" tIns="0" bIns="0"/>
+          <a:lstStyle/>
+          <a:p>
+            <a:pPr algn="ctr"/>
+            <a:r>
+              <a:rPr sz="750" b="1">
+                <a:solidFill>
+                  <a:srgbClr val="FFFFFF"/>
+                </a:solidFill>
+                <a:latin typeface="Calibri"/>
+              </a:rPr>
+              <a:t>→ Proyek di Pipeline PV</a:t>
+            </a:r>
+          </a:p>
+        </p:txBody>
+      </p:sp>
+      <p:sp>
+        <p:nvSpPr>
+          <p:cNvPr id="35" name="Oval 34"/>
+          <p:cNvSpPr/>
+          <p:nvPr/>
+        </p:nvSpPr>
+        <p:spPr>
+          <a:xfrm>
+            <a:off x="5646991" y="1883663"/>
+            <a:ext cx="438912" cy="438912"/>
+          </a:xfrm>
+          <a:prstGeom prst="ellipse">
+            <a:avLst/>
+          </a:prstGeom>
+          <a:solidFill>
+            <a:srgbClr val="1F2A44"/>
+          </a:solidFill>
+          <a:ln>
+            <a:noFill/>
+          </a:ln>
+          <a:effectLst/>
+        </p:spPr>
+        <p:txBody>
+          <a:bodyPr rtlCol="0" anchor="ctr" lIns="0" rIns="0" tIns="0" bIns="0"/>
+          <a:lstStyle/>
+          <a:p>
+            <a:pPr algn="ctr"/>
+            <a:r>
               <a:rPr sz="1300" b="1">
                 <a:solidFill>
                   <a:srgbClr val="FFFFFF"/>
                 </a:solidFill>
                 <a:latin typeface="Calibri"/>
               </a:rPr>
-              <a:t>3</a:t>
-            </a:r>
-          </a:p>
-        </p:txBody>
-      </p:sp>
-      <p:sp>
-        <p:nvSpPr>
-          <p:cNvPr id="27" name="Rectangle 26"/>
+              <a:t>4</a:t>
+            </a:r>
+          </a:p>
+        </p:txBody>
+      </p:sp>
+      <p:sp>
+        <p:nvSpPr>
+          <p:cNvPr id="36" name="Rectangle 35"/>
           <p:cNvSpPr/>
           <p:nvPr/>
         </p:nvSpPr>
         <p:spPr>
           <a:xfrm>
-            <a:off x="3911346" y="2450592"/>
+            <a:off x="5236082" y="2450592"/>
             <a:ext cx="1260729" cy="2194560"/>
           </a:xfrm>
           <a:prstGeom prst="rect">
@@ -4569,265 +4956,16 @@
       </p:sp>
       <p:sp>
         <p:nvSpPr>
-          <p:cNvPr id="28" name="Rectangle 27"/>
+          <p:cNvPr id="37" name="Rectangle 36"/>
           <p:cNvSpPr/>
           <p:nvPr/>
         </p:nvSpPr>
         <p:spPr>
           <a:xfrm>
-            <a:off x="3911346" y="2450592"/>
+            <a:off x="5236082" y="2450592"/>
             <a:ext cx="1260729" cy="45720"/>
           </a:xfrm>
           <a:prstGeom prst="rect">
-            <a:avLst/>
-          </a:prstGeom>
-          <a:solidFill>
-            <a:srgbClr val="C26A0A"/>
-          </a:solidFill>
-          <a:ln>
-            <a:noFill/>
-          </a:ln>
-          <a:effectLst/>
-        </p:spPr>
-        <p:txBody>
-          <a:bodyPr rtlCol="0" anchor="ctr"/>
-          <a:lstStyle/>
-          <a:p>
-            <a:pPr algn="ctr"/>
-          </a:p>
-        </p:txBody>
-      </p:sp>
-      <p:sp>
-        <p:nvSpPr>
-          <p:cNvPr id="29" name="TextBox 28"/>
-          <p:cNvSpPr txBox="1"/>
-          <p:nvPr/>
-        </p:nvSpPr>
-        <p:spPr>
-          <a:xfrm>
-            <a:off x="3984498" y="2542032"/>
-            <a:ext cx="1114425" cy="411480"/>
-          </a:xfrm>
-          <a:prstGeom prst="rect">
-            <a:avLst/>
-          </a:prstGeom>
-          <a:noFill/>
-        </p:spPr>
-        <p:txBody>
-          <a:bodyPr wrap="square" lIns="18288" rIns="18288" tIns="9144" bIns="9144" anchor="t">
-            <a:spAutoFit/>
-          </a:bodyPr>
-          <a:lstStyle/>
-          <a:p>
-            <a:pPr algn="l"/>
-            <a:r>
-              <a:rPr sz="1000" b="1" i="0">
-                <a:solidFill>
-                  <a:srgbClr val="1B2420"/>
-                </a:solidFill>
-                <a:latin typeface="Calibri"/>
-              </a:rPr>
-              <a:t>Pipeline PV &amp;</a:t>
-            </a:r>
-          </a:p>
-          <a:p>
-            <a:pPr algn="l"/>
-            <a:r>
-              <a:rPr sz="1000" b="1" i="0">
-                <a:solidFill>
-                  <a:srgbClr val="1B2420"/>
-                </a:solidFill>
-                <a:latin typeface="Calibri"/>
-              </a:rPr>
-              <a:t>Investasi</a:t>
-            </a:r>
-          </a:p>
-        </p:txBody>
-      </p:sp>
-      <p:sp>
-        <p:nvSpPr>
-          <p:cNvPr id="30" name="TextBox 29"/>
-          <p:cNvSpPr txBox="1"/>
-          <p:nvPr/>
-        </p:nvSpPr>
-        <p:spPr>
-          <a:xfrm>
-            <a:off x="3984498" y="2962656"/>
-            <a:ext cx="1114425" cy="182880"/>
-          </a:xfrm>
-          <a:prstGeom prst="rect">
-            <a:avLst/>
-          </a:prstGeom>
-          <a:noFill/>
-        </p:spPr>
-        <p:txBody>
-          <a:bodyPr wrap="square" lIns="18288" rIns="18288" tIns="9144" bIns="9144" anchor="t">
-            <a:spAutoFit/>
-          </a:bodyPr>
-          <a:lstStyle/>
-          <a:p>
-            <a:pPr algn="l"/>
-            <a:r>
-              <a:rPr sz="700" b="1" i="0">
-                <a:solidFill>
-                  <a:srgbClr val="C26A0A"/>
-                </a:solidFill>
-                <a:latin typeface="Calibri"/>
-              </a:rPr>
-              <a:t>Sep 27 – 2028 · M8</a:t>
-            </a:r>
-          </a:p>
-        </p:txBody>
-      </p:sp>
-      <p:sp>
-        <p:nvSpPr>
-          <p:cNvPr id="31" name="TextBox 30"/>
-          <p:cNvSpPr txBox="1"/>
-          <p:nvPr/>
-        </p:nvSpPr>
-        <p:spPr>
-          <a:xfrm>
-            <a:off x="3947922" y="3182112"/>
-            <a:ext cx="1169288" cy="1005840"/>
-          </a:xfrm>
-          <a:prstGeom prst="rect">
-            <a:avLst/>
-          </a:prstGeom>
-          <a:noFill/>
-        </p:spPr>
-        <p:txBody>
-          <a:bodyPr wrap="square" lIns="36576" rIns="36576" tIns="18288" bIns="18288" anchor="t">
-            <a:spAutoFit/>
-          </a:bodyPr>
-          <a:lstStyle/>
-          <a:p>
-            <a:pPr algn="l">
-              <a:spcAft>
-                <a:spcPts val="200"/>
-              </a:spcAft>
-            </a:pPr>
-            <a:r>
-              <a:rPr sz="800" b="1">
-                <a:solidFill>
-                  <a:srgbClr val="C26A0A"/>
-                </a:solidFill>
-                <a:latin typeface="Calibri"/>
-              </a:rPr>
-              <a:t>▪ </a:t>
-            </a:r>
-            <a:r>
-              <a:rPr sz="800" b="0">
-                <a:solidFill>
-                  <a:srgbClr val="1B2420"/>
-                </a:solidFill>
-                <a:latin typeface="Calibri"/>
-              </a:rPr>
-              <a:t>Listing di pipeline Plan Vivo</a:t>
-            </a:r>
-          </a:p>
-          <a:p>
-            <a:pPr algn="l">
-              <a:spcAft>
-                <a:spcPts val="200"/>
-              </a:spcAft>
-            </a:pPr>
-            <a:r>
-              <a:rPr sz="800" b="1">
-                <a:solidFill>
-                  <a:srgbClr val="C26A0A"/>
-                </a:solidFill>
-                <a:latin typeface="Calibri"/>
-              </a:rPr>
-              <a:t>▪ </a:t>
-            </a:r>
-            <a:r>
-              <a:rPr sz="800" b="0">
-                <a:solidFill>
-                  <a:srgbClr val="1B2420"/>
-                </a:solidFill>
-                <a:latin typeface="Calibri"/>
-              </a:rPr>
-              <a:t>Pre-financing / offtake berjangka</a:t>
-            </a:r>
-          </a:p>
-          <a:p>
-            <a:pPr algn="l">
-              <a:spcAft>
-                <a:spcPts val="200"/>
-              </a:spcAft>
-            </a:pPr>
-            <a:r>
-              <a:rPr sz="800" b="1">
-                <a:solidFill>
-                  <a:srgbClr val="C26A0A"/>
-                </a:solidFill>
-                <a:latin typeface="Calibri"/>
-              </a:rPr>
-              <a:t>▪ </a:t>
-            </a:r>
-            <a:r>
-              <a:rPr sz="800" b="0">
-                <a:solidFill>
-                  <a:srgbClr val="1B2420"/>
-                </a:solidFill>
-                <a:latin typeface="Calibri"/>
-              </a:rPr>
-              <a:t>Pendamping teregistrasi, DPP</a:t>
-            </a:r>
-          </a:p>
-        </p:txBody>
-      </p:sp>
-      <p:sp>
-        <p:nvSpPr>
-          <p:cNvPr id="32" name="Rounded Rectangle 31"/>
-          <p:cNvSpPr/>
-          <p:nvPr/>
-        </p:nvSpPr>
-        <p:spPr>
-          <a:xfrm>
-            <a:off x="3984498" y="4261104"/>
-            <a:ext cx="1114425" cy="292608"/>
-          </a:xfrm>
-          <a:prstGeom prst="roundRect">
-            <a:avLst/>
-          </a:prstGeom>
-          <a:solidFill>
-            <a:srgbClr val="FBF1E4"/>
-          </a:solidFill>
-          <a:ln>
-            <a:noFill/>
-          </a:ln>
-          <a:effectLst/>
-        </p:spPr>
-        <p:txBody>
-          <a:bodyPr rtlCol="0" anchor="ctr" lIns="0" rIns="0" tIns="0" bIns="0"/>
-          <a:lstStyle/>
-          <a:p>
-            <a:pPr algn="ctr"/>
-            <a:r>
-              <a:rPr sz="750" b="1">
-                <a:solidFill>
-                  <a:srgbClr val="C26A0A"/>
-                </a:solidFill>
-                <a:latin typeface="Calibri"/>
-              </a:rPr>
-              <a:t>→ LoI / term sheet investor</a:t>
-            </a:r>
-          </a:p>
-        </p:txBody>
-      </p:sp>
-      <p:sp>
-        <p:nvSpPr>
-          <p:cNvPr id="33" name="Oval 32"/>
-          <p:cNvSpPr/>
-          <p:nvPr/>
-        </p:nvSpPr>
-        <p:spPr>
-          <a:xfrm>
-            <a:off x="5646991" y="1883663"/>
-            <a:ext cx="438912" cy="438912"/>
-          </a:xfrm>
-          <a:prstGeom prst="ellipse">
             <a:avLst/>
           </a:prstGeom>
           <a:solidFill>
@@ -4839,31 +4977,270 @@
           <a:effectLst/>
         </p:spPr>
         <p:txBody>
+          <a:bodyPr rtlCol="0" anchor="ctr"/>
+          <a:lstStyle/>
+          <a:p>
+            <a:pPr algn="ctr"/>
+          </a:p>
+        </p:txBody>
+      </p:sp>
+      <p:sp>
+        <p:nvSpPr>
+          <p:cNvPr id="38" name="TextBox 37"/>
+          <p:cNvSpPr txBox="1"/>
+          <p:nvPr/>
+        </p:nvSpPr>
+        <p:spPr>
+          <a:xfrm>
+            <a:off x="5309234" y="2542032"/>
+            <a:ext cx="1114425" cy="411480"/>
+          </a:xfrm>
+          <a:prstGeom prst="rect">
+            <a:avLst/>
+          </a:prstGeom>
+          <a:noFill/>
+        </p:spPr>
+        <p:txBody>
+          <a:bodyPr wrap="square" lIns="18288" rIns="18288" tIns="9144" bIns="9144" anchor="t">
+            <a:spAutoFit/>
+          </a:bodyPr>
+          <a:lstStyle/>
+          <a:p>
+            <a:pPr algn="l"/>
+            <a:r>
+              <a:rPr sz="1000" b="1" i="0">
+                <a:solidFill>
+                  <a:srgbClr val="1B2420"/>
+                </a:solidFill>
+                <a:latin typeface="Calibri"/>
+              </a:rPr>
+              <a:t>Penyusunan PDD</a:t>
+            </a:r>
+          </a:p>
+        </p:txBody>
+      </p:sp>
+      <p:sp>
+        <p:nvSpPr>
+          <p:cNvPr id="39" name="TextBox 38"/>
+          <p:cNvSpPr txBox="1"/>
+          <p:nvPr/>
+        </p:nvSpPr>
+        <p:spPr>
+          <a:xfrm>
+            <a:off x="5309234" y="2962656"/>
+            <a:ext cx="1114425" cy="182880"/>
+          </a:xfrm>
+          <a:prstGeom prst="rect">
+            <a:avLst/>
+          </a:prstGeom>
+          <a:noFill/>
+        </p:spPr>
+        <p:txBody>
+          <a:bodyPr wrap="square" lIns="18288" rIns="18288" tIns="9144" bIns="9144" anchor="t">
+            <a:spAutoFit/>
+          </a:bodyPr>
+          <a:lstStyle/>
+          <a:p>
+            <a:pPr algn="l"/>
+            <a:r>
+              <a:rPr sz="700" b="1" i="0">
+                <a:solidFill>
+                  <a:srgbClr val="1F2A44"/>
+                </a:solidFill>
+                <a:latin typeface="Calibri"/>
+              </a:rPr>
+              <a:t>2027 – 2029 · M9</a:t>
+            </a:r>
+          </a:p>
+        </p:txBody>
+      </p:sp>
+      <p:sp>
+        <p:nvSpPr>
+          <p:cNvPr id="40" name="TextBox 39"/>
+          <p:cNvSpPr txBox="1"/>
+          <p:nvPr/>
+        </p:nvSpPr>
+        <p:spPr>
+          <a:xfrm>
+            <a:off x="5272658" y="3182112"/>
+            <a:ext cx="1169288" cy="1005840"/>
+          </a:xfrm>
+          <a:prstGeom prst="rect">
+            <a:avLst/>
+          </a:prstGeom>
+          <a:noFill/>
+        </p:spPr>
+        <p:txBody>
+          <a:bodyPr wrap="square" lIns="36576" rIns="36576" tIns="18288" bIns="18288" anchor="t">
+            <a:spAutoFit/>
+          </a:bodyPr>
+          <a:lstStyle/>
+          <a:p>
+            <a:pPr algn="l">
+              <a:spcAft>
+                <a:spcPts val="200"/>
+              </a:spcAft>
+            </a:pPr>
+            <a:r>
+              <a:rPr sz="800" b="1">
+                <a:solidFill>
+                  <a:srgbClr val="1F2A44"/>
+                </a:solidFill>
+                <a:latin typeface="Calibri"/>
+              </a:rPr>
+              <a:t>▪ </a:t>
+            </a:r>
+            <a:r>
+              <a:rPr sz="800" b="0">
+                <a:solidFill>
+                  <a:srgbClr val="1B2420"/>
+                </a:solidFill>
+                <a:latin typeface="Calibri"/>
+              </a:rPr>
+              <a:t>Pre-financing investor / offtaker</a:t>
+            </a:r>
+          </a:p>
+          <a:p>
+            <a:pPr algn="l">
+              <a:spcAft>
+                <a:spcPts val="200"/>
+              </a:spcAft>
+            </a:pPr>
+            <a:r>
+              <a:rPr sz="800" b="1">
+                <a:solidFill>
+                  <a:srgbClr val="1F2A44"/>
+                </a:solidFill>
+                <a:latin typeface="Calibri"/>
+              </a:rPr>
+              <a:t>▪ </a:t>
+            </a:r>
+            <a:r>
+              <a:rPr sz="800" b="0">
+                <a:solidFill>
+                  <a:srgbClr val="1B2420"/>
+                </a:solidFill>
+                <a:latin typeface="Calibri"/>
+              </a:rPr>
+              <a:t>Metodologi disetujui Plan Vivo</a:t>
+            </a:r>
+          </a:p>
+          <a:p>
+            <a:pPr algn="l">
+              <a:spcAft>
+                <a:spcPts val="200"/>
+              </a:spcAft>
+            </a:pPr>
+            <a:r>
+              <a:rPr sz="800" b="1">
+                <a:solidFill>
+                  <a:srgbClr val="1F2A44"/>
+                </a:solidFill>
+                <a:latin typeface="Calibri"/>
+              </a:rPr>
+              <a:t>▪ </a:t>
+            </a:r>
+            <a:r>
+              <a:rPr sz="800" b="0">
+                <a:solidFill>
+                  <a:srgbClr val="1B2420"/>
+                </a:solidFill>
+                <a:latin typeface="Calibri"/>
+              </a:rPr>
+              <a:t>Stok karbon, baseline, PDD review</a:t>
+            </a:r>
+          </a:p>
+        </p:txBody>
+      </p:sp>
+      <p:sp>
+        <p:nvSpPr>
+          <p:cNvPr id="41" name="Rounded Rectangle 40"/>
+          <p:cNvSpPr/>
+          <p:nvPr/>
+        </p:nvSpPr>
+        <p:spPr>
+          <a:xfrm>
+            <a:off x="5309234" y="4261104"/>
+            <a:ext cx="1114425" cy="292608"/>
+          </a:xfrm>
+          <a:prstGeom prst="roundRect">
+            <a:avLst/>
+          </a:prstGeom>
+          <a:solidFill>
+            <a:srgbClr val="E6E9EF"/>
+          </a:solidFill>
+          <a:ln>
+            <a:noFill/>
+          </a:ln>
+          <a:effectLst/>
+        </p:spPr>
+        <p:txBody>
           <a:bodyPr rtlCol="0" anchor="ctr" lIns="0" rIns="0" tIns="0" bIns="0"/>
           <a:lstStyle/>
           <a:p>
             <a:pPr algn="ctr"/>
             <a:r>
+              <a:rPr sz="750" b="1">
+                <a:solidFill>
+                  <a:srgbClr val="1F2A44"/>
+                </a:solidFill>
+                <a:latin typeface="Calibri"/>
+              </a:rPr>
+              <a:t>→ PDD lolos review</a:t>
+            </a:r>
+          </a:p>
+        </p:txBody>
+      </p:sp>
+      <p:sp>
+        <p:nvSpPr>
+          <p:cNvPr id="42" name="Diamond 41"/>
+          <p:cNvSpPr/>
+          <p:nvPr/>
+        </p:nvSpPr>
+        <p:spPr>
+          <a:xfrm>
+            <a:off x="6944296" y="1856231"/>
+            <a:ext cx="493776" cy="493776"/>
+          </a:xfrm>
+          <a:prstGeom prst="diamond">
+            <a:avLst/>
+          </a:prstGeom>
+          <a:solidFill>
+            <a:srgbClr val="FFFFFF"/>
+          </a:solidFill>
+          <a:ln w="28575">
+            <a:solidFill>
+              <a:srgbClr val="1F2A44"/>
+            </a:solidFill>
+          </a:ln>
+          <a:effectLst/>
+        </p:spPr>
+        <p:txBody>
+          <a:bodyPr rtlCol="0" anchor="ctr" lIns="0" rIns="0" tIns="0" bIns="0"/>
+          <a:lstStyle/>
+          <a:p>
+            <a:pPr algn="ctr"/>
+            <a:r>
               <a:rPr sz="1300" b="1">
                 <a:solidFill>
-                  <a:srgbClr val="FFFFFF"/>
-                </a:solidFill>
-                <a:latin typeface="Calibri"/>
-              </a:rPr>
-              <a:t>4</a:t>
-            </a:r>
-          </a:p>
-        </p:txBody>
-      </p:sp>
-      <p:sp>
-        <p:nvSpPr>
-          <p:cNvPr id="34" name="Rectangle 33"/>
+                  <a:srgbClr val="1F2A44"/>
+                </a:solidFill>
+                <a:latin typeface="Calibri"/>
+              </a:rPr>
+              <a:t>5</a:t>
+            </a:r>
+          </a:p>
+        </p:txBody>
+      </p:sp>
+      <p:sp>
+        <p:nvSpPr>
+          <p:cNvPr id="43" name="Rectangle 42"/>
           <p:cNvSpPr/>
           <p:nvPr/>
         </p:nvSpPr>
         <p:spPr>
           <a:xfrm>
-            <a:off x="5236082" y="2450592"/>
+            <a:off x="6560820" y="2450592"/>
             <a:ext cx="1260729" cy="2194560"/>
           </a:xfrm>
           <a:prstGeom prst="rect">
@@ -4889,13 +5266,13 @@
       </p:sp>
       <p:sp>
         <p:nvSpPr>
-          <p:cNvPr id="35" name="Rectangle 34"/>
+          <p:cNvPr id="44" name="Rectangle 43"/>
           <p:cNvSpPr/>
           <p:nvPr/>
         </p:nvSpPr>
         <p:spPr>
           <a:xfrm>
-            <a:off x="5236082" y="2450592"/>
+            <a:off x="6560820" y="2450592"/>
             <a:ext cx="1260729" cy="45720"/>
           </a:xfrm>
           <a:prstGeom prst="rect">
@@ -4919,13 +5296,13 @@
       </p:sp>
       <p:sp>
         <p:nvSpPr>
-          <p:cNvPr id="36" name="TextBox 35"/>
+          <p:cNvPr id="45" name="TextBox 44"/>
           <p:cNvSpPr txBox="1"/>
           <p:nvPr/>
         </p:nvSpPr>
         <p:spPr>
           <a:xfrm>
-            <a:off x="5309234" y="2542032"/>
+            <a:off x="6633972" y="2542032"/>
             <a:ext cx="1114425" cy="411480"/>
           </a:xfrm>
           <a:prstGeom prst="rect">
@@ -4947,20 +5324,20 @@
                 </a:solidFill>
                 <a:latin typeface="Calibri"/>
               </a:rPr>
-              <a:t>Penyusunan PDD</a:t>
-            </a:r>
-          </a:p>
-        </p:txBody>
-      </p:sp>
-      <p:sp>
-        <p:nvSpPr>
-          <p:cNvPr id="37" name="TextBox 36"/>
+              <a:t>Validasi &amp; Registrasi</a:t>
+            </a:r>
+          </a:p>
+        </p:txBody>
+      </p:sp>
+      <p:sp>
+        <p:nvSpPr>
+          <p:cNvPr id="46" name="TextBox 45"/>
           <p:cNvSpPr txBox="1"/>
           <p:nvPr/>
         </p:nvSpPr>
         <p:spPr>
           <a:xfrm>
-            <a:off x="5309234" y="2962656"/>
+            <a:off x="6633972" y="2962656"/>
             <a:ext cx="1114425" cy="182880"/>
           </a:xfrm>
           <a:prstGeom prst="rect">
@@ -4982,20 +5359,20 @@
                 </a:solidFill>
                 <a:latin typeface="Calibri"/>
               </a:rPr>
-              <a:t>2027 – 2029 · M9</a:t>
-            </a:r>
-          </a:p>
-        </p:txBody>
-      </p:sp>
-      <p:sp>
-        <p:nvSpPr>
-          <p:cNvPr id="38" name="TextBox 37"/>
+              <a:t>2029 – 2030 · M10</a:t>
+            </a:r>
+          </a:p>
+        </p:txBody>
+      </p:sp>
+      <p:sp>
+        <p:nvSpPr>
+          <p:cNvPr id="47" name="TextBox 46"/>
           <p:cNvSpPr txBox="1"/>
           <p:nvPr/>
         </p:nvSpPr>
         <p:spPr>
           <a:xfrm>
-            <a:off x="5272658" y="3182112"/>
+            <a:off x="6597396" y="3182112"/>
             <a:ext cx="1169288" cy="1005840"/>
           </a:xfrm>
           <a:prstGeom prst="rect">
@@ -5030,7 +5407,7 @@
                 </a:solidFill>
                 <a:latin typeface="Calibri"/>
               </a:rPr>
-              <a:t>Metodologi disetujui Plan Vivo</a:t>
+              <a:t>DPP tercatat di Kemenhut</a:t>
             </a:r>
           </a:p>
           <a:p>
@@ -5055,7 +5432,7 @@
                 </a:solidFill>
                 <a:latin typeface="Calibri"/>
               </a:rPr>
-              <a:t>Stok karbon &amp; baseline penuh</a:t>
+              <a:t>Audit VVB / microscale IE</a:t>
             </a:r>
           </a:p>
           <a:p>
@@ -5080,20 +5457,20 @@
                 </a:solidFill>
                 <a:latin typeface="Calibri"/>
               </a:rPr>
-              <a:t>Konsultasi publik + PDD review</a:t>
-            </a:r>
-          </a:p>
-        </p:txBody>
-      </p:sp>
-      <p:sp>
-        <p:nvSpPr>
-          <p:cNvPr id="39" name="Rounded Rectangle 38"/>
+              <a:t>MoU &amp; PV Climate Registry</a:t>
+            </a:r>
+          </a:p>
+        </p:txBody>
+      </p:sp>
+      <p:sp>
+        <p:nvSpPr>
+          <p:cNvPr id="48" name="Rounded Rectangle 47"/>
           <p:cNvSpPr/>
           <p:nvPr/>
         </p:nvSpPr>
         <p:spPr>
           <a:xfrm>
-            <a:off x="5309234" y="4261104"/>
+            <a:off x="6633972" y="4261104"/>
             <a:ext cx="1114425" cy="292608"/>
           </a:xfrm>
           <a:prstGeom prst="roundRect">
@@ -5119,20 +5496,328 @@
                 </a:solidFill>
                 <a:latin typeface="Calibri"/>
               </a:rPr>
-              <a:t>→ PDD lolos review</a:t>
-            </a:r>
-          </a:p>
-        </p:txBody>
-      </p:sp>
-      <p:sp>
-        <p:nvSpPr>
-          <p:cNvPr id="40" name="Diamond 39"/>
+              <a:t>→ Proyek terdaftar</a:t>
+            </a:r>
+          </a:p>
+        </p:txBody>
+      </p:sp>
+      <p:sp>
+        <p:nvSpPr>
+          <p:cNvPr id="49" name="Oval 48"/>
           <p:cNvSpPr/>
           <p:nvPr/>
         </p:nvSpPr>
         <p:spPr>
           <a:xfrm>
-            <a:off x="6944296" y="1856231"/>
+            <a:off x="8296465" y="1883663"/>
+            <a:ext cx="438912" cy="438912"/>
+          </a:xfrm>
+          <a:prstGeom prst="ellipse">
+            <a:avLst/>
+          </a:prstGeom>
+          <a:solidFill>
+            <a:srgbClr val="1F2A44"/>
+          </a:solidFill>
+          <a:ln>
+            <a:noFill/>
+          </a:ln>
+          <a:effectLst/>
+        </p:spPr>
+        <p:txBody>
+          <a:bodyPr rtlCol="0" anchor="ctr" lIns="0" rIns="0" tIns="0" bIns="0"/>
+          <a:lstStyle/>
+          <a:p>
+            <a:pPr algn="ctr"/>
+            <a:r>
+              <a:rPr sz="1300" b="1">
+                <a:solidFill>
+                  <a:srgbClr val="FFFFFF"/>
+                </a:solidFill>
+                <a:latin typeface="Calibri"/>
+              </a:rPr>
+              <a:t>6</a:t>
+            </a:r>
+          </a:p>
+        </p:txBody>
+      </p:sp>
+      <p:sp>
+        <p:nvSpPr>
+          <p:cNvPr id="50" name="Rectangle 49"/>
+          <p:cNvSpPr/>
+          <p:nvPr/>
+        </p:nvSpPr>
+        <p:spPr>
+          <a:xfrm>
+            <a:off x="7885557" y="2450592"/>
+            <a:ext cx="1260729" cy="2194560"/>
+          </a:xfrm>
+          <a:prstGeom prst="rect">
+            <a:avLst/>
+          </a:prstGeom>
+          <a:solidFill>
+            <a:srgbClr val="FFFFFF"/>
+          </a:solidFill>
+          <a:ln w="9525">
+            <a:solidFill>
+              <a:srgbClr val="D5DBD6"/>
+            </a:solidFill>
+          </a:ln>
+          <a:effectLst/>
+        </p:spPr>
+        <p:txBody>
+          <a:bodyPr rtlCol="0" anchor="ctr"/>
+          <a:lstStyle/>
+          <a:p>
+            <a:pPr algn="ctr"/>
+          </a:p>
+        </p:txBody>
+      </p:sp>
+      <p:sp>
+        <p:nvSpPr>
+          <p:cNvPr id="51" name="Rectangle 50"/>
+          <p:cNvSpPr/>
+          <p:nvPr/>
+        </p:nvSpPr>
+        <p:spPr>
+          <a:xfrm>
+            <a:off x="7885557" y="2450592"/>
+            <a:ext cx="1260729" cy="45720"/>
+          </a:xfrm>
+          <a:prstGeom prst="rect">
+            <a:avLst/>
+          </a:prstGeom>
+          <a:solidFill>
+            <a:srgbClr val="1F2A44"/>
+          </a:solidFill>
+          <a:ln>
+            <a:noFill/>
+          </a:ln>
+          <a:effectLst/>
+        </p:spPr>
+        <p:txBody>
+          <a:bodyPr rtlCol="0" anchor="ctr"/>
+          <a:lstStyle/>
+          <a:p>
+            <a:pPr algn="ctr"/>
+          </a:p>
+        </p:txBody>
+      </p:sp>
+      <p:sp>
+        <p:nvSpPr>
+          <p:cNvPr id="52" name="TextBox 51"/>
+          <p:cNvSpPr txBox="1"/>
+          <p:nvPr/>
+        </p:nvSpPr>
+        <p:spPr>
+          <a:xfrm>
+            <a:off x="7958709" y="2542032"/>
+            <a:ext cx="1114425" cy="411480"/>
+          </a:xfrm>
+          <a:prstGeom prst="rect">
+            <a:avLst/>
+          </a:prstGeom>
+          <a:noFill/>
+        </p:spPr>
+        <p:txBody>
+          <a:bodyPr wrap="square" lIns="18288" rIns="18288" tIns="9144" bIns="9144" anchor="t">
+            <a:spAutoFit/>
+          </a:bodyPr>
+          <a:lstStyle/>
+          <a:p>
+            <a:pPr algn="l"/>
+            <a:r>
+              <a:rPr sz="1000" b="1" i="0">
+                <a:solidFill>
+                  <a:srgbClr val="1B2420"/>
+                </a:solidFill>
+                <a:latin typeface="Calibri"/>
+              </a:rPr>
+              <a:t>Implementasi &amp; Monitoring</a:t>
+            </a:r>
+          </a:p>
+        </p:txBody>
+      </p:sp>
+      <p:sp>
+        <p:nvSpPr>
+          <p:cNvPr id="53" name="TextBox 52"/>
+          <p:cNvSpPr txBox="1"/>
+          <p:nvPr/>
+        </p:nvSpPr>
+        <p:spPr>
+          <a:xfrm>
+            <a:off x="7958709" y="2962656"/>
+            <a:ext cx="1114425" cy="182880"/>
+          </a:xfrm>
+          <a:prstGeom prst="rect">
+            <a:avLst/>
+          </a:prstGeom>
+          <a:noFill/>
+        </p:spPr>
+        <p:txBody>
+          <a:bodyPr wrap="square" lIns="18288" rIns="18288" tIns="9144" bIns="9144" anchor="t">
+            <a:spAutoFit/>
+          </a:bodyPr>
+          <a:lstStyle/>
+          <a:p>
+            <a:pPr algn="l"/>
+            <a:r>
+              <a:rPr sz="700" b="1" i="0">
+                <a:solidFill>
+                  <a:srgbClr val="1F2A44"/>
+                </a:solidFill>
+                <a:latin typeface="Calibri"/>
+              </a:rPr>
+              <a:t>2030 → · M11</a:t>
+            </a:r>
+          </a:p>
+        </p:txBody>
+      </p:sp>
+      <p:sp>
+        <p:nvSpPr>
+          <p:cNvPr id="54" name="TextBox 53"/>
+          <p:cNvSpPr txBox="1"/>
+          <p:nvPr/>
+        </p:nvSpPr>
+        <p:spPr>
+          <a:xfrm>
+            <a:off x="7922133" y="3182112"/>
+            <a:ext cx="1169288" cy="1005840"/>
+          </a:xfrm>
+          <a:prstGeom prst="rect">
+            <a:avLst/>
+          </a:prstGeom>
+          <a:noFill/>
+        </p:spPr>
+        <p:txBody>
+          <a:bodyPr wrap="square" lIns="36576" rIns="36576" tIns="18288" bIns="18288" anchor="t">
+            <a:spAutoFit/>
+          </a:bodyPr>
+          <a:lstStyle/>
+          <a:p>
+            <a:pPr algn="l">
+              <a:spcAft>
+                <a:spcPts val="200"/>
+              </a:spcAft>
+            </a:pPr>
+            <a:r>
+              <a:rPr sz="800" b="1">
+                <a:solidFill>
+                  <a:srgbClr val="1F2A44"/>
+                </a:solidFill>
+                <a:latin typeface="Calibri"/>
+              </a:rPr>
+              <a:t>▪ </a:t>
+            </a:r>
+            <a:r>
+              <a:rPr sz="800" b="0">
+                <a:solidFill>
+                  <a:srgbClr val="1B2420"/>
+                </a:solidFill>
+                <a:latin typeface="Calibri"/>
+              </a:rPr>
+              <a:t>Perlindungan &amp; restorasi</a:t>
+            </a:r>
+          </a:p>
+          <a:p>
+            <a:pPr algn="l">
+              <a:spcAft>
+                <a:spcPts val="200"/>
+              </a:spcAft>
+            </a:pPr>
+            <a:r>
+              <a:rPr sz="800" b="1">
+                <a:solidFill>
+                  <a:srgbClr val="1F2A44"/>
+                </a:solidFill>
+                <a:latin typeface="Calibri"/>
+              </a:rPr>
+              <a:t>▪ </a:t>
+            </a:r>
+            <a:r>
+              <a:rPr sz="800" b="0">
+                <a:solidFill>
+                  <a:srgbClr val="1B2420"/>
+                </a:solidFill>
+                <a:latin typeface="Calibri"/>
+              </a:rPr>
+              <a:t>Livelihood KUPS &amp; WFD</a:t>
+            </a:r>
+          </a:p>
+          <a:p>
+            <a:pPr algn="l">
+              <a:spcAft>
+                <a:spcPts val="200"/>
+              </a:spcAft>
+            </a:pPr>
+            <a:r>
+              <a:rPr sz="800" b="1">
+                <a:solidFill>
+                  <a:srgbClr val="1F2A44"/>
+                </a:solidFill>
+                <a:latin typeface="Calibri"/>
+              </a:rPr>
+              <a:t>▪ </a:t>
+            </a:r>
+            <a:r>
+              <a:rPr sz="800" b="0">
+                <a:solidFill>
+                  <a:srgbClr val="1B2420"/>
+                </a:solidFill>
+                <a:latin typeface="Calibri"/>
+              </a:rPr>
+              <a:t>Annual Report tiap 12 bln</a:t>
+            </a:r>
+          </a:p>
+        </p:txBody>
+      </p:sp>
+      <p:sp>
+        <p:nvSpPr>
+          <p:cNvPr id="55" name="Rounded Rectangle 54"/>
+          <p:cNvSpPr/>
+          <p:nvPr/>
+        </p:nvSpPr>
+        <p:spPr>
+          <a:xfrm>
+            <a:off x="7958709" y="4261104"/>
+            <a:ext cx="1114425" cy="292608"/>
+          </a:xfrm>
+          <a:prstGeom prst="roundRect">
+            <a:avLst/>
+          </a:prstGeom>
+          <a:solidFill>
+            <a:srgbClr val="E6E9EF"/>
+          </a:solidFill>
+          <a:ln>
+            <a:noFill/>
+          </a:ln>
+          <a:effectLst/>
+        </p:spPr>
+        <p:txBody>
+          <a:bodyPr rtlCol="0" anchor="ctr" lIns="0" rIns="0" tIns="0" bIns="0"/>
+          <a:lstStyle/>
+          <a:p>
+            <a:pPr algn="ctr"/>
+            <a:r>
+              <a:rPr sz="750" b="1">
+                <a:solidFill>
+                  <a:srgbClr val="1F2A44"/>
+                </a:solidFill>
+                <a:latin typeface="Calibri"/>
+              </a:rPr>
+              <a:t>→ Data monitoring</a:t>
+            </a:r>
+          </a:p>
+        </p:txBody>
+      </p:sp>
+      <p:sp>
+        <p:nvSpPr>
+          <p:cNvPr id="56" name="Diamond 55"/>
+          <p:cNvSpPr/>
+          <p:nvPr/>
+        </p:nvSpPr>
+        <p:spPr>
+          <a:xfrm>
+            <a:off x="9593770" y="1856231"/>
             <a:ext cx="493776" cy="493776"/>
           </a:xfrm>
           <a:prstGeom prst="diamond">
@@ -5160,20 +5845,20 @@
                 </a:solidFill>
                 <a:latin typeface="Calibri"/>
               </a:rPr>
-              <a:t>5</a:t>
-            </a:r>
-          </a:p>
-        </p:txBody>
-      </p:sp>
-      <p:sp>
-        <p:nvSpPr>
-          <p:cNvPr id="41" name="Rectangle 40"/>
+              <a:t>7</a:t>
+            </a:r>
+          </a:p>
+        </p:txBody>
+      </p:sp>
+      <p:sp>
+        <p:nvSpPr>
+          <p:cNvPr id="57" name="Rectangle 56"/>
           <p:cNvSpPr/>
           <p:nvPr/>
         </p:nvSpPr>
         <p:spPr>
           <a:xfrm>
-            <a:off x="6560820" y="2450592"/>
+            <a:off x="9210293" y="2450592"/>
             <a:ext cx="1260729" cy="2194560"/>
           </a:xfrm>
           <a:prstGeom prst="rect">
@@ -5199,13 +5884,13 @@
       </p:sp>
       <p:sp>
         <p:nvSpPr>
-          <p:cNvPr id="42" name="Rectangle 41"/>
+          <p:cNvPr id="58" name="Rectangle 57"/>
           <p:cNvSpPr/>
           <p:nvPr/>
         </p:nvSpPr>
         <p:spPr>
           <a:xfrm>
-            <a:off x="6560820" y="2450592"/>
+            <a:off x="9210293" y="2450592"/>
             <a:ext cx="1260729" cy="45720"/>
           </a:xfrm>
           <a:prstGeom prst="rect">
@@ -5229,13 +5914,13 @@
       </p:sp>
       <p:sp>
         <p:nvSpPr>
-          <p:cNvPr id="43" name="TextBox 42"/>
+          <p:cNvPr id="59" name="TextBox 58"/>
           <p:cNvSpPr txBox="1"/>
           <p:nvPr/>
         </p:nvSpPr>
         <p:spPr>
           <a:xfrm>
-            <a:off x="6633972" y="2542032"/>
+            <a:off x="9283445" y="2542032"/>
             <a:ext cx="1114425" cy="411480"/>
           </a:xfrm>
           <a:prstGeom prst="rect">
@@ -5257,20 +5942,20 @@
                 </a:solidFill>
                 <a:latin typeface="Calibri"/>
               </a:rPr>
-              <a:t>Validasi &amp; Registrasi</a:t>
-            </a:r>
-          </a:p>
-        </p:txBody>
-      </p:sp>
-      <p:sp>
-        <p:nvSpPr>
-          <p:cNvPr id="44" name="TextBox 43"/>
+              <a:t>Verifikasi &amp; Issuance</a:t>
+            </a:r>
+          </a:p>
+        </p:txBody>
+      </p:sp>
+      <p:sp>
+        <p:nvSpPr>
+          <p:cNvPr id="60" name="TextBox 59"/>
           <p:cNvSpPr txBox="1"/>
           <p:nvPr/>
         </p:nvSpPr>
         <p:spPr>
           <a:xfrm>
-            <a:off x="6633972" y="2962656"/>
+            <a:off x="9283445" y="2962656"/>
             <a:ext cx="1114425" cy="182880"/>
           </a:xfrm>
           <a:prstGeom prst="rect">
@@ -5292,20 +5977,20 @@
                 </a:solidFill>
                 <a:latin typeface="Calibri"/>
               </a:rPr>
-              <a:t>2029 – 2030 · M10</a:t>
-            </a:r>
-          </a:p>
-        </p:txBody>
-      </p:sp>
-      <p:sp>
-        <p:nvSpPr>
-          <p:cNvPr id="45" name="TextBox 44"/>
+              <a:t>≤5 th pasca-validasi · M12</a:t>
+            </a:r>
+          </a:p>
+        </p:txBody>
+      </p:sp>
+      <p:sp>
+        <p:nvSpPr>
+          <p:cNvPr id="61" name="TextBox 60"/>
           <p:cNvSpPr txBox="1"/>
           <p:nvPr/>
         </p:nvSpPr>
         <p:spPr>
           <a:xfrm>
-            <a:off x="6597396" y="3182112"/>
+            <a:off x="9246869" y="3182112"/>
             <a:ext cx="1169288" cy="1005840"/>
           </a:xfrm>
           <a:prstGeom prst="rect">
@@ -5340,7 +6025,7 @@
                 </a:solidFill>
                 <a:latin typeface="Calibri"/>
               </a:rPr>
-              <a:t>DPP tercatat di Kemenhut</a:t>
+              <a:t>Audit verifikasi ≤5 th</a:t>
             </a:r>
           </a:p>
           <a:p>
@@ -5365,7 +6050,7 @@
                 </a:solidFill>
                 <a:latin typeface="Calibri"/>
               </a:rPr>
-              <a:t>Audit VVB / microscale IE</a:t>
+              <a:t>Persetujuan Menteri</a:t>
             </a:r>
           </a:p>
           <a:p>
@@ -5390,20 +6075,20 @@
                 </a:solidFill>
                 <a:latin typeface="Calibri"/>
               </a:rPr>
-              <a:t>MoU &amp; PV Climate Registry</a:t>
-            </a:r>
-          </a:p>
-        </p:txBody>
-      </p:sp>
-      <p:sp>
-        <p:nvSpPr>
-          <p:cNvPr id="46" name="Rounded Rectangle 45"/>
+              <a:t>vPVC terbit, nomor seri</a:t>
+            </a:r>
+          </a:p>
+        </p:txBody>
+      </p:sp>
+      <p:sp>
+        <p:nvSpPr>
+          <p:cNvPr id="62" name="Rounded Rectangle 61"/>
           <p:cNvSpPr/>
           <p:nvPr/>
         </p:nvSpPr>
         <p:spPr>
           <a:xfrm>
-            <a:off x="6633972" y="4261104"/>
+            <a:off x="9283445" y="4261104"/>
             <a:ext cx="1114425" cy="292608"/>
           </a:xfrm>
           <a:prstGeom prst="roundRect">
@@ -5429,20 +6114,20 @@
                 </a:solidFill>
                 <a:latin typeface="Calibri"/>
               </a:rPr>
-              <a:t>→ Proyek terdaftar</a:t>
-            </a:r>
-          </a:p>
-        </p:txBody>
-      </p:sp>
-      <p:sp>
-        <p:nvSpPr>
-          <p:cNvPr id="47" name="Oval 46"/>
+              <a:t>→ vPVC di registry</a:t>
+            </a:r>
+          </a:p>
+        </p:txBody>
+      </p:sp>
+      <p:sp>
+        <p:nvSpPr>
+          <p:cNvPr id="63" name="Oval 62"/>
           <p:cNvSpPr/>
           <p:nvPr/>
         </p:nvSpPr>
         <p:spPr>
           <a:xfrm>
-            <a:off x="8296465" y="1883663"/>
+            <a:off x="10945939" y="1883663"/>
             <a:ext cx="438912" cy="438912"/>
           </a:xfrm>
           <a:prstGeom prst="ellipse">
@@ -5468,20 +6153,20 @@
                 </a:solidFill>
                 <a:latin typeface="Calibri"/>
               </a:rPr>
-              <a:t>6</a:t>
-            </a:r>
-          </a:p>
-        </p:txBody>
-      </p:sp>
-      <p:sp>
-        <p:nvSpPr>
-          <p:cNvPr id="48" name="Rectangle 47"/>
+              <a:t>8</a:t>
+            </a:r>
+          </a:p>
+        </p:txBody>
+      </p:sp>
+      <p:sp>
+        <p:nvSpPr>
+          <p:cNvPr id="64" name="Rectangle 63"/>
           <p:cNvSpPr/>
           <p:nvPr/>
         </p:nvSpPr>
         <p:spPr>
           <a:xfrm>
-            <a:off x="7885557" y="2450592"/>
+            <a:off x="10535030" y="2450592"/>
             <a:ext cx="1260729" cy="2194560"/>
           </a:xfrm>
           <a:prstGeom prst="rect">
@@ -5507,13 +6192,13 @@
       </p:sp>
       <p:sp>
         <p:nvSpPr>
-          <p:cNvPr id="49" name="Rectangle 48"/>
+          <p:cNvPr id="65" name="Rectangle 64"/>
           <p:cNvSpPr/>
           <p:nvPr/>
         </p:nvSpPr>
         <p:spPr>
           <a:xfrm>
-            <a:off x="7885557" y="2450592"/>
+            <a:off x="10535030" y="2450592"/>
             <a:ext cx="1260729" cy="45720"/>
           </a:xfrm>
           <a:prstGeom prst="rect">
@@ -5537,13 +6222,13 @@
       </p:sp>
       <p:sp>
         <p:nvSpPr>
-          <p:cNvPr id="50" name="TextBox 49"/>
+          <p:cNvPr id="66" name="TextBox 65"/>
           <p:cNvSpPr txBox="1"/>
           <p:nvPr/>
         </p:nvSpPr>
         <p:spPr>
           <a:xfrm>
-            <a:off x="7958709" y="2542032"/>
+            <a:off x="10608182" y="2542032"/>
             <a:ext cx="1114425" cy="411480"/>
           </a:xfrm>
           <a:prstGeom prst="rect">
@@ -5565,20 +6250,20 @@
                 </a:solidFill>
                 <a:latin typeface="Calibri"/>
               </a:rPr>
-              <a:t>Implementasi &amp; Monitoring</a:t>
-            </a:r>
-          </a:p>
-        </p:txBody>
-      </p:sp>
-      <p:sp>
-        <p:nvSpPr>
-          <p:cNvPr id="51" name="TextBox 50"/>
+              <a:t>Penjualan &amp; Benefit Sharing</a:t>
+            </a:r>
+          </a:p>
+        </p:txBody>
+      </p:sp>
+      <p:sp>
+        <p:nvSpPr>
+          <p:cNvPr id="67" name="TextBox 66"/>
           <p:cNvSpPr txBox="1"/>
           <p:nvPr/>
         </p:nvSpPr>
         <p:spPr>
           <a:xfrm>
-            <a:off x="7958709" y="2962656"/>
+            <a:off x="10608182" y="2962656"/>
             <a:ext cx="1114425" cy="182880"/>
           </a:xfrm>
           <a:prstGeom prst="rect">
@@ -5600,20 +6285,20 @@
                 </a:solidFill>
                 <a:latin typeface="Calibri"/>
               </a:rPr>
-              <a:t>2030 → · M11</a:t>
-            </a:r>
-          </a:p>
-        </p:txBody>
-      </p:sp>
-      <p:sp>
-        <p:nvSpPr>
-          <p:cNvPr id="52" name="TextBox 51"/>
+              <a:t>setelah issuance · M13</a:t>
+            </a:r>
+          </a:p>
+        </p:txBody>
+      </p:sp>
+      <p:sp>
+        <p:nvSpPr>
+          <p:cNvPr id="68" name="TextBox 67"/>
           <p:cNvSpPr txBox="1"/>
           <p:nvPr/>
         </p:nvSpPr>
         <p:spPr>
           <a:xfrm>
-            <a:off x="7922133" y="3182112"/>
+            <a:off x="10571606" y="3182112"/>
             <a:ext cx="1169288" cy="1005840"/>
           </a:xfrm>
           <a:prstGeom prst="rect">
@@ -5648,7 +6333,7 @@
                 </a:solidFill>
                 <a:latin typeface="Calibri"/>
               </a:rPr>
-              <a:t>Perlindungan &amp; restorasi</a:t>
+              <a:t>Realisasi offtake &amp; penjualan</a:t>
             </a:r>
           </a:p>
           <a:p>
@@ -5673,7 +6358,7 @@
                 </a:solidFill>
                 <a:latin typeface="Calibri"/>
               </a:rPr>
-              <a:t>Livelihood KUPS &amp; WFD</a:t>
+              <a:t>Otorisasi/CA bila ekspor; PNBP</a:t>
             </a:r>
           </a:p>
           <a:p>
@@ -5698,20 +6383,20 @@
                 </a:solidFill>
                 <a:latin typeface="Calibri"/>
               </a:rPr>
-              <a:t>Annual Report tiap 12 bln</a:t>
-            </a:r>
-          </a:p>
-        </p:txBody>
-      </p:sp>
-      <p:sp>
-        <p:nvSpPr>
-          <p:cNvPr id="53" name="Rounded Rectangle 52"/>
+              <a:t>≥60% pendapatan ke komunitas</a:t>
+            </a:r>
+          </a:p>
+        </p:txBody>
+      </p:sp>
+      <p:sp>
+        <p:nvSpPr>
+          <p:cNvPr id="69" name="Rounded Rectangle 68"/>
           <p:cNvSpPr/>
           <p:nvPr/>
         </p:nvSpPr>
         <p:spPr>
           <a:xfrm>
-            <a:off x="7958709" y="4261104"/>
+            <a:off x="10608182" y="4261104"/>
             <a:ext cx="1114425" cy="292608"/>
           </a:xfrm>
           <a:prstGeom prst="roundRect">
@@ -5737,32 +6422,65 @@
                 </a:solidFill>
                 <a:latin typeface="Calibri"/>
               </a:rPr>
-              <a:t>→ Data monitoring</a:t>
-            </a:r>
-          </a:p>
-        </p:txBody>
-      </p:sp>
-      <p:sp>
-        <p:nvSpPr>
-          <p:cNvPr id="54" name="Diamond 53"/>
+              <a:t>→ Pendapatan &amp; manfaat</a:t>
+            </a:r>
+          </a:p>
+        </p:txBody>
+      </p:sp>
+      <p:sp>
+        <p:nvSpPr>
+          <p:cNvPr id="70" name="TextBox 69"/>
+          <p:cNvSpPr txBox="1"/>
+          <p:nvPr/>
+        </p:nvSpPr>
+        <p:spPr>
+          <a:xfrm>
+            <a:off x="411480" y="4809744"/>
+            <a:ext cx="777240" cy="274320"/>
+          </a:xfrm>
+          <a:prstGeom prst="rect">
+            <a:avLst/>
+          </a:prstGeom>
+          <a:noFill/>
+        </p:spPr>
+        <p:txBody>
+          <a:bodyPr wrap="square" lIns="18288" rIns="18288" tIns="9144" bIns="9144" anchor="t">
+            <a:spAutoFit/>
+          </a:bodyPr>
+          <a:lstStyle/>
+          <a:p>
+            <a:pPr algn="l"/>
+            <a:r>
+              <a:rPr sz="800" b="1" i="0">
+                <a:solidFill>
+                  <a:srgbClr val="5F6B65"/>
+                </a:solidFill>
+                <a:latin typeface="Calibri"/>
+              </a:rPr>
+              <a:t>DUKUNGAN</a:t>
+            </a:r>
+          </a:p>
+        </p:txBody>
+      </p:sp>
+      <p:sp>
+        <p:nvSpPr>
+          <p:cNvPr id="71" name="Rectangle 70"/>
           <p:cNvSpPr/>
           <p:nvPr/>
         </p:nvSpPr>
         <p:spPr>
           <a:xfrm>
-            <a:off x="9593770" y="1856231"/>
-            <a:ext cx="493776" cy="493776"/>
-          </a:xfrm>
-          <a:prstGeom prst="diamond">
+            <a:off x="1261872" y="4773168"/>
+            <a:ext cx="3910203" cy="292608"/>
+          </a:xfrm>
+          <a:prstGeom prst="rect">
             <a:avLst/>
           </a:prstGeom>
           <a:solidFill>
-            <a:srgbClr val="FFFFFF"/>
+            <a:srgbClr val="E3F1EE"/>
           </a:solidFill>
-          <a:ln w="28575">
-            <a:solidFill>
-              <a:srgbClr val="1F2A44"/>
-            </a:solidFill>
+          <a:ln>
+            <a:noFill/>
           </a:ln>
           <a:effectLst/>
         </p:spPr>
@@ -5772,59 +6490,218 @@
           <a:p>
             <a:pPr algn="ctr"/>
             <a:r>
-              <a:rPr sz="1300" b="1">
-                <a:solidFill>
-                  <a:srgbClr val="1F2A44"/>
-                </a:solidFill>
-                <a:latin typeface="Calibri"/>
-              </a:rPr>
-              <a:t>7</a:t>
-            </a:r>
-          </a:p>
-        </p:txBody>
-      </p:sp>
-      <p:sp>
-        <p:nvSpPr>
-          <p:cNvPr id="55" name="Rectangle 54"/>
+              <a:rPr sz="800" b="1">
+                <a:solidFill>
+                  <a:srgbClr val="0E7C6B"/>
+                </a:solidFill>
+                <a:latin typeface="Calibri"/>
+              </a:rPr>
+              <a:t>TAF · SETAPAK 4 — SAMPAN Kalimantan &amp; LPHD Pasir</a:t>
+            </a:r>
+          </a:p>
+        </p:txBody>
+      </p:sp>
+      <p:sp>
+        <p:nvSpPr>
+          <p:cNvPr id="72" name="Rectangle 71"/>
           <p:cNvSpPr/>
           <p:nvPr/>
         </p:nvSpPr>
         <p:spPr>
           <a:xfrm>
-            <a:off x="9210293" y="2450592"/>
-            <a:ext cx="1260729" cy="2194560"/>
+            <a:off x="5236082" y="4773168"/>
+            <a:ext cx="6559676" cy="292608"/>
           </a:xfrm>
           <a:prstGeom prst="rect">
             <a:avLst/>
           </a:prstGeom>
           <a:solidFill>
-            <a:srgbClr val="FFFFFF"/>
+            <a:srgbClr val="E6E9EF"/>
           </a:solidFill>
-          <a:ln w="9525">
-            <a:solidFill>
-              <a:srgbClr val="D5DBD6"/>
-            </a:solidFill>
+          <a:ln>
+            <a:noFill/>
           </a:ln>
           <a:effectLst/>
         </p:spPr>
         <p:txBody>
-          <a:bodyPr rtlCol="0" anchor="ctr"/>
+          <a:bodyPr rtlCol="0" anchor="ctr" lIns="0" rIns="0" tIns="0" bIns="0"/>
           <a:lstStyle/>
           <a:p>
             <a:pPr algn="ctr"/>
-          </a:p>
-        </p:txBody>
-      </p:sp>
-      <p:sp>
-        <p:nvSpPr>
-          <p:cNvPr id="56" name="Rectangle 55"/>
+            <a:r>
+              <a:rPr sz="800" b="1">
+                <a:solidFill>
+                  <a:srgbClr val="1F2A44"/>
+                </a:solidFill>
+                <a:latin typeface="Calibri"/>
+              </a:rPr>
+              <a:t>Investor / offtaker (pre-financing, presale berjangka) + pendanaan lanjutan  →  pendapatan karbon</a:t>
+            </a:r>
+          </a:p>
+        </p:txBody>
+      </p:sp>
+      <p:sp>
+        <p:nvSpPr>
+          <p:cNvPr id="73" name="TextBox 72"/>
+          <p:cNvSpPr txBox="1"/>
+          <p:nvPr/>
+        </p:nvSpPr>
+        <p:spPr>
+          <a:xfrm>
+            <a:off x="411480" y="5175504"/>
+            <a:ext cx="777240" cy="274320"/>
+          </a:xfrm>
+          <a:prstGeom prst="rect">
+            <a:avLst/>
+          </a:prstGeom>
+          <a:noFill/>
+        </p:spPr>
+        <p:txBody>
+          <a:bodyPr wrap="square" lIns="18288" rIns="18288" tIns="9144" bIns="9144" anchor="t">
+            <a:spAutoFit/>
+          </a:bodyPr>
+          <a:lstStyle/>
+          <a:p>
+            <a:pPr algn="l"/>
+            <a:r>
+              <a:rPr sz="800" b="1" i="0">
+                <a:solidFill>
+                  <a:srgbClr val="5F6B65"/>
+                </a:solidFill>
+                <a:latin typeface="Calibri"/>
+              </a:rPr>
+              <a:t>UNIT KARBON</a:t>
+            </a:r>
+          </a:p>
+        </p:txBody>
+      </p:sp>
+      <p:sp>
+        <p:nvSpPr>
+          <p:cNvPr id="74" name="Rectangle 73"/>
           <p:cNvSpPr/>
           <p:nvPr/>
         </p:nvSpPr>
         <p:spPr>
           <a:xfrm>
-            <a:off x="9210293" y="2450592"/>
-            <a:ext cx="1260729" cy="45720"/>
+            <a:off x="1261872" y="5138928"/>
+            <a:ext cx="5234940" cy="292608"/>
+          </a:xfrm>
+          <a:prstGeom prst="rect">
+            <a:avLst/>
+          </a:prstGeom>
+          <a:solidFill>
+            <a:srgbClr val="EEEFEC"/>
+          </a:solidFill>
+          <a:ln>
+            <a:noFill/>
+          </a:ln>
+          <a:effectLst/>
+        </p:spPr>
+        <p:txBody>
+          <a:bodyPr rtlCol="0" anchor="ctr" lIns="0" rIns="0" tIns="0" bIns="0"/>
+          <a:lstStyle/>
+          <a:p>
+            <a:pPr algn="ctr"/>
+            <a:r>
+              <a:rPr sz="800" b="0">
+                <a:solidFill>
+                  <a:srgbClr val="5F6B65"/>
+                </a:solidFill>
+                <a:latin typeface="Calibri"/>
+              </a:rPr>
+              <a:t>Belum ada kredit — pipeline ≠ registrasi ≠ issuance</a:t>
+            </a:r>
+          </a:p>
+        </p:txBody>
+      </p:sp>
+      <p:sp>
+        <p:nvSpPr>
+          <p:cNvPr id="75" name="Rectangle 74"/>
+          <p:cNvSpPr/>
+          <p:nvPr/>
+        </p:nvSpPr>
+        <p:spPr>
+          <a:xfrm>
+            <a:off x="6560820" y="5138928"/>
+            <a:ext cx="1260729" cy="292608"/>
+          </a:xfrm>
+          <a:prstGeom prst="rect">
+            <a:avLst/>
+          </a:prstGeom>
+          <a:solidFill>
+            <a:srgbClr val="E6E9EF"/>
+          </a:solidFill>
+          <a:ln>
+            <a:noFill/>
+          </a:ln>
+          <a:effectLst/>
+        </p:spPr>
+        <p:txBody>
+          <a:bodyPr rtlCol="0" anchor="ctr" lIns="0" rIns="0" tIns="0" bIns="0"/>
+          <a:lstStyle/>
+          <a:p>
+            <a:pPr algn="ctr"/>
+            <a:r>
+              <a:rPr sz="750" b="1">
+                <a:solidFill>
+                  <a:srgbClr val="1F2A44"/>
+                </a:solidFill>
+                <a:latin typeface="Calibri"/>
+              </a:rPr>
+              <a:t>fPVC (restorasi)</a:t>
+            </a:r>
+          </a:p>
+        </p:txBody>
+      </p:sp>
+      <p:sp>
+        <p:nvSpPr>
+          <p:cNvPr id="76" name="Rectangle 75"/>
+          <p:cNvSpPr/>
+          <p:nvPr/>
+        </p:nvSpPr>
+        <p:spPr>
+          <a:xfrm>
+            <a:off x="7885557" y="5138928"/>
+            <a:ext cx="1260729" cy="292608"/>
+          </a:xfrm>
+          <a:prstGeom prst="rect">
+            <a:avLst/>
+          </a:prstGeom>
+          <a:solidFill>
+            <a:srgbClr val="E6E9EF"/>
+          </a:solidFill>
+          <a:ln>
+            <a:noFill/>
+          </a:ln>
+          <a:effectLst/>
+        </p:spPr>
+        <p:txBody>
+          <a:bodyPr rtlCol="0" anchor="ctr" lIns="0" rIns="0" tIns="0" bIns="0"/>
+          <a:lstStyle/>
+          <a:p>
+            <a:pPr algn="ctr"/>
+            <a:r>
+              <a:rPr sz="750" b="1">
+                <a:solidFill>
+                  <a:srgbClr val="1F2A44"/>
+                </a:solidFill>
+                <a:latin typeface="Calibri"/>
+              </a:rPr>
+              <a:t>rPVC (Annual Report)</a:t>
+            </a:r>
+          </a:p>
+        </p:txBody>
+      </p:sp>
+      <p:sp>
+        <p:nvSpPr>
+          <p:cNvPr id="77" name="Rectangle 76"/>
+          <p:cNvSpPr/>
+          <p:nvPr/>
+        </p:nvSpPr>
+        <p:spPr>
+          <a:xfrm>
+            <a:off x="9210293" y="5138928"/>
+            <a:ext cx="1260729" cy="292608"/>
           </a:xfrm>
           <a:prstGeom prst="rect">
             <a:avLst/>
@@ -5838,232 +6715,34 @@
           <a:effectLst/>
         </p:spPr>
         <p:txBody>
-          <a:bodyPr rtlCol="0" anchor="ctr"/>
+          <a:bodyPr rtlCol="0" anchor="ctr" lIns="0" rIns="0" tIns="0" bIns="0"/>
           <a:lstStyle/>
           <a:p>
             <a:pPr algn="ctr"/>
-          </a:p>
-        </p:txBody>
-      </p:sp>
-      <p:sp>
-        <p:nvSpPr>
-          <p:cNvPr id="57" name="TextBox 56"/>
-          <p:cNvSpPr txBox="1"/>
-          <p:nvPr/>
-        </p:nvSpPr>
-        <p:spPr>
-          <a:xfrm>
-            <a:off x="9283445" y="2542032"/>
-            <a:ext cx="1114425" cy="411480"/>
+            <a:r>
+              <a:rPr sz="750" b="1">
+                <a:solidFill>
+                  <a:srgbClr val="FFFFFF"/>
+                </a:solidFill>
+                <a:latin typeface="Calibri"/>
+              </a:rPr>
+              <a:t>vPVC ✓ dapat di-retire</a:t>
+            </a:r>
+          </a:p>
+        </p:txBody>
+      </p:sp>
+      <p:sp>
+        <p:nvSpPr>
+          <p:cNvPr id="78" name="Rectangle 77"/>
+          <p:cNvSpPr/>
+          <p:nvPr/>
+        </p:nvSpPr>
+        <p:spPr>
+          <a:xfrm>
+            <a:off x="10535030" y="5138928"/>
+            <a:ext cx="1260729" cy="292608"/>
           </a:xfrm>
           <a:prstGeom prst="rect">
-            <a:avLst/>
-          </a:prstGeom>
-          <a:noFill/>
-        </p:spPr>
-        <p:txBody>
-          <a:bodyPr wrap="square" lIns="18288" rIns="18288" tIns="9144" bIns="9144" anchor="t">
-            <a:spAutoFit/>
-          </a:bodyPr>
-          <a:lstStyle/>
-          <a:p>
-            <a:pPr algn="l"/>
-            <a:r>
-              <a:rPr sz="1000" b="1" i="0">
-                <a:solidFill>
-                  <a:srgbClr val="1B2420"/>
-                </a:solidFill>
-                <a:latin typeface="Calibri"/>
-              </a:rPr>
-              <a:t>Verifikasi &amp; Issuance</a:t>
-            </a:r>
-          </a:p>
-        </p:txBody>
-      </p:sp>
-      <p:sp>
-        <p:nvSpPr>
-          <p:cNvPr id="58" name="TextBox 57"/>
-          <p:cNvSpPr txBox="1"/>
-          <p:nvPr/>
-        </p:nvSpPr>
-        <p:spPr>
-          <a:xfrm>
-            <a:off x="9283445" y="2962656"/>
-            <a:ext cx="1114425" cy="182880"/>
-          </a:xfrm>
-          <a:prstGeom prst="rect">
-            <a:avLst/>
-          </a:prstGeom>
-          <a:noFill/>
-        </p:spPr>
-        <p:txBody>
-          <a:bodyPr wrap="square" lIns="18288" rIns="18288" tIns="9144" bIns="9144" anchor="t">
-            <a:spAutoFit/>
-          </a:bodyPr>
-          <a:lstStyle/>
-          <a:p>
-            <a:pPr algn="l"/>
-            <a:r>
-              <a:rPr sz="700" b="1" i="0">
-                <a:solidFill>
-                  <a:srgbClr val="1F2A44"/>
-                </a:solidFill>
-                <a:latin typeface="Calibri"/>
-              </a:rPr>
-              <a:t>≤5 th pasca-validasi · M12</a:t>
-            </a:r>
-          </a:p>
-        </p:txBody>
-      </p:sp>
-      <p:sp>
-        <p:nvSpPr>
-          <p:cNvPr id="59" name="TextBox 58"/>
-          <p:cNvSpPr txBox="1"/>
-          <p:nvPr/>
-        </p:nvSpPr>
-        <p:spPr>
-          <a:xfrm>
-            <a:off x="9246869" y="3182112"/>
-            <a:ext cx="1169288" cy="1005840"/>
-          </a:xfrm>
-          <a:prstGeom prst="rect">
-            <a:avLst/>
-          </a:prstGeom>
-          <a:noFill/>
-        </p:spPr>
-        <p:txBody>
-          <a:bodyPr wrap="square" lIns="36576" rIns="36576" tIns="18288" bIns="18288" anchor="t">
-            <a:spAutoFit/>
-          </a:bodyPr>
-          <a:lstStyle/>
-          <a:p>
-            <a:pPr algn="l">
-              <a:spcAft>
-                <a:spcPts val="200"/>
-              </a:spcAft>
-            </a:pPr>
-            <a:r>
-              <a:rPr sz="800" b="1">
-                <a:solidFill>
-                  <a:srgbClr val="1F2A44"/>
-                </a:solidFill>
-                <a:latin typeface="Calibri"/>
-              </a:rPr>
-              <a:t>▪ </a:t>
-            </a:r>
-            <a:r>
-              <a:rPr sz="800" b="0">
-                <a:solidFill>
-                  <a:srgbClr val="1B2420"/>
-                </a:solidFill>
-                <a:latin typeface="Calibri"/>
-              </a:rPr>
-              <a:t>Audit verifikasi ≤5 th</a:t>
-            </a:r>
-          </a:p>
-          <a:p>
-            <a:pPr algn="l">
-              <a:spcAft>
-                <a:spcPts val="200"/>
-              </a:spcAft>
-            </a:pPr>
-            <a:r>
-              <a:rPr sz="800" b="1">
-                <a:solidFill>
-                  <a:srgbClr val="1F2A44"/>
-                </a:solidFill>
-                <a:latin typeface="Calibri"/>
-              </a:rPr>
-              <a:t>▪ </a:t>
-            </a:r>
-            <a:r>
-              <a:rPr sz="800" b="0">
-                <a:solidFill>
-                  <a:srgbClr val="1B2420"/>
-                </a:solidFill>
-                <a:latin typeface="Calibri"/>
-              </a:rPr>
-              <a:t>Persetujuan Menteri</a:t>
-            </a:r>
-          </a:p>
-          <a:p>
-            <a:pPr algn="l">
-              <a:spcAft>
-                <a:spcPts val="200"/>
-              </a:spcAft>
-            </a:pPr>
-            <a:r>
-              <a:rPr sz="800" b="1">
-                <a:solidFill>
-                  <a:srgbClr val="1F2A44"/>
-                </a:solidFill>
-                <a:latin typeface="Calibri"/>
-              </a:rPr>
-              <a:t>▪ </a:t>
-            </a:r>
-            <a:r>
-              <a:rPr sz="800" b="0">
-                <a:solidFill>
-                  <a:srgbClr val="1B2420"/>
-                </a:solidFill>
-                <a:latin typeface="Calibri"/>
-              </a:rPr>
-              <a:t>vPVC terbit, nomor seri</a:t>
-            </a:r>
-          </a:p>
-        </p:txBody>
-      </p:sp>
-      <p:sp>
-        <p:nvSpPr>
-          <p:cNvPr id="60" name="Rounded Rectangle 59"/>
-          <p:cNvSpPr/>
-          <p:nvPr/>
-        </p:nvSpPr>
-        <p:spPr>
-          <a:xfrm>
-            <a:off x="9283445" y="4261104"/>
-            <a:ext cx="1114425" cy="292608"/>
-          </a:xfrm>
-          <a:prstGeom prst="roundRect">
-            <a:avLst/>
-          </a:prstGeom>
-          <a:solidFill>
-            <a:srgbClr val="E6E9EF"/>
-          </a:solidFill>
-          <a:ln>
-            <a:noFill/>
-          </a:ln>
-          <a:effectLst/>
-        </p:spPr>
-        <p:txBody>
-          <a:bodyPr rtlCol="0" anchor="ctr" lIns="0" rIns="0" tIns="0" bIns="0"/>
-          <a:lstStyle/>
-          <a:p>
-            <a:pPr algn="ctr"/>
-            <a:r>
-              <a:rPr sz="750" b="1">
-                <a:solidFill>
-                  <a:srgbClr val="1F2A44"/>
-                </a:solidFill>
-                <a:latin typeface="Calibri"/>
-              </a:rPr>
-              <a:t>→ vPVC di registry</a:t>
-            </a:r>
-          </a:p>
-        </p:txBody>
-      </p:sp>
-      <p:sp>
-        <p:nvSpPr>
-          <p:cNvPr id="61" name="Oval 60"/>
-          <p:cNvSpPr/>
-          <p:nvPr/>
-        </p:nvSpPr>
-        <p:spPr>
-          <a:xfrm>
-            <a:off x="10945939" y="1883663"/>
-            <a:ext cx="438912" cy="438912"/>
-          </a:xfrm>
-          <a:prstGeom prst="ellipse">
             <a:avLst/>
           </a:prstGeom>
           <a:solidFill>
@@ -6080,657 +6759,6 @@
           <a:p>
             <a:pPr algn="ctr"/>
             <a:r>
-              <a:rPr sz="1300" b="1">
-                <a:solidFill>
-                  <a:srgbClr val="FFFFFF"/>
-                </a:solidFill>
-                <a:latin typeface="Calibri"/>
-              </a:rPr>
-              <a:t>8</a:t>
-            </a:r>
-          </a:p>
-        </p:txBody>
-      </p:sp>
-      <p:sp>
-        <p:nvSpPr>
-          <p:cNvPr id="62" name="Rectangle 61"/>
-          <p:cNvSpPr/>
-          <p:nvPr/>
-        </p:nvSpPr>
-        <p:spPr>
-          <a:xfrm>
-            <a:off x="10535030" y="2450592"/>
-            <a:ext cx="1260729" cy="2194560"/>
-          </a:xfrm>
-          <a:prstGeom prst="rect">
-            <a:avLst/>
-          </a:prstGeom>
-          <a:solidFill>
-            <a:srgbClr val="FFFFFF"/>
-          </a:solidFill>
-          <a:ln w="9525">
-            <a:solidFill>
-              <a:srgbClr val="D5DBD6"/>
-            </a:solidFill>
-          </a:ln>
-          <a:effectLst/>
-        </p:spPr>
-        <p:txBody>
-          <a:bodyPr rtlCol="0" anchor="ctr"/>
-          <a:lstStyle/>
-          <a:p>
-            <a:pPr algn="ctr"/>
-          </a:p>
-        </p:txBody>
-      </p:sp>
-      <p:sp>
-        <p:nvSpPr>
-          <p:cNvPr id="63" name="Rectangle 62"/>
-          <p:cNvSpPr/>
-          <p:nvPr/>
-        </p:nvSpPr>
-        <p:spPr>
-          <a:xfrm>
-            <a:off x="10535030" y="2450592"/>
-            <a:ext cx="1260729" cy="45720"/>
-          </a:xfrm>
-          <a:prstGeom prst="rect">
-            <a:avLst/>
-          </a:prstGeom>
-          <a:solidFill>
-            <a:srgbClr val="1F2A44"/>
-          </a:solidFill>
-          <a:ln>
-            <a:noFill/>
-          </a:ln>
-          <a:effectLst/>
-        </p:spPr>
-        <p:txBody>
-          <a:bodyPr rtlCol="0" anchor="ctr"/>
-          <a:lstStyle/>
-          <a:p>
-            <a:pPr algn="ctr"/>
-          </a:p>
-        </p:txBody>
-      </p:sp>
-      <p:sp>
-        <p:nvSpPr>
-          <p:cNvPr id="64" name="TextBox 63"/>
-          <p:cNvSpPr txBox="1"/>
-          <p:nvPr/>
-        </p:nvSpPr>
-        <p:spPr>
-          <a:xfrm>
-            <a:off x="10608182" y="2542032"/>
-            <a:ext cx="1114425" cy="411480"/>
-          </a:xfrm>
-          <a:prstGeom prst="rect">
-            <a:avLst/>
-          </a:prstGeom>
-          <a:noFill/>
-        </p:spPr>
-        <p:txBody>
-          <a:bodyPr wrap="square" lIns="18288" rIns="18288" tIns="9144" bIns="9144" anchor="t">
-            <a:spAutoFit/>
-          </a:bodyPr>
-          <a:lstStyle/>
-          <a:p>
-            <a:pPr algn="l"/>
-            <a:r>
-              <a:rPr sz="1000" b="1" i="0">
-                <a:solidFill>
-                  <a:srgbClr val="1B2420"/>
-                </a:solidFill>
-                <a:latin typeface="Calibri"/>
-              </a:rPr>
-              <a:t>Penjualan &amp; Benefit Sharing</a:t>
-            </a:r>
-          </a:p>
-        </p:txBody>
-      </p:sp>
-      <p:sp>
-        <p:nvSpPr>
-          <p:cNvPr id="65" name="TextBox 64"/>
-          <p:cNvSpPr txBox="1"/>
-          <p:nvPr/>
-        </p:nvSpPr>
-        <p:spPr>
-          <a:xfrm>
-            <a:off x="10608182" y="2962656"/>
-            <a:ext cx="1114425" cy="182880"/>
-          </a:xfrm>
-          <a:prstGeom prst="rect">
-            <a:avLst/>
-          </a:prstGeom>
-          <a:noFill/>
-        </p:spPr>
-        <p:txBody>
-          <a:bodyPr wrap="square" lIns="18288" rIns="18288" tIns="9144" bIns="9144" anchor="t">
-            <a:spAutoFit/>
-          </a:bodyPr>
-          <a:lstStyle/>
-          <a:p>
-            <a:pPr algn="l"/>
-            <a:r>
-              <a:rPr sz="700" b="1" i="0">
-                <a:solidFill>
-                  <a:srgbClr val="1F2A44"/>
-                </a:solidFill>
-                <a:latin typeface="Calibri"/>
-              </a:rPr>
-              <a:t>setelah issuance · M13</a:t>
-            </a:r>
-          </a:p>
-        </p:txBody>
-      </p:sp>
-      <p:sp>
-        <p:nvSpPr>
-          <p:cNvPr id="66" name="TextBox 65"/>
-          <p:cNvSpPr txBox="1"/>
-          <p:nvPr/>
-        </p:nvSpPr>
-        <p:spPr>
-          <a:xfrm>
-            <a:off x="10571606" y="3182112"/>
-            <a:ext cx="1169288" cy="1005840"/>
-          </a:xfrm>
-          <a:prstGeom prst="rect">
-            <a:avLst/>
-          </a:prstGeom>
-          <a:noFill/>
-        </p:spPr>
-        <p:txBody>
-          <a:bodyPr wrap="square" lIns="36576" rIns="36576" tIns="18288" bIns="18288" anchor="t">
-            <a:spAutoFit/>
-          </a:bodyPr>
-          <a:lstStyle/>
-          <a:p>
-            <a:pPr algn="l">
-              <a:spcAft>
-                <a:spcPts val="200"/>
-              </a:spcAft>
-            </a:pPr>
-            <a:r>
-              <a:rPr sz="800" b="1">
-                <a:solidFill>
-                  <a:srgbClr val="1F2A44"/>
-                </a:solidFill>
-                <a:latin typeface="Calibri"/>
-              </a:rPr>
-              <a:t>▪ </a:t>
-            </a:r>
-            <a:r>
-              <a:rPr sz="800" b="0">
-                <a:solidFill>
-                  <a:srgbClr val="1B2420"/>
-                </a:solidFill>
-                <a:latin typeface="Calibri"/>
-              </a:rPr>
-              <a:t>Realisasi offtake &amp; penjualan</a:t>
-            </a:r>
-          </a:p>
-          <a:p>
-            <a:pPr algn="l">
-              <a:spcAft>
-                <a:spcPts val="200"/>
-              </a:spcAft>
-            </a:pPr>
-            <a:r>
-              <a:rPr sz="800" b="1">
-                <a:solidFill>
-                  <a:srgbClr val="1F2A44"/>
-                </a:solidFill>
-                <a:latin typeface="Calibri"/>
-              </a:rPr>
-              <a:t>▪ </a:t>
-            </a:r>
-            <a:r>
-              <a:rPr sz="800" b="0">
-                <a:solidFill>
-                  <a:srgbClr val="1B2420"/>
-                </a:solidFill>
-                <a:latin typeface="Calibri"/>
-              </a:rPr>
-              <a:t>Otorisasi/CA bila ekspor; PNBP</a:t>
-            </a:r>
-          </a:p>
-          <a:p>
-            <a:pPr algn="l">
-              <a:spcAft>
-                <a:spcPts val="200"/>
-              </a:spcAft>
-            </a:pPr>
-            <a:r>
-              <a:rPr sz="800" b="1">
-                <a:solidFill>
-                  <a:srgbClr val="1F2A44"/>
-                </a:solidFill>
-                <a:latin typeface="Calibri"/>
-              </a:rPr>
-              <a:t>▪ </a:t>
-            </a:r>
-            <a:r>
-              <a:rPr sz="800" b="0">
-                <a:solidFill>
-                  <a:srgbClr val="1B2420"/>
-                </a:solidFill>
-                <a:latin typeface="Calibri"/>
-              </a:rPr>
-              <a:t>≥60% pendapatan ke komunitas</a:t>
-            </a:r>
-          </a:p>
-        </p:txBody>
-      </p:sp>
-      <p:sp>
-        <p:nvSpPr>
-          <p:cNvPr id="67" name="Rounded Rectangle 66"/>
-          <p:cNvSpPr/>
-          <p:nvPr/>
-        </p:nvSpPr>
-        <p:spPr>
-          <a:xfrm>
-            <a:off x="10608182" y="4261104"/>
-            <a:ext cx="1114425" cy="292608"/>
-          </a:xfrm>
-          <a:prstGeom prst="roundRect">
-            <a:avLst/>
-          </a:prstGeom>
-          <a:solidFill>
-            <a:srgbClr val="E6E9EF"/>
-          </a:solidFill>
-          <a:ln>
-            <a:noFill/>
-          </a:ln>
-          <a:effectLst/>
-        </p:spPr>
-        <p:txBody>
-          <a:bodyPr rtlCol="0" anchor="ctr" lIns="0" rIns="0" tIns="0" bIns="0"/>
-          <a:lstStyle/>
-          <a:p>
-            <a:pPr algn="ctr"/>
-            <a:r>
-              <a:rPr sz="750" b="1">
-                <a:solidFill>
-                  <a:srgbClr val="1F2A44"/>
-                </a:solidFill>
-                <a:latin typeface="Calibri"/>
-              </a:rPr>
-              <a:t>→ Pendapatan &amp; manfaat</a:t>
-            </a:r>
-          </a:p>
-        </p:txBody>
-      </p:sp>
-      <p:sp>
-        <p:nvSpPr>
-          <p:cNvPr id="68" name="TextBox 67"/>
-          <p:cNvSpPr txBox="1"/>
-          <p:nvPr/>
-        </p:nvSpPr>
-        <p:spPr>
-          <a:xfrm>
-            <a:off x="411480" y="4809744"/>
-            <a:ext cx="777240" cy="274320"/>
-          </a:xfrm>
-          <a:prstGeom prst="rect">
-            <a:avLst/>
-          </a:prstGeom>
-          <a:noFill/>
-        </p:spPr>
-        <p:txBody>
-          <a:bodyPr wrap="square" lIns="18288" rIns="18288" tIns="9144" bIns="9144" anchor="t">
-            <a:spAutoFit/>
-          </a:bodyPr>
-          <a:lstStyle/>
-          <a:p>
-            <a:pPr algn="l"/>
-            <a:r>
-              <a:rPr sz="800" b="1" i="0">
-                <a:solidFill>
-                  <a:srgbClr val="5F6B65"/>
-                </a:solidFill>
-                <a:latin typeface="Calibri"/>
-              </a:rPr>
-              <a:t>DUKUNGAN</a:t>
-            </a:r>
-          </a:p>
-        </p:txBody>
-      </p:sp>
-      <p:sp>
-        <p:nvSpPr>
-          <p:cNvPr id="69" name="Rectangle 68"/>
-          <p:cNvSpPr/>
-          <p:nvPr/>
-        </p:nvSpPr>
-        <p:spPr>
-          <a:xfrm>
-            <a:off x="1261872" y="4773168"/>
-            <a:ext cx="2585465" cy="292608"/>
-          </a:xfrm>
-          <a:prstGeom prst="rect">
-            <a:avLst/>
-          </a:prstGeom>
-          <a:solidFill>
-            <a:srgbClr val="E3F1EE"/>
-          </a:solidFill>
-          <a:ln>
-            <a:noFill/>
-          </a:ln>
-          <a:effectLst/>
-        </p:spPr>
-        <p:txBody>
-          <a:bodyPr rtlCol="0" anchor="ctr" lIns="0" rIns="0" tIns="0" bIns="0"/>
-          <a:lstStyle/>
-          <a:p>
-            <a:pPr algn="ctr"/>
-            <a:r>
-              <a:rPr sz="800" b="1">
-                <a:solidFill>
-                  <a:srgbClr val="0E7C6B"/>
-                </a:solidFill>
-                <a:latin typeface="Calibri"/>
-              </a:rPr>
-              <a:t>TAF · SETAPAK 4 — SAMPAN &amp; LPHD Pasir</a:t>
-            </a:r>
-          </a:p>
-        </p:txBody>
-      </p:sp>
-      <p:sp>
-        <p:nvSpPr>
-          <p:cNvPr id="70" name="Rectangle 69"/>
-          <p:cNvSpPr/>
-          <p:nvPr/>
-        </p:nvSpPr>
-        <p:spPr>
-          <a:xfrm>
-            <a:off x="3911346" y="4773168"/>
-            <a:ext cx="1260729" cy="292608"/>
-          </a:xfrm>
-          <a:prstGeom prst="rect">
-            <a:avLst/>
-          </a:prstGeom>
-          <a:solidFill>
-            <a:srgbClr val="FBF1E4"/>
-          </a:solidFill>
-          <a:ln>
-            <a:noFill/>
-          </a:ln>
-          <a:effectLst/>
-        </p:spPr>
-        <p:txBody>
-          <a:bodyPr rtlCol="0" anchor="ctr" lIns="0" rIns="0" tIns="0" bIns="0"/>
-          <a:lstStyle/>
-          <a:p>
-            <a:pPr algn="ctr"/>
-            <a:r>
-              <a:rPr sz="800" b="1">
-                <a:solidFill>
-                  <a:srgbClr val="C26A0A"/>
-                </a:solidFill>
-                <a:latin typeface="Calibri"/>
-              </a:rPr>
-              <a:t>Investor / offtaker</a:t>
-            </a:r>
-          </a:p>
-        </p:txBody>
-      </p:sp>
-      <p:sp>
-        <p:nvSpPr>
-          <p:cNvPr id="71" name="Rectangle 70"/>
-          <p:cNvSpPr/>
-          <p:nvPr/>
-        </p:nvSpPr>
-        <p:spPr>
-          <a:xfrm>
-            <a:off x="5236082" y="4773168"/>
-            <a:ext cx="6559676" cy="292608"/>
-          </a:xfrm>
-          <a:prstGeom prst="rect">
-            <a:avLst/>
-          </a:prstGeom>
-          <a:solidFill>
-            <a:srgbClr val="E6E9EF"/>
-          </a:solidFill>
-          <a:ln>
-            <a:noFill/>
-          </a:ln>
-          <a:effectLst/>
-        </p:spPr>
-        <p:txBody>
-          <a:bodyPr rtlCol="0" anchor="ctr" lIns="0" rIns="0" tIns="0" bIns="0"/>
-          <a:lstStyle/>
-          <a:p>
-            <a:pPr algn="ctr"/>
-            <a:r>
-              <a:rPr sz="800" b="1">
-                <a:solidFill>
-                  <a:srgbClr val="1F2A44"/>
-                </a:solidFill>
-                <a:latin typeface="Calibri"/>
-              </a:rPr>
-              <a:t>Pre-financing + pendanaan lanjutan  →  pendapatan karbon membiayai operasi</a:t>
-            </a:r>
-          </a:p>
-        </p:txBody>
-      </p:sp>
-      <p:sp>
-        <p:nvSpPr>
-          <p:cNvPr id="72" name="TextBox 71"/>
-          <p:cNvSpPr txBox="1"/>
-          <p:nvPr/>
-        </p:nvSpPr>
-        <p:spPr>
-          <a:xfrm>
-            <a:off x="411480" y="5175504"/>
-            <a:ext cx="777240" cy="274320"/>
-          </a:xfrm>
-          <a:prstGeom prst="rect">
-            <a:avLst/>
-          </a:prstGeom>
-          <a:noFill/>
-        </p:spPr>
-        <p:txBody>
-          <a:bodyPr wrap="square" lIns="18288" rIns="18288" tIns="9144" bIns="9144" anchor="t">
-            <a:spAutoFit/>
-          </a:bodyPr>
-          <a:lstStyle/>
-          <a:p>
-            <a:pPr algn="l"/>
-            <a:r>
-              <a:rPr sz="800" b="1" i="0">
-                <a:solidFill>
-                  <a:srgbClr val="5F6B65"/>
-                </a:solidFill>
-                <a:latin typeface="Calibri"/>
-              </a:rPr>
-              <a:t>UNIT KARBON</a:t>
-            </a:r>
-          </a:p>
-        </p:txBody>
-      </p:sp>
-      <p:sp>
-        <p:nvSpPr>
-          <p:cNvPr id="73" name="Rectangle 72"/>
-          <p:cNvSpPr/>
-          <p:nvPr/>
-        </p:nvSpPr>
-        <p:spPr>
-          <a:xfrm>
-            <a:off x="1261872" y="5138928"/>
-            <a:ext cx="5234940" cy="292608"/>
-          </a:xfrm>
-          <a:prstGeom prst="rect">
-            <a:avLst/>
-          </a:prstGeom>
-          <a:solidFill>
-            <a:srgbClr val="EEEFEC"/>
-          </a:solidFill>
-          <a:ln>
-            <a:noFill/>
-          </a:ln>
-          <a:effectLst/>
-        </p:spPr>
-        <p:txBody>
-          <a:bodyPr rtlCol="0" anchor="ctr" lIns="0" rIns="0" tIns="0" bIns="0"/>
-          <a:lstStyle/>
-          <a:p>
-            <a:pPr algn="ctr"/>
-            <a:r>
-              <a:rPr sz="800" b="0">
-                <a:solidFill>
-                  <a:srgbClr val="5F6B65"/>
-                </a:solidFill>
-                <a:latin typeface="Calibri"/>
-              </a:rPr>
-              <a:t>Belum ada kredit — pipeline ≠ registrasi ≠ issuance</a:t>
-            </a:r>
-          </a:p>
-        </p:txBody>
-      </p:sp>
-      <p:sp>
-        <p:nvSpPr>
-          <p:cNvPr id="74" name="Rectangle 73"/>
-          <p:cNvSpPr/>
-          <p:nvPr/>
-        </p:nvSpPr>
-        <p:spPr>
-          <a:xfrm>
-            <a:off x="6560820" y="5138928"/>
-            <a:ext cx="1260729" cy="292608"/>
-          </a:xfrm>
-          <a:prstGeom prst="rect">
-            <a:avLst/>
-          </a:prstGeom>
-          <a:solidFill>
-            <a:srgbClr val="E6E9EF"/>
-          </a:solidFill>
-          <a:ln>
-            <a:noFill/>
-          </a:ln>
-          <a:effectLst/>
-        </p:spPr>
-        <p:txBody>
-          <a:bodyPr rtlCol="0" anchor="ctr" lIns="0" rIns="0" tIns="0" bIns="0"/>
-          <a:lstStyle/>
-          <a:p>
-            <a:pPr algn="ctr"/>
-            <a:r>
-              <a:rPr sz="750" b="1">
-                <a:solidFill>
-                  <a:srgbClr val="1F2A44"/>
-                </a:solidFill>
-                <a:latin typeface="Calibri"/>
-              </a:rPr>
-              <a:t>fPVC (restorasi)</a:t>
-            </a:r>
-          </a:p>
-        </p:txBody>
-      </p:sp>
-      <p:sp>
-        <p:nvSpPr>
-          <p:cNvPr id="75" name="Rectangle 74"/>
-          <p:cNvSpPr/>
-          <p:nvPr/>
-        </p:nvSpPr>
-        <p:spPr>
-          <a:xfrm>
-            <a:off x="7885557" y="5138928"/>
-            <a:ext cx="1260729" cy="292608"/>
-          </a:xfrm>
-          <a:prstGeom prst="rect">
-            <a:avLst/>
-          </a:prstGeom>
-          <a:solidFill>
-            <a:srgbClr val="E6E9EF"/>
-          </a:solidFill>
-          <a:ln>
-            <a:noFill/>
-          </a:ln>
-          <a:effectLst/>
-        </p:spPr>
-        <p:txBody>
-          <a:bodyPr rtlCol="0" anchor="ctr" lIns="0" rIns="0" tIns="0" bIns="0"/>
-          <a:lstStyle/>
-          <a:p>
-            <a:pPr algn="ctr"/>
-            <a:r>
-              <a:rPr sz="750" b="1">
-                <a:solidFill>
-                  <a:srgbClr val="1F2A44"/>
-                </a:solidFill>
-                <a:latin typeface="Calibri"/>
-              </a:rPr>
-              <a:t>rPVC (Annual Report)</a:t>
-            </a:r>
-          </a:p>
-        </p:txBody>
-      </p:sp>
-      <p:sp>
-        <p:nvSpPr>
-          <p:cNvPr id="76" name="Rectangle 75"/>
-          <p:cNvSpPr/>
-          <p:nvPr/>
-        </p:nvSpPr>
-        <p:spPr>
-          <a:xfrm>
-            <a:off x="9210293" y="5138928"/>
-            <a:ext cx="1260729" cy="292608"/>
-          </a:xfrm>
-          <a:prstGeom prst="rect">
-            <a:avLst/>
-          </a:prstGeom>
-          <a:solidFill>
-            <a:srgbClr val="1F2A44"/>
-          </a:solidFill>
-          <a:ln>
-            <a:noFill/>
-          </a:ln>
-          <a:effectLst/>
-        </p:spPr>
-        <p:txBody>
-          <a:bodyPr rtlCol="0" anchor="ctr" lIns="0" rIns="0" tIns="0" bIns="0"/>
-          <a:lstStyle/>
-          <a:p>
-            <a:pPr algn="ctr"/>
-            <a:r>
-              <a:rPr sz="750" b="1">
-                <a:solidFill>
-                  <a:srgbClr val="FFFFFF"/>
-                </a:solidFill>
-                <a:latin typeface="Calibri"/>
-              </a:rPr>
-              <a:t>vPVC ✓ dapat di-retire</a:t>
-            </a:r>
-          </a:p>
-        </p:txBody>
-      </p:sp>
-      <p:sp>
-        <p:nvSpPr>
-          <p:cNvPr id="77" name="Rectangle 76"/>
-          <p:cNvSpPr/>
-          <p:nvPr/>
-        </p:nvSpPr>
-        <p:spPr>
-          <a:xfrm>
-            <a:off x="10535030" y="5138928"/>
-            <a:ext cx="1260729" cy="292608"/>
-          </a:xfrm>
-          <a:prstGeom prst="rect">
-            <a:avLst/>
-          </a:prstGeom>
-          <a:solidFill>
-            <a:srgbClr val="1F2A44"/>
-          </a:solidFill>
-          <a:ln>
-            <a:noFill/>
-          </a:ln>
-          <a:effectLst/>
-        </p:spPr>
-        <p:txBody>
-          <a:bodyPr rtlCol="0" anchor="ctr" lIns="0" rIns="0" tIns="0" bIns="0"/>
-          <a:lstStyle/>
-          <a:p>
-            <a:pPr algn="ctr"/>
-            <a:r>
               <a:rPr sz="750" b="1">
                 <a:solidFill>
                   <a:srgbClr val="FFFFFF"/>
@@ -6744,7 +6772,7 @@
       </p:sp>
       <p:cxnSp>
         <p:nvCxnSpPr>
-          <p:cNvPr id="78" name="Connector 77"/>
+          <p:cNvPr id="79" name="Connector 78"/>
           <p:cNvCxnSpPr/>
           <p:nvPr/>
         </p:nvCxnSpPr>
@@ -6779,7 +6807,7 @@
       </p:cxnSp>
       <p:sp>
         <p:nvSpPr>
-          <p:cNvPr id="79" name="TextBox 78"/>
+          <p:cNvPr id="80" name="TextBox 79"/>
           <p:cNvSpPr txBox="1"/>
           <p:nvPr/>
         </p:nvSpPr>
@@ -6814,7 +6842,7 @@
       </p:sp>
       <p:sp>
         <p:nvSpPr>
-          <p:cNvPr id="80" name="TextBox 79"/>
+          <p:cNvPr id="81" name="TextBox 80"/>
           <p:cNvSpPr txBox="1"/>
           <p:nvPr/>
         </p:nvSpPr>
@@ -6849,7 +6877,7 @@
       </p:sp>
       <p:sp>
         <p:nvSpPr>
-          <p:cNvPr id="81" name="TextBox 80"/>
+          <p:cNvPr id="82" name="TextBox 81"/>
           <p:cNvSpPr txBox="1"/>
           <p:nvPr/>
         </p:nvSpPr>
@@ -6873,7 +6901,7 @@
             <a:r>
               <a:rPr sz="2000" b="1" i="0">
                 <a:solidFill>
-                  <a:srgbClr val="C26A0A"/>
+                  <a:srgbClr val="0E7C6B"/>
                 </a:solidFill>
                 <a:latin typeface="Cambria"/>
               </a:rPr>
@@ -6884,7 +6912,7 @@
       </p:sp>
       <p:sp>
         <p:nvSpPr>
-          <p:cNvPr id="82" name="TextBox 81"/>
+          <p:cNvPr id="83" name="TextBox 82"/>
           <p:cNvSpPr txBox="1"/>
           <p:nvPr/>
         </p:nvSpPr>
@@ -6912,14 +6940,14 @@
                 </a:solidFill>
                 <a:latin typeface="Calibri"/>
               </a:rPr>
-              <a:t>Target masuk pipeline · akhir TAF</a:t>
-            </a:r>
-          </a:p>
-        </p:txBody>
-      </p:sp>
-      <p:sp>
-        <p:nvSpPr>
-          <p:cNvPr id="83" name="TextBox 82"/>
+              <a:t>Masuk Pipeline PV — output utama SETAPAK 4</a:t>
+            </a:r>
+          </a:p>
+        </p:txBody>
+      </p:sp>
+      <p:sp>
+        <p:nvSpPr>
+          <p:cNvPr id="84" name="TextBox 83"/>
           <p:cNvSpPr txBox="1"/>
           <p:nvPr/>
         </p:nvSpPr>
@@ -6954,7 +6982,7 @@
       </p:sp>
       <p:sp>
         <p:nvSpPr>
-          <p:cNvPr id="84" name="TextBox 83"/>
+          <p:cNvPr id="85" name="TextBox 84"/>
           <p:cNvSpPr txBox="1"/>
           <p:nvPr/>
         </p:nvSpPr>
@@ -6989,7 +7017,7 @@
       </p:sp>
       <p:sp>
         <p:nvSpPr>
-          <p:cNvPr id="85" name="TextBox 84"/>
+          <p:cNvPr id="86" name="TextBox 85"/>
           <p:cNvSpPr txBox="1"/>
           <p:nvPr/>
         </p:nvSpPr>
@@ -7024,7 +7052,7 @@
       </p:sp>
       <p:sp>
         <p:nvSpPr>
-          <p:cNvPr id="86" name="TextBox 85"/>
+          <p:cNvPr id="87" name="TextBox 86"/>
           <p:cNvSpPr txBox="1"/>
           <p:nvPr/>
         </p:nvSpPr>
@@ -7059,7 +7087,7 @@
       </p:sp>
       <p:sp>
         <p:nvSpPr>
-          <p:cNvPr id="87" name="Oval 86"/>
+          <p:cNvPr id="88" name="Oval 87"/>
           <p:cNvSpPr/>
           <p:nvPr/>
         </p:nvSpPr>
@@ -7089,7 +7117,7 @@
       </p:sp>
       <p:sp>
         <p:nvSpPr>
-          <p:cNvPr id="88" name="TextBox 87"/>
+          <p:cNvPr id="89" name="TextBox 88"/>
           <p:cNvSpPr txBox="1"/>
           <p:nvPr/>
         </p:nvSpPr>
@@ -7124,7 +7152,7 @@
       </p:sp>
       <p:sp>
         <p:nvSpPr>
-          <p:cNvPr id="89" name="Diamond 88"/>
+          <p:cNvPr id="90" name="Diamond 89"/>
           <p:cNvSpPr/>
           <p:nvPr/>
         </p:nvSpPr>
@@ -7156,7 +7184,7 @@
       </p:sp>
       <p:sp>
         <p:nvSpPr>
-          <p:cNvPr id="90" name="TextBox 89"/>
+          <p:cNvPr id="91" name="TextBox 90"/>
           <p:cNvSpPr txBox="1"/>
           <p:nvPr/>
         </p:nvSpPr>
@@ -7191,7 +7219,7 @@
       </p:sp>
       <p:cxnSp>
         <p:nvCxnSpPr>
-          <p:cNvPr id="91" name="Connector 90"/>
+          <p:cNvPr id="92" name="Connector 91"/>
           <p:cNvCxnSpPr/>
           <p:nvPr/>
         </p:nvCxnSpPr>
@@ -7227,7 +7255,7 @@
       </p:cxnSp>
       <p:sp>
         <p:nvSpPr>
-          <p:cNvPr id="92" name="TextBox 91"/>
+          <p:cNvPr id="93" name="TextBox 92"/>
           <p:cNvSpPr txBox="1"/>
           <p:nvPr/>
         </p:nvSpPr>
@@ -7262,7 +7290,7 @@
       </p:sp>
       <p:sp>
         <p:nvSpPr>
-          <p:cNvPr id="93" name="TextBox 92"/>
+          <p:cNvPr id="94" name="TextBox 93"/>
           <p:cNvSpPr txBox="1"/>
           <p:nvPr/>
         </p:nvSpPr>

</xml_diff>

<commit_message>
Switch slides to Open Sauce Sans and bundle the font (OFL)
Co-Authored-By: Claude Opus 5.5 <noreply@anthropic.com>
Claude-Session: https://claude.ai/code/session_01Tt9bQwcKRKX4vaP5NybJqL
</commit_message>
<xml_diff>
--- a/hutan-desa-pasir/Roadmap_1Slide_HD_Pasir.pptx
+++ b/hutan-desa-pasir/Roadmap_1Slide_HD_Pasir.pptx
@@ -3566,7 +3566,7 @@
                 <a:solidFill>
                   <a:srgbClr val="0E7C6B"/>
                 </a:solidFill>
-                <a:latin typeface="Calibri"/>
+                <a:latin typeface="Open Sauce Sans"/>
               </a:rPr>
               <a:t>COMMUNITY CARBON HUTAN DESA PASIR · MEMPAWAH, KALIMANTAN BARAT · PLAN VIVO PV CLIMATE</a:t>
             </a:r>
@@ -3601,7 +3601,7 @@
                 <a:solidFill>
                   <a:srgbClr val="1B2420"/>
                 </a:solidFill>
-                <a:latin typeface="Cambria"/>
+                <a:latin typeface="Open Sauce Sans"/>
               </a:rPr>
               <a:t>SETAPAK 4 berakhir dengan proyek masuk Pipeline Plan Vivo — status ini</a:t>
             </a:r>
@@ -3613,7 +3613,7 @@
                 <a:solidFill>
                   <a:srgbClr val="1B2420"/>
                 </a:solidFill>
-                <a:latin typeface="Cambria"/>
+                <a:latin typeface="Open Sauce Sans"/>
               </a:rPr>
               <a:t>membuka investasi untuk PDD, validasi, hingga penjualan kredit karbon</a:t>
             </a:r>
@@ -3628,8 +3628,8 @@
         </p:nvSpPr>
         <p:spPr>
           <a:xfrm>
-            <a:off x="1261872" y="1481328"/>
-            <a:ext cx="3910203" cy="292608"/>
+            <a:off x="1188720" y="1481328"/>
+            <a:ext cx="3953637" cy="292608"/>
           </a:xfrm>
           <a:prstGeom prst="rect">
             <a:avLst/>
@@ -3652,7 +3652,7 @@
                 <a:solidFill>
                   <a:srgbClr val="FFFFFF"/>
                 </a:solidFill>
-                <a:latin typeface="Calibri"/>
+                <a:latin typeface="Open Sauce Sans"/>
               </a:rPr>
               <a:t>STEP 1 · PROGRAM SETAPAK 4 (TAF) · Okt 2026 – Sep 2027</a:t>
             </a:r>
@@ -3667,8 +3667,8 @@
         </p:nvSpPr>
         <p:spPr>
           <a:xfrm>
-            <a:off x="5236082" y="1481328"/>
-            <a:ext cx="6559676" cy="292608"/>
+            <a:off x="5197221" y="1481328"/>
+            <a:ext cx="6625971" cy="292608"/>
           </a:xfrm>
           <a:prstGeom prst="rect">
             <a:avLst/>
@@ -3691,7 +3691,7 @@
                 <a:solidFill>
                   <a:srgbClr val="FFFFFF"/>
                 </a:solidFill>
-                <a:latin typeface="Calibri"/>
+                <a:latin typeface="Open Sauce Sans"/>
               </a:rPr>
               <a:t>STEP 2 · PENGEMBANGAN LANJUTAN (PASCA-SETAPAK 4) · Okt 2027 →</a:t>
             </a:r>
@@ -3706,8 +3706,8 @@
         </p:nvCxnSpPr>
         <p:spPr>
           <a:xfrm>
-            <a:off x="1892236" y="2103120"/>
-            <a:ext cx="3311842" cy="0"/>
+            <a:off x="1829371" y="2103120"/>
+            <a:ext cx="3340418" cy="0"/>
           </a:xfrm>
           <a:prstGeom prst="line">
             <a:avLst/>
@@ -3741,8 +3741,8 @@
         </p:nvCxnSpPr>
         <p:spPr>
           <a:xfrm>
-            <a:off x="5204078" y="2103120"/>
-            <a:ext cx="5961317" cy="0"/>
+            <a:off x="5169789" y="2103120"/>
+            <a:ext cx="6012751" cy="0"/>
           </a:xfrm>
           <a:prstGeom prst="line">
             <a:avLst/>
@@ -3796,7 +3796,7 @@
                 <a:solidFill>
                   <a:srgbClr val="5F6B65"/>
                 </a:solidFill>
-                <a:latin typeface="Calibri"/>
+                <a:latin typeface="Open Sauce Sans"/>
               </a:rPr>
               <a:t>TAHAP</a:t>
             </a:r>
@@ -3811,7 +3811,7 @@
         </p:nvCxnSpPr>
         <p:spPr>
           <a:xfrm>
-            <a:off x="5204078" y="1426464"/>
+            <a:off x="5169789" y="1426464"/>
             <a:ext cx="0" cy="4059936"/>
           </a:xfrm>
           <a:prstGeom prst="line">
@@ -3847,7 +3847,7 @@
         </p:nvSpPr>
         <p:spPr>
           <a:xfrm>
-            <a:off x="3741038" y="1234440"/>
+            <a:off x="3706748" y="1234440"/>
             <a:ext cx="2926080" cy="201168"/>
           </a:xfrm>
           <a:prstGeom prst="rect">
@@ -3867,7 +3867,7 @@
                 <a:solidFill>
                   <a:srgbClr val="C26A0A"/>
                 </a:solidFill>
-                <a:latin typeface="Calibri"/>
+                <a:latin typeface="Open Sauce Sans"/>
               </a:rPr>
               <a:t>▼ GERBANG PIPELINE · AKHIR SETAPAK 4</a:t>
             </a:r>
@@ -3882,7 +3882,7 @@
         </p:nvSpPr>
         <p:spPr>
           <a:xfrm>
-            <a:off x="1672780" y="1883663"/>
+            <a:off x="1609915" y="1883663"/>
             <a:ext cx="438912" cy="438912"/>
           </a:xfrm>
           <a:prstGeom prst="ellipse">
@@ -3906,7 +3906,7 @@
                 <a:solidFill>
                   <a:srgbClr val="FFFFFF"/>
                 </a:solidFill>
-                <a:latin typeface="Calibri"/>
+                <a:latin typeface="Open Sauce Sans"/>
               </a:rPr>
               <a:t>1</a:t>
             </a:r>
@@ -3921,8 +3921,8 @@
         </p:nvSpPr>
         <p:spPr>
           <a:xfrm>
-            <a:off x="1261872" y="2450592"/>
-            <a:ext cx="1260729" cy="2194560"/>
+            <a:off x="1188720" y="2450592"/>
+            <a:ext cx="1281303" cy="2194560"/>
           </a:xfrm>
           <a:prstGeom prst="rect">
             <a:avLst/>
@@ -3953,8 +3953,8 @@
         </p:nvSpPr>
         <p:spPr>
           <a:xfrm>
-            <a:off x="1261872" y="2450592"/>
-            <a:ext cx="1260729" cy="45720"/>
+            <a:off x="1188720" y="2450592"/>
+            <a:ext cx="1281303" cy="45720"/>
           </a:xfrm>
           <a:prstGeom prst="rect">
             <a:avLst/>
@@ -3983,8 +3983,8 @@
         </p:nvSpPr>
         <p:spPr>
           <a:xfrm>
-            <a:off x="1335024" y="2542032"/>
-            <a:ext cx="1114425" cy="411480"/>
+            <a:off x="1261872" y="2542032"/>
+            <a:ext cx="1134999" cy="411480"/>
           </a:xfrm>
           <a:prstGeom prst="rect">
             <a:avLst/>
@@ -3999,11 +3999,11 @@
           <a:p>
             <a:pPr algn="l"/>
             <a:r>
-              <a:rPr sz="1000" b="1" i="0">
+              <a:rPr sz="950" b="1" i="0">
                 <a:solidFill>
                   <a:srgbClr val="1B2420"/>
                 </a:solidFill>
-                <a:latin typeface="Calibri"/>
+                <a:latin typeface="Open Sauce Sans"/>
               </a:rPr>
               <a:t>Persiapan Pendaftaran PIN</a:t>
             </a:r>
@@ -4018,8 +4018,8 @@
         </p:nvSpPr>
         <p:spPr>
           <a:xfrm>
-            <a:off x="1335024" y="2962656"/>
-            <a:ext cx="1114425" cy="182880"/>
+            <a:off x="1261872" y="2962656"/>
+            <a:ext cx="1134999" cy="182880"/>
           </a:xfrm>
           <a:prstGeom prst="rect">
             <a:avLst/>
@@ -4034,13 +4034,13 @@
           <a:p>
             <a:pPr algn="l"/>
             <a:r>
-              <a:rPr sz="700" b="1" i="0">
+              <a:rPr sz="650" b="1" i="0">
                 <a:solidFill>
                   <a:srgbClr val="0E7C6B"/>
                 </a:solidFill>
-                <a:latin typeface="Calibri"/>
-              </a:rPr>
-              <a:t>Okt 26 – Apr 27 · M1–M5</a:t>
+                <a:latin typeface="Open Sauce Sans"/>
+              </a:rPr>
+              <a:t>Okt 26–Apr 27 · M1–M5</a:t>
             </a:r>
           </a:p>
         </p:txBody>
@@ -4053,8 +4053,8 @@
         </p:nvSpPr>
         <p:spPr>
           <a:xfrm>
-            <a:off x="1298448" y="3182112"/>
-            <a:ext cx="1169288" cy="1005840"/>
+            <a:off x="1225296" y="3182112"/>
+            <a:ext cx="1189862" cy="1005840"/>
           </a:xfrm>
           <a:prstGeom prst="rect">
             <a:avLst/>
@@ -4073,22 +4073,22 @@
               </a:spcAft>
             </a:pPr>
             <a:r>
-              <a:rPr sz="800" b="1">
+              <a:rPr sz="750" b="1">
                 <a:solidFill>
                   <a:srgbClr val="0E7C6B"/>
                 </a:solidFill>
-                <a:latin typeface="Calibri"/>
-              </a:rPr>
-              <a:t>▪ </a:t>
-            </a:r>
-            <a:r>
-              <a:rPr sz="800" b="0">
+                <a:latin typeface="Open Sauce Sans"/>
+              </a:rPr>
+              <a:t>• </a:t>
+            </a:r>
+            <a:r>
+              <a:rPr sz="750" b="0">
                 <a:solidFill>
                   <a:srgbClr val="1B2420"/>
                 </a:solidFill>
-                <a:latin typeface="Calibri"/>
-              </a:rPr>
-              <a:t>Safeguard: FPIC i–ii, GRM, E&amp;S, GESI</a:t>
+                <a:latin typeface="Open Sauce Sans"/>
+              </a:rPr>
+              <a:t>Safeguard: FPIC, GRM, E&amp;S, GESI</a:t>
             </a:r>
           </a:p>
           <a:p>
@@ -4098,22 +4098,22 @@
               </a:spcAft>
             </a:pPr>
             <a:r>
-              <a:rPr sz="800" b="1">
+              <a:rPr sz="750" b="1">
                 <a:solidFill>
                   <a:srgbClr val="0E7C6B"/>
                 </a:solidFill>
-                <a:latin typeface="Calibri"/>
-              </a:rPr>
-              <a:t>▪ </a:t>
-            </a:r>
-            <a:r>
-              <a:rPr sz="800" b="0">
+                <a:latin typeface="Open Sauce Sans"/>
+              </a:rPr>
+              <a:t>• </a:t>
+            </a:r>
+            <a:r>
+              <a:rPr sz="750" b="0">
                 <a:solidFill>
                   <a:srgbClr val="1B2420"/>
                 </a:solidFill>
-                <a:latin typeface="Calibri"/>
-              </a:rPr>
-              <a:t>Kebutuhan &amp; progres yang sudah berjalan</a:t>
+                <a:latin typeface="Open Sauce Sans"/>
+              </a:rPr>
+              <a:t>Kebutuhan &amp; progres berjalan</a:t>
             </a:r>
           </a:p>
           <a:p>
@@ -4123,22 +4123,22 @@
               </a:spcAft>
             </a:pPr>
             <a:r>
-              <a:rPr sz="800" b="1">
+              <a:rPr sz="750" b="1">
                 <a:solidFill>
                   <a:srgbClr val="0E7C6B"/>
                 </a:solidFill>
-                <a:latin typeface="Calibri"/>
-              </a:rPr>
-              <a:t>▪ </a:t>
-            </a:r>
-            <a:r>
-              <a:rPr sz="800" b="0">
+                <a:latin typeface="Open Sauce Sans"/>
+              </a:rPr>
+              <a:t>• </a:t>
+            </a:r>
+            <a:r>
+              <a:rPr sz="750" b="0">
                 <a:solidFill>
                   <a:srgbClr val="1B2420"/>
                 </a:solidFill>
-                <a:latin typeface="Calibri"/>
-              </a:rPr>
-              <a:t>Baseline via PV tools → project scenario</a:t>
+                <a:latin typeface="Open Sauce Sans"/>
+              </a:rPr>
+              <a:t>Baseline (PV tools) → project scenario</a:t>
             </a:r>
           </a:p>
         </p:txBody>
@@ -4151,8 +4151,8 @@
         </p:nvSpPr>
         <p:spPr>
           <a:xfrm>
-            <a:off x="1335024" y="4261104"/>
-            <a:ext cx="1114425" cy="292608"/>
+            <a:off x="1261872" y="4261104"/>
+            <a:ext cx="1134999" cy="292608"/>
           </a:xfrm>
           <a:prstGeom prst="roundRect">
             <a:avLst/>
@@ -4171,11 +4171,11 @@
           <a:p>
             <a:pPr algn="ctr"/>
             <a:r>
-              <a:rPr sz="750" b="1">
+              <a:rPr sz="700" b="1">
                 <a:solidFill>
                   <a:srgbClr val="0E7C6B"/>
                 </a:solidFill>
-                <a:latin typeface="Calibri"/>
+                <a:latin typeface="Open Sauce Sans"/>
               </a:rPr>
               <a:t>→ Bahan PIN lengkap</a:t>
             </a:r>
@@ -4190,7 +4190,7 @@
         </p:nvSpPr>
         <p:spPr>
           <a:xfrm>
-            <a:off x="2970085" y="1856231"/>
+            <a:off x="2918650" y="1856231"/>
             <a:ext cx="493776" cy="493776"/>
           </a:xfrm>
           <a:prstGeom prst="diamond">
@@ -4216,7 +4216,7 @@
                 <a:solidFill>
                   <a:srgbClr val="0E7C6B"/>
                 </a:solidFill>
-                <a:latin typeface="Calibri"/>
+                <a:latin typeface="Open Sauce Sans"/>
               </a:rPr>
               <a:t>2</a:t>
             </a:r>
@@ -4231,8 +4231,8 @@
         </p:nvSpPr>
         <p:spPr>
           <a:xfrm>
-            <a:off x="2586609" y="2450592"/>
-            <a:ext cx="1260729" cy="2194560"/>
+            <a:off x="2524887" y="2450592"/>
+            <a:ext cx="1281303" cy="2194560"/>
           </a:xfrm>
           <a:prstGeom prst="rect">
             <a:avLst/>
@@ -4263,8 +4263,8 @@
         </p:nvSpPr>
         <p:spPr>
           <a:xfrm>
-            <a:off x="2586609" y="2450592"/>
-            <a:ext cx="1260729" cy="45720"/>
+            <a:off x="2524887" y="2450592"/>
+            <a:ext cx="1281303" cy="45720"/>
           </a:xfrm>
           <a:prstGeom prst="rect">
             <a:avLst/>
@@ -4293,8 +4293,8 @@
         </p:nvSpPr>
         <p:spPr>
           <a:xfrm>
-            <a:off x="2659761" y="2542032"/>
-            <a:ext cx="1114425" cy="411480"/>
+            <a:off x="2598039" y="2542032"/>
+            <a:ext cx="1134999" cy="411480"/>
           </a:xfrm>
           <a:prstGeom prst="rect">
             <a:avLst/>
@@ -4309,11 +4309,11 @@
           <a:p>
             <a:pPr algn="l"/>
             <a:r>
-              <a:rPr sz="1000" b="1" i="0">
+              <a:rPr sz="950" b="1" i="0">
                 <a:solidFill>
                   <a:srgbClr val="1B2420"/>
                 </a:solidFill>
-                <a:latin typeface="Calibri"/>
+                <a:latin typeface="Open Sauce Sans"/>
               </a:rPr>
               <a:t>Submit PIN hingga Approval</a:t>
             </a:r>
@@ -4328,8 +4328,8 @@
         </p:nvSpPr>
         <p:spPr>
           <a:xfrm>
-            <a:off x="2659761" y="2962656"/>
-            <a:ext cx="1114425" cy="182880"/>
+            <a:off x="2598039" y="2962656"/>
+            <a:ext cx="1134999" cy="182880"/>
           </a:xfrm>
           <a:prstGeom prst="rect">
             <a:avLst/>
@@ -4344,13 +4344,13 @@
           <a:p>
             <a:pPr algn="l"/>
             <a:r>
-              <a:rPr sz="700" b="1" i="0">
+              <a:rPr sz="650" b="1" i="0">
                 <a:solidFill>
                   <a:srgbClr val="0E7C6B"/>
                 </a:solidFill>
-                <a:latin typeface="Calibri"/>
-              </a:rPr>
-              <a:t>Mar – Sep 27 · M6–M7</a:t>
+                <a:latin typeface="Open Sauce Sans"/>
+              </a:rPr>
+              <a:t>Mar–Sep 27 · M6–M7</a:t>
             </a:r>
           </a:p>
         </p:txBody>
@@ -4363,8 +4363,8 @@
         </p:nvSpPr>
         <p:spPr>
           <a:xfrm>
-            <a:off x="2623185" y="3182112"/>
-            <a:ext cx="1169288" cy="1005840"/>
+            <a:off x="2561463" y="3182112"/>
+            <a:ext cx="1189862" cy="1005840"/>
           </a:xfrm>
           <a:prstGeom prst="rect">
             <a:avLst/>
@@ -4383,20 +4383,20 @@
               </a:spcAft>
             </a:pPr>
             <a:r>
-              <a:rPr sz="800" b="1">
+              <a:rPr sz="750" b="1">
                 <a:solidFill>
                   <a:srgbClr val="0E7C6B"/>
                 </a:solidFill>
-                <a:latin typeface="Calibri"/>
-              </a:rPr>
-              <a:t>▪ </a:t>
-            </a:r>
-            <a:r>
-              <a:rPr sz="800" b="0">
+                <a:latin typeface="Open Sauce Sans"/>
+              </a:rPr>
+              <a:t>• </a:t>
+            </a:r>
+            <a:r>
+              <a:rPr sz="750" b="0">
                 <a:solidFill>
                   <a:srgbClr val="1B2420"/>
                 </a:solidFill>
-                <a:latin typeface="Calibri"/>
+                <a:latin typeface="Open Sauce Sans"/>
               </a:rPr>
               <a:t>PIN Template V1.4</a:t>
             </a:r>
@@ -4408,20 +4408,20 @@
               </a:spcAft>
             </a:pPr>
             <a:r>
-              <a:rPr sz="800" b="1">
+              <a:rPr sz="750" b="1">
                 <a:solidFill>
                   <a:srgbClr val="0E7C6B"/>
                 </a:solidFill>
-                <a:latin typeface="Calibri"/>
-              </a:rPr>
-              <a:t>▪ </a:t>
-            </a:r>
-            <a:r>
-              <a:rPr sz="800" b="0">
+                <a:latin typeface="Open Sauce Sans"/>
+              </a:rPr>
+              <a:t>• </a:t>
+            </a:r>
+            <a:r>
+              <a:rPr sz="750" b="0">
                 <a:solidFill>
                   <a:srgbClr val="1B2420"/>
                 </a:solidFill>
-                <a:latin typeface="Calibri"/>
+                <a:latin typeface="Open Sauce Sans"/>
               </a:rPr>
               <a:t>Submit ≤ Mei 2027</a:t>
             </a:r>
@@ -4433,20 +4433,20 @@
               </a:spcAft>
             </a:pPr>
             <a:r>
-              <a:rPr sz="800" b="1">
+              <a:rPr sz="750" b="1">
                 <a:solidFill>
                   <a:srgbClr val="0E7C6B"/>
                 </a:solidFill>
-                <a:latin typeface="Calibri"/>
-              </a:rPr>
-              <a:t>▪ </a:t>
-            </a:r>
-            <a:r>
-              <a:rPr sz="800" b="0">
+                <a:latin typeface="Open Sauce Sans"/>
+              </a:rPr>
+              <a:t>• </a:t>
+            </a:r>
+            <a:r>
+              <a:rPr sz="750" b="0">
                 <a:solidFill>
                   <a:srgbClr val="1B2420"/>
                 </a:solidFill>
-                <a:latin typeface="Calibri"/>
+                <a:latin typeface="Open Sauce Sans"/>
               </a:rPr>
               <a:t>Review CAR/NIR, maks. 3 putaran</a:t>
             </a:r>
@@ -4461,8 +4461,8 @@
         </p:nvSpPr>
         <p:spPr>
           <a:xfrm>
-            <a:off x="2659761" y="4261104"/>
-            <a:ext cx="1114425" cy="292608"/>
+            <a:off x="2598039" y="4261104"/>
+            <a:ext cx="1134999" cy="292608"/>
           </a:xfrm>
           <a:prstGeom prst="roundRect">
             <a:avLst/>
@@ -4481,11 +4481,11 @@
           <a:p>
             <a:pPr algn="ctr"/>
             <a:r>
-              <a:rPr sz="750" b="1">
+              <a:rPr sz="700" b="1">
                 <a:solidFill>
                   <a:srgbClr val="0E7C6B"/>
                 </a:solidFill>
-                <a:latin typeface="Calibri"/>
+                <a:latin typeface="Open Sauce Sans"/>
               </a:rPr>
               <a:t>→ PIN disetujui</a:t>
             </a:r>
@@ -4500,7 +4500,7 @@
         </p:nvSpPr>
         <p:spPr>
           <a:xfrm>
-            <a:off x="4230814" y="1792223"/>
+            <a:off x="4190809" y="1792223"/>
             <a:ext cx="621792" cy="621792"/>
           </a:xfrm>
           <a:prstGeom prst="ellipse">
@@ -4532,7 +4532,7 @@
         </p:nvSpPr>
         <p:spPr>
           <a:xfrm>
-            <a:off x="4303966" y="1865376"/>
+            <a:off x="4263961" y="1865376"/>
             <a:ext cx="475488" cy="475488"/>
           </a:xfrm>
           <a:prstGeom prst="ellipse">
@@ -4556,7 +4556,7 @@
                 <a:solidFill>
                   <a:srgbClr val="FFFFFF"/>
                 </a:solidFill>
-                <a:latin typeface="Calibri"/>
+                <a:latin typeface="Open Sauce Sans"/>
               </a:rPr>
               <a:t>3</a:t>
             </a:r>
@@ -4571,8 +4571,8 @@
         </p:nvSpPr>
         <p:spPr>
           <a:xfrm>
-            <a:off x="3911346" y="2450592"/>
-            <a:ext cx="1260729" cy="2194560"/>
+            <a:off x="3861054" y="2450592"/>
+            <a:ext cx="1281303" cy="2194560"/>
           </a:xfrm>
           <a:prstGeom prst="rect">
             <a:avLst/>
@@ -4603,8 +4603,8 @@
         </p:nvSpPr>
         <p:spPr>
           <a:xfrm>
-            <a:off x="3911346" y="2450592"/>
-            <a:ext cx="1260729" cy="45720"/>
+            <a:off x="3861054" y="2450592"/>
+            <a:ext cx="1281303" cy="45720"/>
           </a:xfrm>
           <a:prstGeom prst="rect">
             <a:avLst/>
@@ -4633,8 +4633,8 @@
         </p:nvSpPr>
         <p:spPr>
           <a:xfrm>
-            <a:off x="4021074" y="2331720"/>
-            <a:ext cx="1041272" cy="219456"/>
+            <a:off x="3970782" y="2331720"/>
+            <a:ext cx="1061847" cy="219456"/>
           </a:xfrm>
           <a:prstGeom prst="roundRect">
             <a:avLst/>
@@ -4657,7 +4657,7 @@
                 <a:solidFill>
                   <a:srgbClr val="FFFFFF"/>
                 </a:solidFill>
-                <a:latin typeface="Calibri"/>
+                <a:latin typeface="Open Sauce Sans"/>
               </a:rPr>
               <a:t>★ OUTPUT UTAMA</a:t>
             </a:r>
@@ -4672,8 +4672,8 @@
         </p:nvSpPr>
         <p:spPr>
           <a:xfrm>
-            <a:off x="3984498" y="2542032"/>
-            <a:ext cx="1114425" cy="411480"/>
+            <a:off x="3934206" y="2542032"/>
+            <a:ext cx="1134999" cy="411480"/>
           </a:xfrm>
           <a:prstGeom prst="rect">
             <a:avLst/>
@@ -4688,11 +4688,11 @@
           <a:p>
             <a:pPr algn="l"/>
             <a:r>
-              <a:rPr sz="1000" b="1" i="0">
+              <a:rPr sz="950" b="1" i="0">
                 <a:solidFill>
                   <a:srgbClr val="1B2420"/>
                 </a:solidFill>
-                <a:latin typeface="Calibri"/>
+                <a:latin typeface="Open Sauce Sans"/>
               </a:rPr>
               <a:t>Masuk</a:t>
             </a:r>
@@ -4700,11 +4700,11 @@
           <a:p>
             <a:pPr algn="l"/>
             <a:r>
-              <a:rPr sz="1000" b="1" i="0">
+              <a:rPr sz="950" b="1" i="0">
                 <a:solidFill>
                   <a:srgbClr val="1B2420"/>
                 </a:solidFill>
-                <a:latin typeface="Calibri"/>
+                <a:latin typeface="Open Sauce Sans"/>
               </a:rPr>
               <a:t>Pipeline PV</a:t>
             </a:r>
@@ -4719,8 +4719,8 @@
         </p:nvSpPr>
         <p:spPr>
           <a:xfrm>
-            <a:off x="3984498" y="2962656"/>
-            <a:ext cx="1114425" cy="182880"/>
+            <a:off x="3934206" y="2962656"/>
+            <a:ext cx="1134999" cy="182880"/>
           </a:xfrm>
           <a:prstGeom prst="rect">
             <a:avLst/>
@@ -4735,11 +4735,11 @@
           <a:p>
             <a:pPr algn="l"/>
             <a:r>
-              <a:rPr sz="700" b="1" i="0">
+              <a:rPr sz="650" b="1" i="0">
                 <a:solidFill>
                   <a:srgbClr val="0E7C6B"/>
                 </a:solidFill>
-                <a:latin typeface="Calibri"/>
+                <a:latin typeface="Open Sauce Sans"/>
               </a:rPr>
               <a:t>Sep 2027 · M7.5 · M8</a:t>
             </a:r>
@@ -4754,8 +4754,8 @@
         </p:nvSpPr>
         <p:spPr>
           <a:xfrm>
-            <a:off x="3947922" y="3182112"/>
-            <a:ext cx="1169288" cy="1005840"/>
+            <a:off x="3897630" y="3182112"/>
+            <a:ext cx="1189862" cy="1005840"/>
           </a:xfrm>
           <a:prstGeom prst="rect">
             <a:avLst/>
@@ -4774,22 +4774,22 @@
               </a:spcAft>
             </a:pPr>
             <a:r>
-              <a:rPr sz="800" b="1">
+              <a:rPr sz="750" b="1">
                 <a:solidFill>
                   <a:srgbClr val="0E7C6B"/>
                 </a:solidFill>
-                <a:latin typeface="Calibri"/>
-              </a:rPr>
-              <a:t>▪ </a:t>
-            </a:r>
-            <a:r>
-              <a:rPr sz="800" b="0">
+                <a:latin typeface="Open Sauce Sans"/>
+              </a:rPr>
+              <a:t>• </a:t>
+            </a:r>
+            <a:r>
+              <a:rPr sz="750" b="0">
                 <a:solidFill>
                   <a:srgbClr val="1B2420"/>
                 </a:solidFill>
-                <a:latin typeface="Calibri"/>
-              </a:rPr>
-              <a:t>PIN dipublikasikan di pipeline Plan Vivo</a:t>
+                <a:latin typeface="Open Sauce Sans"/>
+              </a:rPr>
+              <a:t>PIN tayang di pipeline Plan Vivo</a:t>
             </a:r>
           </a:p>
           <a:p>
@@ -4799,20 +4799,20 @@
               </a:spcAft>
             </a:pPr>
             <a:r>
-              <a:rPr sz="800" b="1">
+              <a:rPr sz="750" b="1">
                 <a:solidFill>
                   <a:srgbClr val="0E7C6B"/>
                 </a:solidFill>
-                <a:latin typeface="Calibri"/>
-              </a:rPr>
-              <a:t>▪ </a:t>
-            </a:r>
-            <a:r>
-              <a:rPr sz="800" b="0">
+                <a:latin typeface="Open Sauce Sans"/>
+              </a:rPr>
+              <a:t>• </a:t>
+            </a:r>
+            <a:r>
+              <a:rPr sz="750" b="0">
                 <a:solidFill>
                   <a:srgbClr val="1B2420"/>
                 </a:solidFill>
-                <a:latin typeface="Calibri"/>
+                <a:latin typeface="Open Sauce Sans"/>
               </a:rPr>
               <a:t>Profil proyek &amp; penjajakan investor</a:t>
             </a:r>
@@ -4824,22 +4824,22 @@
               </a:spcAft>
             </a:pPr>
             <a:r>
-              <a:rPr sz="800" b="1">
+              <a:rPr sz="750" b="1">
                 <a:solidFill>
                   <a:srgbClr val="0E7C6B"/>
                 </a:solidFill>
-                <a:latin typeface="Calibri"/>
-              </a:rPr>
-              <a:t>▪ </a:t>
-            </a:r>
-            <a:r>
-              <a:rPr sz="800" b="0">
+                <a:latin typeface="Open Sauce Sans"/>
+              </a:rPr>
+              <a:t>• </a:t>
+            </a:r>
+            <a:r>
+              <a:rPr sz="750" b="0">
                 <a:solidFill>
                   <a:srgbClr val="1B2420"/>
                 </a:solidFill>
-                <a:latin typeface="Calibri"/>
-              </a:rPr>
-              <a:t>Pendamping teregistrasi (Permenhut 6/2026)</a:t>
+                <a:latin typeface="Open Sauce Sans"/>
+              </a:rPr>
+              <a:t>Pendamping teregistrasi</a:t>
             </a:r>
           </a:p>
         </p:txBody>
@@ -4852,8 +4852,8 @@
         </p:nvSpPr>
         <p:spPr>
           <a:xfrm>
-            <a:off x="3984498" y="4261104"/>
-            <a:ext cx="1114425" cy="292608"/>
+            <a:off x="3934206" y="4261104"/>
+            <a:ext cx="1134999" cy="292608"/>
           </a:xfrm>
           <a:prstGeom prst="roundRect">
             <a:avLst/>
@@ -4872,13 +4872,13 @@
           <a:p>
             <a:pPr algn="ctr"/>
             <a:r>
-              <a:rPr sz="750" b="1">
+              <a:rPr sz="700" b="1">
                 <a:solidFill>
                   <a:srgbClr val="FFFFFF"/>
                 </a:solidFill>
-                <a:latin typeface="Calibri"/>
-              </a:rPr>
-              <a:t>→ Proyek di Pipeline PV</a:t>
+                <a:latin typeface="Open Sauce Sans"/>
+              </a:rPr>
+              <a:t>→ Proyek di Pipeline</a:t>
             </a:r>
           </a:p>
         </p:txBody>
@@ -4891,7 +4891,7 @@
         </p:nvSpPr>
         <p:spPr>
           <a:xfrm>
-            <a:off x="5646991" y="1883663"/>
+            <a:off x="5618416" y="1883663"/>
             <a:ext cx="438912" cy="438912"/>
           </a:xfrm>
           <a:prstGeom prst="ellipse">
@@ -4915,7 +4915,7 @@
                 <a:solidFill>
                   <a:srgbClr val="FFFFFF"/>
                 </a:solidFill>
-                <a:latin typeface="Calibri"/>
+                <a:latin typeface="Open Sauce Sans"/>
               </a:rPr>
               <a:t>4</a:t>
             </a:r>
@@ -4930,8 +4930,8 @@
         </p:nvSpPr>
         <p:spPr>
           <a:xfrm>
-            <a:off x="5236082" y="2450592"/>
-            <a:ext cx="1260729" cy="2194560"/>
+            <a:off x="5197221" y="2450592"/>
+            <a:ext cx="1281303" cy="2194560"/>
           </a:xfrm>
           <a:prstGeom prst="rect">
             <a:avLst/>
@@ -4962,8 +4962,8 @@
         </p:nvSpPr>
         <p:spPr>
           <a:xfrm>
-            <a:off x="5236082" y="2450592"/>
-            <a:ext cx="1260729" cy="45720"/>
+            <a:off x="5197221" y="2450592"/>
+            <a:ext cx="1281303" cy="45720"/>
           </a:xfrm>
           <a:prstGeom prst="rect">
             <a:avLst/>
@@ -4992,8 +4992,8 @@
         </p:nvSpPr>
         <p:spPr>
           <a:xfrm>
-            <a:off x="5309234" y="2542032"/>
-            <a:ext cx="1114425" cy="411480"/>
+            <a:off x="5270373" y="2542032"/>
+            <a:ext cx="1134999" cy="411480"/>
           </a:xfrm>
           <a:prstGeom prst="rect">
             <a:avLst/>
@@ -5008,11 +5008,11 @@
           <a:p>
             <a:pPr algn="l"/>
             <a:r>
-              <a:rPr sz="1000" b="1" i="0">
+              <a:rPr sz="950" b="1" i="0">
                 <a:solidFill>
                   <a:srgbClr val="1B2420"/>
                 </a:solidFill>
-                <a:latin typeface="Calibri"/>
+                <a:latin typeface="Open Sauce Sans"/>
               </a:rPr>
               <a:t>Penyusunan PDD</a:t>
             </a:r>
@@ -5027,8 +5027,8 @@
         </p:nvSpPr>
         <p:spPr>
           <a:xfrm>
-            <a:off x="5309234" y="2962656"/>
-            <a:ext cx="1114425" cy="182880"/>
+            <a:off x="5270373" y="2962656"/>
+            <a:ext cx="1134999" cy="182880"/>
           </a:xfrm>
           <a:prstGeom prst="rect">
             <a:avLst/>
@@ -5043,11 +5043,11 @@
           <a:p>
             <a:pPr algn="l"/>
             <a:r>
-              <a:rPr sz="700" b="1" i="0">
+              <a:rPr sz="650" b="1" i="0">
                 <a:solidFill>
                   <a:srgbClr val="1F2A44"/>
                 </a:solidFill>
-                <a:latin typeface="Calibri"/>
+                <a:latin typeface="Open Sauce Sans"/>
               </a:rPr>
               <a:t>2027 – 2029 · M9</a:t>
             </a:r>
@@ -5062,8 +5062,8 @@
         </p:nvSpPr>
         <p:spPr>
           <a:xfrm>
-            <a:off x="5272658" y="3182112"/>
-            <a:ext cx="1169288" cy="1005840"/>
+            <a:off x="5233797" y="3182112"/>
+            <a:ext cx="1189862" cy="1005840"/>
           </a:xfrm>
           <a:prstGeom prst="rect">
             <a:avLst/>
@@ -5082,20 +5082,20 @@
               </a:spcAft>
             </a:pPr>
             <a:r>
-              <a:rPr sz="800" b="1">
+              <a:rPr sz="750" b="1">
                 <a:solidFill>
                   <a:srgbClr val="1F2A44"/>
                 </a:solidFill>
-                <a:latin typeface="Calibri"/>
-              </a:rPr>
-              <a:t>▪ </a:t>
-            </a:r>
-            <a:r>
-              <a:rPr sz="800" b="0">
+                <a:latin typeface="Open Sauce Sans"/>
+              </a:rPr>
+              <a:t>• </a:t>
+            </a:r>
+            <a:r>
+              <a:rPr sz="750" b="0">
                 <a:solidFill>
                   <a:srgbClr val="1B2420"/>
                 </a:solidFill>
-                <a:latin typeface="Calibri"/>
+                <a:latin typeface="Open Sauce Sans"/>
               </a:rPr>
               <a:t>Pre-financing investor / offtaker</a:t>
             </a:r>
@@ -5107,20 +5107,20 @@
               </a:spcAft>
             </a:pPr>
             <a:r>
-              <a:rPr sz="800" b="1">
+              <a:rPr sz="750" b="1">
                 <a:solidFill>
                   <a:srgbClr val="1F2A44"/>
                 </a:solidFill>
-                <a:latin typeface="Calibri"/>
-              </a:rPr>
-              <a:t>▪ </a:t>
-            </a:r>
-            <a:r>
-              <a:rPr sz="800" b="0">
+                <a:latin typeface="Open Sauce Sans"/>
+              </a:rPr>
+              <a:t>• </a:t>
+            </a:r>
+            <a:r>
+              <a:rPr sz="750" b="0">
                 <a:solidFill>
                   <a:srgbClr val="1B2420"/>
                 </a:solidFill>
-                <a:latin typeface="Calibri"/>
+                <a:latin typeface="Open Sauce Sans"/>
               </a:rPr>
               <a:t>Metodologi disetujui Plan Vivo</a:t>
             </a:r>
@@ -5132,20 +5132,20 @@
               </a:spcAft>
             </a:pPr>
             <a:r>
-              <a:rPr sz="800" b="1">
+              <a:rPr sz="750" b="1">
                 <a:solidFill>
                   <a:srgbClr val="1F2A44"/>
                 </a:solidFill>
-                <a:latin typeface="Calibri"/>
-              </a:rPr>
-              <a:t>▪ </a:t>
-            </a:r>
-            <a:r>
-              <a:rPr sz="800" b="0">
+                <a:latin typeface="Open Sauce Sans"/>
+              </a:rPr>
+              <a:t>• </a:t>
+            </a:r>
+            <a:r>
+              <a:rPr sz="750" b="0">
                 <a:solidFill>
                   <a:srgbClr val="1B2420"/>
                 </a:solidFill>
-                <a:latin typeface="Calibri"/>
+                <a:latin typeface="Open Sauce Sans"/>
               </a:rPr>
               <a:t>Stok karbon, baseline, PDD review</a:t>
             </a:r>
@@ -5160,8 +5160,8 @@
         </p:nvSpPr>
         <p:spPr>
           <a:xfrm>
-            <a:off x="5309234" y="4261104"/>
-            <a:ext cx="1114425" cy="292608"/>
+            <a:off x="5270373" y="4261104"/>
+            <a:ext cx="1134999" cy="292608"/>
           </a:xfrm>
           <a:prstGeom prst="roundRect">
             <a:avLst/>
@@ -5180,11 +5180,11 @@
           <a:p>
             <a:pPr algn="ctr"/>
             <a:r>
-              <a:rPr sz="750" b="1">
+              <a:rPr sz="700" b="1">
                 <a:solidFill>
                   <a:srgbClr val="1F2A44"/>
                 </a:solidFill>
-                <a:latin typeface="Calibri"/>
+                <a:latin typeface="Open Sauce Sans"/>
               </a:rPr>
               <a:t>→ PDD lolos review</a:t>
             </a:r>
@@ -5199,7 +5199,7 @@
         </p:nvSpPr>
         <p:spPr>
           <a:xfrm>
-            <a:off x="6944296" y="1856231"/>
+            <a:off x="6927151" y="1856231"/>
             <a:ext cx="493776" cy="493776"/>
           </a:xfrm>
           <a:prstGeom prst="diamond">
@@ -5225,7 +5225,7 @@
                 <a:solidFill>
                   <a:srgbClr val="1F2A44"/>
                 </a:solidFill>
-                <a:latin typeface="Calibri"/>
+                <a:latin typeface="Open Sauce Sans"/>
               </a:rPr>
               <a:t>5</a:t>
             </a:r>
@@ -5240,8 +5240,8 @@
         </p:nvSpPr>
         <p:spPr>
           <a:xfrm>
-            <a:off x="6560820" y="2450592"/>
-            <a:ext cx="1260729" cy="2194560"/>
+            <a:off x="6533388" y="2450592"/>
+            <a:ext cx="1281303" cy="2194560"/>
           </a:xfrm>
           <a:prstGeom prst="rect">
             <a:avLst/>
@@ -5272,8 +5272,8 @@
         </p:nvSpPr>
         <p:spPr>
           <a:xfrm>
-            <a:off x="6560820" y="2450592"/>
-            <a:ext cx="1260729" cy="45720"/>
+            <a:off x="6533388" y="2450592"/>
+            <a:ext cx="1281303" cy="45720"/>
           </a:xfrm>
           <a:prstGeom prst="rect">
             <a:avLst/>
@@ -5302,8 +5302,8 @@
         </p:nvSpPr>
         <p:spPr>
           <a:xfrm>
-            <a:off x="6633972" y="2542032"/>
-            <a:ext cx="1114425" cy="411480"/>
+            <a:off x="6606540" y="2542032"/>
+            <a:ext cx="1134999" cy="411480"/>
           </a:xfrm>
           <a:prstGeom prst="rect">
             <a:avLst/>
@@ -5318,11 +5318,11 @@
           <a:p>
             <a:pPr algn="l"/>
             <a:r>
-              <a:rPr sz="1000" b="1" i="0">
+              <a:rPr sz="950" b="1" i="0">
                 <a:solidFill>
                   <a:srgbClr val="1B2420"/>
                 </a:solidFill>
-                <a:latin typeface="Calibri"/>
+                <a:latin typeface="Open Sauce Sans"/>
               </a:rPr>
               <a:t>Validasi &amp; Registrasi</a:t>
             </a:r>
@@ -5337,8 +5337,8 @@
         </p:nvSpPr>
         <p:spPr>
           <a:xfrm>
-            <a:off x="6633972" y="2962656"/>
-            <a:ext cx="1114425" cy="182880"/>
+            <a:off x="6606540" y="2962656"/>
+            <a:ext cx="1134999" cy="182880"/>
           </a:xfrm>
           <a:prstGeom prst="rect">
             <a:avLst/>
@@ -5353,11 +5353,11 @@
           <a:p>
             <a:pPr algn="l"/>
             <a:r>
-              <a:rPr sz="700" b="1" i="0">
+              <a:rPr sz="650" b="1" i="0">
                 <a:solidFill>
                   <a:srgbClr val="1F2A44"/>
                 </a:solidFill>
-                <a:latin typeface="Calibri"/>
+                <a:latin typeface="Open Sauce Sans"/>
               </a:rPr>
               <a:t>2029 – 2030 · M10</a:t>
             </a:r>
@@ -5372,8 +5372,8 @@
         </p:nvSpPr>
         <p:spPr>
           <a:xfrm>
-            <a:off x="6597396" y="3182112"/>
-            <a:ext cx="1169288" cy="1005840"/>
+            <a:off x="6569964" y="3182112"/>
+            <a:ext cx="1189862" cy="1005840"/>
           </a:xfrm>
           <a:prstGeom prst="rect">
             <a:avLst/>
@@ -5392,20 +5392,20 @@
               </a:spcAft>
             </a:pPr>
             <a:r>
-              <a:rPr sz="800" b="1">
+              <a:rPr sz="750" b="1">
                 <a:solidFill>
                   <a:srgbClr val="1F2A44"/>
                 </a:solidFill>
-                <a:latin typeface="Calibri"/>
-              </a:rPr>
-              <a:t>▪ </a:t>
-            </a:r>
-            <a:r>
-              <a:rPr sz="800" b="0">
+                <a:latin typeface="Open Sauce Sans"/>
+              </a:rPr>
+              <a:t>• </a:t>
+            </a:r>
+            <a:r>
+              <a:rPr sz="750" b="0">
                 <a:solidFill>
                   <a:srgbClr val="1B2420"/>
                 </a:solidFill>
-                <a:latin typeface="Calibri"/>
+                <a:latin typeface="Open Sauce Sans"/>
               </a:rPr>
               <a:t>DPP tercatat di Kemenhut</a:t>
             </a:r>
@@ -5417,20 +5417,20 @@
               </a:spcAft>
             </a:pPr>
             <a:r>
-              <a:rPr sz="800" b="1">
+              <a:rPr sz="750" b="1">
                 <a:solidFill>
                   <a:srgbClr val="1F2A44"/>
                 </a:solidFill>
-                <a:latin typeface="Calibri"/>
-              </a:rPr>
-              <a:t>▪ </a:t>
-            </a:r>
-            <a:r>
-              <a:rPr sz="800" b="0">
+                <a:latin typeface="Open Sauce Sans"/>
+              </a:rPr>
+              <a:t>• </a:t>
+            </a:r>
+            <a:r>
+              <a:rPr sz="750" b="0">
                 <a:solidFill>
                   <a:srgbClr val="1B2420"/>
                 </a:solidFill>
-                <a:latin typeface="Calibri"/>
+                <a:latin typeface="Open Sauce Sans"/>
               </a:rPr>
               <a:t>Audit VVB / microscale IE</a:t>
             </a:r>
@@ -5442,20 +5442,20 @@
               </a:spcAft>
             </a:pPr>
             <a:r>
-              <a:rPr sz="800" b="1">
+              <a:rPr sz="750" b="1">
                 <a:solidFill>
                   <a:srgbClr val="1F2A44"/>
                 </a:solidFill>
-                <a:latin typeface="Calibri"/>
-              </a:rPr>
-              <a:t>▪ </a:t>
-            </a:r>
-            <a:r>
-              <a:rPr sz="800" b="0">
+                <a:latin typeface="Open Sauce Sans"/>
+              </a:rPr>
+              <a:t>• </a:t>
+            </a:r>
+            <a:r>
+              <a:rPr sz="750" b="0">
                 <a:solidFill>
                   <a:srgbClr val="1B2420"/>
                 </a:solidFill>
-                <a:latin typeface="Calibri"/>
+                <a:latin typeface="Open Sauce Sans"/>
               </a:rPr>
               <a:t>MoU &amp; PV Climate Registry</a:t>
             </a:r>
@@ -5470,8 +5470,8 @@
         </p:nvSpPr>
         <p:spPr>
           <a:xfrm>
-            <a:off x="6633972" y="4261104"/>
-            <a:ext cx="1114425" cy="292608"/>
+            <a:off x="6606540" y="4261104"/>
+            <a:ext cx="1134999" cy="292608"/>
           </a:xfrm>
           <a:prstGeom prst="roundRect">
             <a:avLst/>
@@ -5490,11 +5490,11 @@
           <a:p>
             <a:pPr algn="ctr"/>
             <a:r>
-              <a:rPr sz="750" b="1">
+              <a:rPr sz="700" b="1">
                 <a:solidFill>
                   <a:srgbClr val="1F2A44"/>
                 </a:solidFill>
-                <a:latin typeface="Calibri"/>
+                <a:latin typeface="Open Sauce Sans"/>
               </a:rPr>
               <a:t>→ Proyek terdaftar</a:t>
             </a:r>
@@ -5509,7 +5509,7 @@
         </p:nvSpPr>
         <p:spPr>
           <a:xfrm>
-            <a:off x="8296465" y="1883663"/>
+            <a:off x="8290750" y="1883663"/>
             <a:ext cx="438912" cy="438912"/>
           </a:xfrm>
           <a:prstGeom prst="ellipse">
@@ -5533,7 +5533,7 @@
                 <a:solidFill>
                   <a:srgbClr val="FFFFFF"/>
                 </a:solidFill>
-                <a:latin typeface="Calibri"/>
+                <a:latin typeface="Open Sauce Sans"/>
               </a:rPr>
               <a:t>6</a:t>
             </a:r>
@@ -5548,8 +5548,8 @@
         </p:nvSpPr>
         <p:spPr>
           <a:xfrm>
-            <a:off x="7885557" y="2450592"/>
-            <a:ext cx="1260729" cy="2194560"/>
+            <a:off x="7869554" y="2450592"/>
+            <a:ext cx="1281303" cy="2194560"/>
           </a:xfrm>
           <a:prstGeom prst="rect">
             <a:avLst/>
@@ -5580,8 +5580,8 @@
         </p:nvSpPr>
         <p:spPr>
           <a:xfrm>
-            <a:off x="7885557" y="2450592"/>
-            <a:ext cx="1260729" cy="45720"/>
+            <a:off x="7869554" y="2450592"/>
+            <a:ext cx="1281303" cy="45720"/>
           </a:xfrm>
           <a:prstGeom prst="rect">
             <a:avLst/>
@@ -5610,8 +5610,8 @@
         </p:nvSpPr>
         <p:spPr>
           <a:xfrm>
-            <a:off x="7958709" y="2542032"/>
-            <a:ext cx="1114425" cy="411480"/>
+            <a:off x="7942706" y="2542032"/>
+            <a:ext cx="1134999" cy="411480"/>
           </a:xfrm>
           <a:prstGeom prst="rect">
             <a:avLst/>
@@ -5626,11 +5626,11 @@
           <a:p>
             <a:pPr algn="l"/>
             <a:r>
-              <a:rPr sz="1000" b="1" i="0">
+              <a:rPr sz="950" b="1" i="0">
                 <a:solidFill>
                   <a:srgbClr val="1B2420"/>
                 </a:solidFill>
-                <a:latin typeface="Calibri"/>
+                <a:latin typeface="Open Sauce Sans"/>
               </a:rPr>
               <a:t>Implementasi &amp; Monitoring</a:t>
             </a:r>
@@ -5645,8 +5645,8 @@
         </p:nvSpPr>
         <p:spPr>
           <a:xfrm>
-            <a:off x="7958709" y="2962656"/>
-            <a:ext cx="1114425" cy="182880"/>
+            <a:off x="7942706" y="2962656"/>
+            <a:ext cx="1134999" cy="182880"/>
           </a:xfrm>
           <a:prstGeom prst="rect">
             <a:avLst/>
@@ -5661,11 +5661,11 @@
           <a:p>
             <a:pPr algn="l"/>
             <a:r>
-              <a:rPr sz="700" b="1" i="0">
+              <a:rPr sz="650" b="1" i="0">
                 <a:solidFill>
                   <a:srgbClr val="1F2A44"/>
                 </a:solidFill>
-                <a:latin typeface="Calibri"/>
+                <a:latin typeface="Open Sauce Sans"/>
               </a:rPr>
               <a:t>2030 → · M11</a:t>
             </a:r>
@@ -5680,8 +5680,8 @@
         </p:nvSpPr>
         <p:spPr>
           <a:xfrm>
-            <a:off x="7922133" y="3182112"/>
-            <a:ext cx="1169288" cy="1005840"/>
+            <a:off x="7906130" y="3182112"/>
+            <a:ext cx="1189862" cy="1005840"/>
           </a:xfrm>
           <a:prstGeom prst="rect">
             <a:avLst/>
@@ -5700,20 +5700,20 @@
               </a:spcAft>
             </a:pPr>
             <a:r>
-              <a:rPr sz="800" b="1">
+              <a:rPr sz="750" b="1">
                 <a:solidFill>
                   <a:srgbClr val="1F2A44"/>
                 </a:solidFill>
-                <a:latin typeface="Calibri"/>
-              </a:rPr>
-              <a:t>▪ </a:t>
-            </a:r>
-            <a:r>
-              <a:rPr sz="800" b="0">
+                <a:latin typeface="Open Sauce Sans"/>
+              </a:rPr>
+              <a:t>• </a:t>
+            </a:r>
+            <a:r>
+              <a:rPr sz="750" b="0">
                 <a:solidFill>
                   <a:srgbClr val="1B2420"/>
                 </a:solidFill>
-                <a:latin typeface="Calibri"/>
+                <a:latin typeface="Open Sauce Sans"/>
               </a:rPr>
               <a:t>Perlindungan &amp; restorasi</a:t>
             </a:r>
@@ -5725,20 +5725,20 @@
               </a:spcAft>
             </a:pPr>
             <a:r>
-              <a:rPr sz="800" b="1">
+              <a:rPr sz="750" b="1">
                 <a:solidFill>
                   <a:srgbClr val="1F2A44"/>
                 </a:solidFill>
-                <a:latin typeface="Calibri"/>
-              </a:rPr>
-              <a:t>▪ </a:t>
-            </a:r>
-            <a:r>
-              <a:rPr sz="800" b="0">
+                <a:latin typeface="Open Sauce Sans"/>
+              </a:rPr>
+              <a:t>• </a:t>
+            </a:r>
+            <a:r>
+              <a:rPr sz="750" b="0">
                 <a:solidFill>
                   <a:srgbClr val="1B2420"/>
                 </a:solidFill>
-                <a:latin typeface="Calibri"/>
+                <a:latin typeface="Open Sauce Sans"/>
               </a:rPr>
               <a:t>Livelihood KUPS &amp; WFD</a:t>
             </a:r>
@@ -5750,20 +5750,20 @@
               </a:spcAft>
             </a:pPr>
             <a:r>
-              <a:rPr sz="800" b="1">
+              <a:rPr sz="750" b="1">
                 <a:solidFill>
                   <a:srgbClr val="1F2A44"/>
                 </a:solidFill>
-                <a:latin typeface="Calibri"/>
-              </a:rPr>
-              <a:t>▪ </a:t>
-            </a:r>
-            <a:r>
-              <a:rPr sz="800" b="0">
+                <a:latin typeface="Open Sauce Sans"/>
+              </a:rPr>
+              <a:t>• </a:t>
+            </a:r>
+            <a:r>
+              <a:rPr sz="750" b="0">
                 <a:solidFill>
                   <a:srgbClr val="1B2420"/>
                 </a:solidFill>
-                <a:latin typeface="Calibri"/>
+                <a:latin typeface="Open Sauce Sans"/>
               </a:rPr>
               <a:t>Annual Report tiap 12 bln</a:t>
             </a:r>
@@ -5778,8 +5778,8 @@
         </p:nvSpPr>
         <p:spPr>
           <a:xfrm>
-            <a:off x="7958709" y="4261104"/>
-            <a:ext cx="1114425" cy="292608"/>
+            <a:off x="7942706" y="4261104"/>
+            <a:ext cx="1134999" cy="292608"/>
           </a:xfrm>
           <a:prstGeom prst="roundRect">
             <a:avLst/>
@@ -5798,11 +5798,11 @@
           <a:p>
             <a:pPr algn="ctr"/>
             <a:r>
-              <a:rPr sz="750" b="1">
+              <a:rPr sz="700" b="1">
                 <a:solidFill>
                   <a:srgbClr val="1F2A44"/>
                 </a:solidFill>
-                <a:latin typeface="Calibri"/>
+                <a:latin typeface="Open Sauce Sans"/>
               </a:rPr>
               <a:t>→ Data monitoring</a:t>
             </a:r>
@@ -5817,7 +5817,7 @@
         </p:nvSpPr>
         <p:spPr>
           <a:xfrm>
-            <a:off x="9593770" y="1856231"/>
+            <a:off x="9599485" y="1856231"/>
             <a:ext cx="493776" cy="493776"/>
           </a:xfrm>
           <a:prstGeom prst="diamond">
@@ -5843,7 +5843,7 @@
                 <a:solidFill>
                   <a:srgbClr val="1F2A44"/>
                 </a:solidFill>
-                <a:latin typeface="Calibri"/>
+                <a:latin typeface="Open Sauce Sans"/>
               </a:rPr>
               <a:t>7</a:t>
             </a:r>
@@ -5858,8 +5858,8 @@
         </p:nvSpPr>
         <p:spPr>
           <a:xfrm>
-            <a:off x="9210293" y="2450592"/>
-            <a:ext cx="1260729" cy="2194560"/>
+            <a:off x="9205722" y="2450592"/>
+            <a:ext cx="1281303" cy="2194560"/>
           </a:xfrm>
           <a:prstGeom prst="rect">
             <a:avLst/>
@@ -5890,8 +5890,8 @@
         </p:nvSpPr>
         <p:spPr>
           <a:xfrm>
-            <a:off x="9210293" y="2450592"/>
-            <a:ext cx="1260729" cy="45720"/>
+            <a:off x="9205722" y="2450592"/>
+            <a:ext cx="1281303" cy="45720"/>
           </a:xfrm>
           <a:prstGeom prst="rect">
             <a:avLst/>
@@ -5920,8 +5920,8 @@
         </p:nvSpPr>
         <p:spPr>
           <a:xfrm>
-            <a:off x="9283445" y="2542032"/>
-            <a:ext cx="1114425" cy="411480"/>
+            <a:off x="9278874" y="2542032"/>
+            <a:ext cx="1134999" cy="411480"/>
           </a:xfrm>
           <a:prstGeom prst="rect">
             <a:avLst/>
@@ -5936,11 +5936,11 @@
           <a:p>
             <a:pPr algn="l"/>
             <a:r>
-              <a:rPr sz="1000" b="1" i="0">
+              <a:rPr sz="950" b="1" i="0">
                 <a:solidFill>
                   <a:srgbClr val="1B2420"/>
                 </a:solidFill>
-                <a:latin typeface="Calibri"/>
+                <a:latin typeface="Open Sauce Sans"/>
               </a:rPr>
               <a:t>Verifikasi &amp; Issuance</a:t>
             </a:r>
@@ -5955,8 +5955,8 @@
         </p:nvSpPr>
         <p:spPr>
           <a:xfrm>
-            <a:off x="9283445" y="2962656"/>
-            <a:ext cx="1114425" cy="182880"/>
+            <a:off x="9278874" y="2962656"/>
+            <a:ext cx="1134999" cy="182880"/>
           </a:xfrm>
           <a:prstGeom prst="rect">
             <a:avLst/>
@@ -5971,11 +5971,11 @@
           <a:p>
             <a:pPr algn="l"/>
             <a:r>
-              <a:rPr sz="700" b="1" i="0">
+              <a:rPr sz="650" b="1" i="0">
                 <a:solidFill>
                   <a:srgbClr val="1F2A44"/>
                 </a:solidFill>
-                <a:latin typeface="Calibri"/>
+                <a:latin typeface="Open Sauce Sans"/>
               </a:rPr>
               <a:t>≤5 th pasca-validasi · M12</a:t>
             </a:r>
@@ -5990,8 +5990,8 @@
         </p:nvSpPr>
         <p:spPr>
           <a:xfrm>
-            <a:off x="9246869" y="3182112"/>
-            <a:ext cx="1169288" cy="1005840"/>
+            <a:off x="9242298" y="3182112"/>
+            <a:ext cx="1189862" cy="1005840"/>
           </a:xfrm>
           <a:prstGeom prst="rect">
             <a:avLst/>
@@ -6010,20 +6010,20 @@
               </a:spcAft>
             </a:pPr>
             <a:r>
-              <a:rPr sz="800" b="1">
+              <a:rPr sz="750" b="1">
                 <a:solidFill>
                   <a:srgbClr val="1F2A44"/>
                 </a:solidFill>
-                <a:latin typeface="Calibri"/>
-              </a:rPr>
-              <a:t>▪ </a:t>
-            </a:r>
-            <a:r>
-              <a:rPr sz="800" b="0">
+                <a:latin typeface="Open Sauce Sans"/>
+              </a:rPr>
+              <a:t>• </a:t>
+            </a:r>
+            <a:r>
+              <a:rPr sz="750" b="0">
                 <a:solidFill>
                   <a:srgbClr val="1B2420"/>
                 </a:solidFill>
-                <a:latin typeface="Calibri"/>
+                <a:latin typeface="Open Sauce Sans"/>
               </a:rPr>
               <a:t>Audit verifikasi ≤5 th</a:t>
             </a:r>
@@ -6035,20 +6035,20 @@
               </a:spcAft>
             </a:pPr>
             <a:r>
-              <a:rPr sz="800" b="1">
+              <a:rPr sz="750" b="1">
                 <a:solidFill>
                   <a:srgbClr val="1F2A44"/>
                 </a:solidFill>
-                <a:latin typeface="Calibri"/>
-              </a:rPr>
-              <a:t>▪ </a:t>
-            </a:r>
-            <a:r>
-              <a:rPr sz="800" b="0">
+                <a:latin typeface="Open Sauce Sans"/>
+              </a:rPr>
+              <a:t>• </a:t>
+            </a:r>
+            <a:r>
+              <a:rPr sz="750" b="0">
                 <a:solidFill>
                   <a:srgbClr val="1B2420"/>
                 </a:solidFill>
-                <a:latin typeface="Calibri"/>
+                <a:latin typeface="Open Sauce Sans"/>
               </a:rPr>
               <a:t>Persetujuan Menteri</a:t>
             </a:r>
@@ -6060,20 +6060,20 @@
               </a:spcAft>
             </a:pPr>
             <a:r>
-              <a:rPr sz="800" b="1">
+              <a:rPr sz="750" b="1">
                 <a:solidFill>
                   <a:srgbClr val="1F2A44"/>
                 </a:solidFill>
-                <a:latin typeface="Calibri"/>
-              </a:rPr>
-              <a:t>▪ </a:t>
-            </a:r>
-            <a:r>
-              <a:rPr sz="800" b="0">
+                <a:latin typeface="Open Sauce Sans"/>
+              </a:rPr>
+              <a:t>• </a:t>
+            </a:r>
+            <a:r>
+              <a:rPr sz="750" b="0">
                 <a:solidFill>
                   <a:srgbClr val="1B2420"/>
                 </a:solidFill>
-                <a:latin typeface="Calibri"/>
+                <a:latin typeface="Open Sauce Sans"/>
               </a:rPr>
               <a:t>vPVC terbit, nomor seri</a:t>
             </a:r>
@@ -6088,8 +6088,8 @@
         </p:nvSpPr>
         <p:spPr>
           <a:xfrm>
-            <a:off x="9283445" y="4261104"/>
-            <a:ext cx="1114425" cy="292608"/>
+            <a:off x="9278874" y="4261104"/>
+            <a:ext cx="1134999" cy="292608"/>
           </a:xfrm>
           <a:prstGeom prst="roundRect">
             <a:avLst/>
@@ -6108,11 +6108,11 @@
           <a:p>
             <a:pPr algn="ctr"/>
             <a:r>
-              <a:rPr sz="750" b="1">
+              <a:rPr sz="700" b="1">
                 <a:solidFill>
                   <a:srgbClr val="1F2A44"/>
                 </a:solidFill>
-                <a:latin typeface="Calibri"/>
+                <a:latin typeface="Open Sauce Sans"/>
               </a:rPr>
               <a:t>→ vPVC di registry</a:t>
             </a:r>
@@ -6127,7 +6127,7 @@
         </p:nvSpPr>
         <p:spPr>
           <a:xfrm>
-            <a:off x="10945939" y="1883663"/>
+            <a:off x="10963084" y="1883663"/>
             <a:ext cx="438912" cy="438912"/>
           </a:xfrm>
           <a:prstGeom prst="ellipse">
@@ -6151,7 +6151,7 @@
                 <a:solidFill>
                   <a:srgbClr val="FFFFFF"/>
                 </a:solidFill>
-                <a:latin typeface="Calibri"/>
+                <a:latin typeface="Open Sauce Sans"/>
               </a:rPr>
               <a:t>8</a:t>
             </a:r>
@@ -6166,8 +6166,8 @@
         </p:nvSpPr>
         <p:spPr>
           <a:xfrm>
-            <a:off x="10535030" y="2450592"/>
-            <a:ext cx="1260729" cy="2194560"/>
+            <a:off x="10541889" y="2450592"/>
+            <a:ext cx="1281303" cy="2194560"/>
           </a:xfrm>
           <a:prstGeom prst="rect">
             <a:avLst/>
@@ -6198,8 +6198,8 @@
         </p:nvSpPr>
         <p:spPr>
           <a:xfrm>
-            <a:off x="10535030" y="2450592"/>
-            <a:ext cx="1260729" cy="45720"/>
+            <a:off x="10541889" y="2450592"/>
+            <a:ext cx="1281303" cy="45720"/>
           </a:xfrm>
           <a:prstGeom prst="rect">
             <a:avLst/>
@@ -6228,8 +6228,8 @@
         </p:nvSpPr>
         <p:spPr>
           <a:xfrm>
-            <a:off x="10608182" y="2542032"/>
-            <a:ext cx="1114425" cy="411480"/>
+            <a:off x="10615041" y="2542032"/>
+            <a:ext cx="1134999" cy="411480"/>
           </a:xfrm>
           <a:prstGeom prst="rect">
             <a:avLst/>
@@ -6244,11 +6244,11 @@
           <a:p>
             <a:pPr algn="l"/>
             <a:r>
-              <a:rPr sz="1000" b="1" i="0">
+              <a:rPr sz="950" b="1" i="0">
                 <a:solidFill>
                   <a:srgbClr val="1B2420"/>
                 </a:solidFill>
-                <a:latin typeface="Calibri"/>
+                <a:latin typeface="Open Sauce Sans"/>
               </a:rPr>
               <a:t>Penjualan &amp; Benefit Sharing</a:t>
             </a:r>
@@ -6263,8 +6263,8 @@
         </p:nvSpPr>
         <p:spPr>
           <a:xfrm>
-            <a:off x="10608182" y="2962656"/>
-            <a:ext cx="1114425" cy="182880"/>
+            <a:off x="10615041" y="2962656"/>
+            <a:ext cx="1134999" cy="182880"/>
           </a:xfrm>
           <a:prstGeom prst="rect">
             <a:avLst/>
@@ -6279,11 +6279,11 @@
           <a:p>
             <a:pPr algn="l"/>
             <a:r>
-              <a:rPr sz="700" b="1" i="0">
+              <a:rPr sz="650" b="1" i="0">
                 <a:solidFill>
                   <a:srgbClr val="1F2A44"/>
                 </a:solidFill>
-                <a:latin typeface="Calibri"/>
+                <a:latin typeface="Open Sauce Sans"/>
               </a:rPr>
               <a:t>setelah issuance · M13</a:t>
             </a:r>
@@ -6298,8 +6298,8 @@
         </p:nvSpPr>
         <p:spPr>
           <a:xfrm>
-            <a:off x="10571606" y="3182112"/>
-            <a:ext cx="1169288" cy="1005840"/>
+            <a:off x="10578465" y="3182112"/>
+            <a:ext cx="1189862" cy="1005840"/>
           </a:xfrm>
           <a:prstGeom prst="rect">
             <a:avLst/>
@@ -6318,20 +6318,20 @@
               </a:spcAft>
             </a:pPr>
             <a:r>
-              <a:rPr sz="800" b="1">
+              <a:rPr sz="750" b="1">
                 <a:solidFill>
                   <a:srgbClr val="1F2A44"/>
                 </a:solidFill>
-                <a:latin typeface="Calibri"/>
-              </a:rPr>
-              <a:t>▪ </a:t>
-            </a:r>
-            <a:r>
-              <a:rPr sz="800" b="0">
+                <a:latin typeface="Open Sauce Sans"/>
+              </a:rPr>
+              <a:t>• </a:t>
+            </a:r>
+            <a:r>
+              <a:rPr sz="750" b="0">
                 <a:solidFill>
                   <a:srgbClr val="1B2420"/>
                 </a:solidFill>
-                <a:latin typeface="Calibri"/>
+                <a:latin typeface="Open Sauce Sans"/>
               </a:rPr>
               <a:t>Realisasi offtake &amp; penjualan</a:t>
             </a:r>
@@ -6343,20 +6343,20 @@
               </a:spcAft>
             </a:pPr>
             <a:r>
-              <a:rPr sz="800" b="1">
+              <a:rPr sz="750" b="1">
                 <a:solidFill>
                   <a:srgbClr val="1F2A44"/>
                 </a:solidFill>
-                <a:latin typeface="Calibri"/>
-              </a:rPr>
-              <a:t>▪ </a:t>
-            </a:r>
-            <a:r>
-              <a:rPr sz="800" b="0">
+                <a:latin typeface="Open Sauce Sans"/>
+              </a:rPr>
+              <a:t>• </a:t>
+            </a:r>
+            <a:r>
+              <a:rPr sz="750" b="0">
                 <a:solidFill>
                   <a:srgbClr val="1B2420"/>
                 </a:solidFill>
-                <a:latin typeface="Calibri"/>
+                <a:latin typeface="Open Sauce Sans"/>
               </a:rPr>
               <a:t>Otorisasi/CA bila ekspor; PNBP</a:t>
             </a:r>
@@ -6368,20 +6368,20 @@
               </a:spcAft>
             </a:pPr>
             <a:r>
-              <a:rPr sz="800" b="1">
+              <a:rPr sz="750" b="1">
                 <a:solidFill>
                   <a:srgbClr val="1F2A44"/>
                 </a:solidFill>
-                <a:latin typeface="Calibri"/>
-              </a:rPr>
-              <a:t>▪ </a:t>
-            </a:r>
-            <a:r>
-              <a:rPr sz="800" b="0">
+                <a:latin typeface="Open Sauce Sans"/>
+              </a:rPr>
+              <a:t>• </a:t>
+            </a:r>
+            <a:r>
+              <a:rPr sz="750" b="0">
                 <a:solidFill>
                   <a:srgbClr val="1B2420"/>
                 </a:solidFill>
-                <a:latin typeface="Calibri"/>
+                <a:latin typeface="Open Sauce Sans"/>
               </a:rPr>
               <a:t>≥60% pendapatan ke komunitas</a:t>
             </a:r>
@@ -6396,8 +6396,8 @@
         </p:nvSpPr>
         <p:spPr>
           <a:xfrm>
-            <a:off x="10608182" y="4261104"/>
-            <a:ext cx="1114425" cy="292608"/>
+            <a:off x="10615041" y="4261104"/>
+            <a:ext cx="1134999" cy="292608"/>
           </a:xfrm>
           <a:prstGeom prst="roundRect">
             <a:avLst/>
@@ -6416,11 +6416,11 @@
           <a:p>
             <a:pPr algn="ctr"/>
             <a:r>
-              <a:rPr sz="750" b="1">
+              <a:rPr sz="700" b="1">
                 <a:solidFill>
                   <a:srgbClr val="1F2A44"/>
                 </a:solidFill>
-                <a:latin typeface="Calibri"/>
+                <a:latin typeface="Open Sauce Sans"/>
               </a:rPr>
               <a:t>→ Pendapatan &amp; manfaat</a:t>
             </a:r>
@@ -6455,7 +6455,7 @@
                 <a:solidFill>
                   <a:srgbClr val="5F6B65"/>
                 </a:solidFill>
-                <a:latin typeface="Calibri"/>
+                <a:latin typeface="Open Sauce Sans"/>
               </a:rPr>
               <a:t>DUKUNGAN</a:t>
             </a:r>
@@ -6470,8 +6470,8 @@
         </p:nvSpPr>
         <p:spPr>
           <a:xfrm>
-            <a:off x="1261872" y="4773168"/>
-            <a:ext cx="3910203" cy="292608"/>
+            <a:off x="1188720" y="4773168"/>
+            <a:ext cx="3953637" cy="292608"/>
           </a:xfrm>
           <a:prstGeom prst="rect">
             <a:avLst/>
@@ -6494,7 +6494,7 @@
                 <a:solidFill>
                   <a:srgbClr val="0E7C6B"/>
                 </a:solidFill>
-                <a:latin typeface="Calibri"/>
+                <a:latin typeface="Open Sauce Sans"/>
               </a:rPr>
               <a:t>TAF · SETAPAK 4 — SAMPAN Kalimantan &amp; LPHD Pasir</a:t>
             </a:r>
@@ -6509,8 +6509,8 @@
         </p:nvSpPr>
         <p:spPr>
           <a:xfrm>
-            <a:off x="5236082" y="4773168"/>
-            <a:ext cx="6559676" cy="292608"/>
+            <a:off x="5197221" y="4773168"/>
+            <a:ext cx="6625971" cy="292608"/>
           </a:xfrm>
           <a:prstGeom prst="rect">
             <a:avLst/>
@@ -6533,7 +6533,7 @@
                 <a:solidFill>
                   <a:srgbClr val="1F2A44"/>
                 </a:solidFill>
-                <a:latin typeface="Calibri"/>
+                <a:latin typeface="Open Sauce Sans"/>
               </a:rPr>
               <a:t>Investor / offtaker (pre-financing, presale berjangka) + pendanaan lanjutan  →  pendapatan karbon</a:t>
             </a:r>
@@ -6568,7 +6568,7 @@
                 <a:solidFill>
                   <a:srgbClr val="5F6B65"/>
                 </a:solidFill>
-                <a:latin typeface="Calibri"/>
+                <a:latin typeface="Open Sauce Sans"/>
               </a:rPr>
               <a:t>UNIT KARBON</a:t>
             </a:r>
@@ -6583,8 +6583,8 @@
         </p:nvSpPr>
         <p:spPr>
           <a:xfrm>
-            <a:off x="1261872" y="5138928"/>
-            <a:ext cx="5234940" cy="292608"/>
+            <a:off x="1188720" y="5138928"/>
+            <a:ext cx="5289804" cy="292608"/>
           </a:xfrm>
           <a:prstGeom prst="rect">
             <a:avLst/>
@@ -6607,7 +6607,7 @@
                 <a:solidFill>
                   <a:srgbClr val="5F6B65"/>
                 </a:solidFill>
-                <a:latin typeface="Calibri"/>
+                <a:latin typeface="Open Sauce Sans"/>
               </a:rPr>
               <a:t>Belum ada kredit — pipeline ≠ registrasi ≠ issuance</a:t>
             </a:r>
@@ -6622,8 +6622,8 @@
         </p:nvSpPr>
         <p:spPr>
           <a:xfrm>
-            <a:off x="6560820" y="5138928"/>
-            <a:ext cx="1260729" cy="292608"/>
+            <a:off x="6533388" y="5138928"/>
+            <a:ext cx="1281303" cy="292608"/>
           </a:xfrm>
           <a:prstGeom prst="rect">
             <a:avLst/>
@@ -6646,7 +6646,7 @@
                 <a:solidFill>
                   <a:srgbClr val="1F2A44"/>
                 </a:solidFill>
-                <a:latin typeface="Calibri"/>
+                <a:latin typeface="Open Sauce Sans"/>
               </a:rPr>
               <a:t>fPVC (restorasi)</a:t>
             </a:r>
@@ -6661,8 +6661,8 @@
         </p:nvSpPr>
         <p:spPr>
           <a:xfrm>
-            <a:off x="7885557" y="5138928"/>
-            <a:ext cx="1260729" cy="292608"/>
+            <a:off x="7869554" y="5138928"/>
+            <a:ext cx="1281303" cy="292608"/>
           </a:xfrm>
           <a:prstGeom prst="rect">
             <a:avLst/>
@@ -6685,7 +6685,7 @@
                 <a:solidFill>
                   <a:srgbClr val="1F2A44"/>
                 </a:solidFill>
-                <a:latin typeface="Calibri"/>
+                <a:latin typeface="Open Sauce Sans"/>
               </a:rPr>
               <a:t>rPVC (Annual Report)</a:t>
             </a:r>
@@ -6700,8 +6700,8 @@
         </p:nvSpPr>
         <p:spPr>
           <a:xfrm>
-            <a:off x="9210293" y="5138928"/>
-            <a:ext cx="1260729" cy="292608"/>
+            <a:off x="9205722" y="5138928"/>
+            <a:ext cx="1281303" cy="292608"/>
           </a:xfrm>
           <a:prstGeom prst="rect">
             <a:avLst/>
@@ -6724,7 +6724,7 @@
                 <a:solidFill>
                   <a:srgbClr val="FFFFFF"/>
                 </a:solidFill>
-                <a:latin typeface="Calibri"/>
+                <a:latin typeface="Open Sauce Sans"/>
               </a:rPr>
               <a:t>vPVC ✓ dapat di-retire</a:t>
             </a:r>
@@ -6739,8 +6739,8 @@
         </p:nvSpPr>
         <p:spPr>
           <a:xfrm>
-            <a:off x="10535030" y="5138928"/>
-            <a:ext cx="1260729" cy="292608"/>
+            <a:off x="10541889" y="5138928"/>
+            <a:ext cx="1281303" cy="292608"/>
           </a:xfrm>
           <a:prstGeom prst="rect">
             <a:avLst/>
@@ -6763,7 +6763,7 @@
                 <a:solidFill>
                   <a:srgbClr val="FFFFFF"/>
                 </a:solidFill>
-                <a:latin typeface="Calibri"/>
+                <a:latin typeface="Open Sauce Sans"/>
               </a:rPr>
               <a:t>Dijual / diserahkan</a:t>
             </a:r>
@@ -6833,7 +6833,7 @@
                 <a:solidFill>
                   <a:srgbClr val="0E7C6B"/>
                 </a:solidFill>
-                <a:latin typeface="Cambria"/>
+                <a:latin typeface="Open Sauce Sans"/>
               </a:rPr>
               <a:t>Mei 2027</a:t>
             </a:r>
@@ -6864,11 +6864,11 @@
           <a:p>
             <a:pPr algn="l"/>
             <a:r>
-              <a:rPr sz="850" b="0" i="0">
+              <a:rPr sz="800" b="0" i="0">
                 <a:solidFill>
                   <a:srgbClr val="1B2420"/>
                 </a:solidFill>
-                <a:latin typeface="Calibri"/>
+                <a:latin typeface="Open Sauce Sans"/>
               </a:rPr>
               <a:t>PIN diajukan ke Plan Vivo</a:t>
             </a:r>
@@ -6903,7 +6903,7 @@
                 <a:solidFill>
                   <a:srgbClr val="0E7C6B"/>
                 </a:solidFill>
-                <a:latin typeface="Cambria"/>
+                <a:latin typeface="Open Sauce Sans"/>
               </a:rPr>
               <a:t>Sep 2027</a:t>
             </a:r>
@@ -6934,13 +6934,13 @@
           <a:p>
             <a:pPr algn="l"/>
             <a:r>
-              <a:rPr sz="850" b="0" i="0">
+              <a:rPr sz="800" b="0" i="0">
                 <a:solidFill>
                   <a:srgbClr val="1B2420"/>
                 </a:solidFill>
-                <a:latin typeface="Calibri"/>
-              </a:rPr>
-              <a:t>Masuk Pipeline PV — output utama SETAPAK 4</a:t>
+                <a:latin typeface="Open Sauce Sans"/>
+              </a:rPr>
+              <a:t>Masuk Pipeline PV · output utama</a:t>
             </a:r>
           </a:p>
         </p:txBody>
@@ -6973,7 +6973,7 @@
                 <a:solidFill>
                   <a:srgbClr val="1F2A44"/>
                 </a:solidFill>
-                <a:latin typeface="Cambria"/>
+                <a:latin typeface="Open Sauce Sans"/>
               </a:rPr>
               <a:t>≤ 3 tahun</a:t>
             </a:r>
@@ -7004,11 +7004,11 @@
           <a:p>
             <a:pPr algn="l"/>
             <a:r>
-              <a:rPr sz="850" b="0" i="0">
+              <a:rPr sz="800" b="0" i="0">
                 <a:solidFill>
                   <a:srgbClr val="1B2420"/>
                 </a:solidFill>
-                <a:latin typeface="Calibri"/>
+                <a:latin typeface="Open Sauce Sans"/>
               </a:rPr>
               <a:t>PDD wajib diajukan sejak PIN disetujui</a:t>
             </a:r>
@@ -7043,7 +7043,7 @@
                 <a:solidFill>
                   <a:srgbClr val="1F2A44"/>
                 </a:solidFill>
-                <a:latin typeface="Cambria"/>
+                <a:latin typeface="Open Sauce Sans"/>
               </a:rPr>
               <a:t>≥ 60%</a:t>
             </a:r>
@@ -7074,11 +7074,11 @@
           <a:p>
             <a:pPr algn="l"/>
             <a:r>
-              <a:rPr sz="850" b="0" i="0">
+              <a:rPr sz="800" b="0" i="0">
                 <a:solidFill>
                   <a:srgbClr val="1B2420"/>
                 </a:solidFill>
-                <a:latin typeface="Calibri"/>
+                <a:latin typeface="Open Sauce Sans"/>
               </a:rPr>
               <a:t>pendapatan PVC untuk komunitas</a:t>
             </a:r>
@@ -7143,7 +7143,7 @@
                 <a:solidFill>
                   <a:srgbClr val="5F6B65"/>
                 </a:solidFill>
-                <a:latin typeface="Calibri"/>
+                <a:latin typeface="Open Sauce Sans"/>
               </a:rPr>
               <a:t>Dikerjakan tim</a:t>
             </a:r>
@@ -7210,7 +7210,7 @@
                 <a:solidFill>
                   <a:srgbClr val="5F6B65"/>
                 </a:solidFill>
-                <a:latin typeface="Calibri"/>
+                <a:latin typeface="Open Sauce Sans"/>
               </a:rPr>
               <a:t>Keputusan pihak luar</a:t>
             </a:r>
@@ -7281,7 +7281,7 @@
                 <a:solidFill>
                   <a:srgbClr val="5F6B65"/>
                 </a:solidFill>
-                <a:latin typeface="Calibri"/>
+                <a:latin typeface="Open Sauce Sans"/>
               </a:rPr>
               <a:t>Batas SETAPAK 4</a:t>
             </a:r>
@@ -7316,7 +7316,7 @@
                 <a:solidFill>
                   <a:srgbClr val="5F6B65"/>
                 </a:solidFill>
-                <a:latin typeface="Calibri"/>
+                <a:latin typeface="Open Sauce Sans"/>
               </a:rPr>
               <a:t>Sumber: Plan Vivo PV Climate Procedures Manual V3.9 &amp; Project Requirements V5.7; Permenhut 6/2026. Tanggal keputusan Plan Vivo, VVB dan Menteri bersifat indikatif. Presale = kontrak berjangka; unit diserahkan setelah terbit.</a:t>
             </a:r>

</xml_diff>

<commit_message>
Remove dates from one-slide roadmap
Co-Authored-By: Claude Opus 5.5 <noreply@anthropic.com>
Claude-Session: https://claude.ai/code/session_01Tt9bQwcKRKX4vaP5NybJqL
</commit_message>
<xml_diff>
--- a/hutan-desa-pasir/Roadmap_1Slide_HD_Pasir.pptx
+++ b/hutan-desa-pasir/Roadmap_1Slide_HD_Pasir.pptx
@@ -502,7 +502,7 @@
           <a:lstStyle/>
           <a:p>
             <a:r>
-              <a:t>Alur: Tahap 1–3 adalah cakupan program SETAPAK 4 yang didanai TAF sampai September 2027. Output utamanya Tahap 3: PIN disetujui dan proyek masuk pipeline Plan Vivo. Pipeline belum berarti registrasi atau kredit. Garis gerbang setelah Tahap 3 menandai akhir SETAPAK 4. Dengan status pipeline, proyek mencari investor atau pembeli untuk pre-financing/offtake berjangka yang membiayai PDD dan validasi (Tahap 4 dst.). Kredit baru muncul setelah registrasi (fPVC untuk restorasi, rPVC dari Annual Report) dan yang dapat di-retire hanya vPVC setelah verifikasi. Minimal 60% pendapatan dari penjualan untuk peserta dan pihak lokal.</a:t>
+              <a:t>Alur: Tahap 1–3 adalah cakupan program SETAPAK 4 yang didanai TAF. Output utamanya Tahap 3: PIN disetujui dan proyek masuk pipeline Plan Vivo. Pipeline belum berarti registrasi atau kredit. Garis gerbang setelah Tahap 3 menandai akhir SETAPAK 4. Dengan status pipeline, proyek mencari investor atau pembeli untuk pre-financing/offtake berjangka yang membiayai PDD dan validasi (Tahap 4 dst.). Kredit baru muncul setelah registrasi (fPVC untuk restorasi, rPVC dari Annual Report) dan yang dapat di-retire hanya vPVC setelah verifikasi. Minimal 60% pendapatan dari penjualan untuk peserta dan pihak lokal.</a:t>
             </a:r>
           </a:p>
         </p:txBody>
@@ -3654,7 +3654,7 @@
                 </a:solidFill>
                 <a:latin typeface="Open Sauce Sans"/>
               </a:rPr>
-              <a:t>STEP 1 · PROGRAM SETAPAK 4 (TAF) · Okt 2026 – Sep 2027</a:t>
+              <a:t>STEP 1 · PROGRAM SETAPAK 4 (TAF)</a:t>
             </a:r>
           </a:p>
         </p:txBody>
@@ -3693,7 +3693,7 @@
                 </a:solidFill>
                 <a:latin typeface="Open Sauce Sans"/>
               </a:rPr>
-              <a:t>STEP 2 · PENGEMBANGAN LANJUTAN (PASCA-SETAPAK 4) · Okt 2027 →</a:t>
+              <a:t>STEP 2 · PENGEMBANGAN LANJUTAN (PASCA-SETAPAK 4) →</a:t>
             </a:r>
           </a:p>
         </p:txBody>
@@ -4040,7 +4040,7 @@
                 </a:solidFill>
                 <a:latin typeface="Open Sauce Sans"/>
               </a:rPr>
-              <a:t>Okt 26–Apr 27 · M1–M5</a:t>
+              <a:t>M1–M5</a:t>
             </a:r>
           </a:p>
         </p:txBody>
@@ -4350,7 +4350,7 @@
                 </a:solidFill>
                 <a:latin typeface="Open Sauce Sans"/>
               </a:rPr>
-              <a:t>Mar–Sep 27 · M6–M7</a:t>
+              <a:t>M6–M7</a:t>
             </a:r>
           </a:p>
         </p:txBody>
@@ -4423,7 +4423,7 @@
                 </a:solidFill>
                 <a:latin typeface="Open Sauce Sans"/>
               </a:rPr>
-              <a:t>Submit ≤ Mei 2027</a:t>
+              <a:t>Submit + PIN review fee</a:t>
             </a:r>
           </a:p>
           <a:p>
@@ -4741,7 +4741,7 @@
                 </a:solidFill>
                 <a:latin typeface="Open Sauce Sans"/>
               </a:rPr>
-              <a:t>Sep 2027 · M7.5 · M8</a:t>
+              <a:t>M7.5 · M8</a:t>
             </a:r>
           </a:p>
         </p:txBody>
@@ -5049,7 +5049,7 @@
                 </a:solidFill>
                 <a:latin typeface="Open Sauce Sans"/>
               </a:rPr>
-              <a:t>2027 – 2029 · M9</a:t>
+              <a:t>M9</a:t>
             </a:r>
           </a:p>
         </p:txBody>
@@ -5359,7 +5359,7 @@
                 </a:solidFill>
                 <a:latin typeface="Open Sauce Sans"/>
               </a:rPr>
-              <a:t>2029 – 2030 · M10</a:t>
+              <a:t>M10</a:t>
             </a:r>
           </a:p>
         </p:txBody>
@@ -5667,7 +5667,7 @@
                 </a:solidFill>
                 <a:latin typeface="Open Sauce Sans"/>
               </a:rPr>
-              <a:t>2030 → · M11</a:t>
+              <a:t>M11</a:t>
             </a:r>
           </a:p>
         </p:txBody>
@@ -5977,7 +5977,7 @@
                 </a:solidFill>
                 <a:latin typeface="Open Sauce Sans"/>
               </a:rPr>
-              <a:t>≤5 th pasca-validasi · M12</a:t>
+              <a:t>M12</a:t>
             </a:r>
           </a:p>
         </p:txBody>
@@ -6285,7 +6285,7 @@
                 </a:solidFill>
                 <a:latin typeface="Open Sauce Sans"/>
               </a:rPr>
-              <a:t>setelah issuance · M13</a:t>
+              <a:t>M13</a:t>
             </a:r>
           </a:p>
         </p:txBody>
@@ -6835,7 +6835,7 @@
                 </a:solidFill>
                 <a:latin typeface="Open Sauce Sans"/>
               </a:rPr>
-              <a:t>Mei 2027</a:t>
+              <a:t>Pipeline PV</a:t>
             </a:r>
           </a:p>
         </p:txBody>
@@ -6870,7 +6870,7 @@
                 </a:solidFill>
                 <a:latin typeface="Open Sauce Sans"/>
               </a:rPr>
-              <a:t>PIN diajukan ke Plan Vivo</a:t>
+              <a:t>Output utama SETAPAK 4</a:t>
             </a:r>
           </a:p>
         </p:txBody>
@@ -6901,11 +6901,11 @@
             <a:r>
               <a:rPr sz="2000" b="1" i="0">
                 <a:solidFill>
-                  <a:srgbClr val="0E7C6B"/>
-                </a:solidFill>
-                <a:latin typeface="Open Sauce Sans"/>
-              </a:rPr>
-              <a:t>Sep 2027</a:t>
+                  <a:srgbClr val="1F2A44"/>
+                </a:solidFill>
+                <a:latin typeface="Open Sauce Sans"/>
+              </a:rPr>
+              <a:t>≤ 3 tahun</a:t>
             </a:r>
           </a:p>
         </p:txBody>
@@ -6940,7 +6940,7 @@
                 </a:solidFill>
                 <a:latin typeface="Open Sauce Sans"/>
               </a:rPr>
-              <a:t>Masuk Pipeline PV · output utama</a:t>
+              <a:t>PDD wajib diajukan sejak PIN disetujui</a:t>
             </a:r>
           </a:p>
         </p:txBody>
@@ -6975,7 +6975,7 @@
                 </a:solidFill>
                 <a:latin typeface="Open Sauce Sans"/>
               </a:rPr>
-              <a:t>≤ 3 tahun</a:t>
+              <a:t>≤ 5 tahun</a:t>
             </a:r>
           </a:p>
         </p:txBody>
@@ -7010,7 +7010,7 @@
                 </a:solidFill>
                 <a:latin typeface="Open Sauce Sans"/>
               </a:rPr>
-              <a:t>PDD wajib diajukan sejak PIN disetujui</a:t>
+              <a:t>Verifikasi pertama setelah validasi</a:t>
             </a:r>
           </a:p>
         </p:txBody>
@@ -7318,7 +7318,7 @@
                 </a:solidFill>
                 <a:latin typeface="Open Sauce Sans"/>
               </a:rPr>
-              <a:t>Sumber: Plan Vivo PV Climate Procedures Manual V3.9 &amp; Project Requirements V5.7; Permenhut 6/2026. Tanggal keputusan Plan Vivo, VVB dan Menteri bersifat indikatif. Presale = kontrak berjangka; unit diserahkan setelah terbit.</a:t>
+              <a:t>Sumber: Plan Vivo PV Climate Procedures Manual V3.9 &amp; Project Requirements V5.7; Permenhut 6/2026. Keputusan Plan Vivo, VVB dan Menteri berada di luar kendali proyek. Presale = kontrak berjangka; unit diserahkan setelah terbit.</a:t>
             </a:r>
           </a:p>
         </p:txBody>

</xml_diff>